<commit_message>
Fix notebook hang: EKS access for notebook role + kubectl timeouts
Root cause of stuck cell 5: SageMaker notebook IAM role was not in EKS
access entries, so kubectl calls hung (no timeout on subprocess.run).

Fixes:
- deploy/60-grant-notebook-eks-access.sh: grants notebook role EKS admin access
- notebook: run_kubectl() helper with timeout + error output (never hangs)
- notebook: connectivity check in Setup cell, all subprocess calls have timeouts
- Updated PPTX architecture diagram (L-shaped Prometheus->AMP arrow, larger fonts)
</commit_message>
<xml_diff>
--- a/docs/diagrams/5g-rcf-architecture-guidance.pptx
+++ b/docs/diagrams/5g-rcf-architecture-guidance.pptx
@@ -876,8 +876,8 @@
         </p:nvSpPr>
         <p:spPr>
           <a:xfrm>
-            <a:off x="274320" y="182880"/>
-            <a:ext cx="8229600" cy="365760"/>
+            <a:off x="274320" y="91440"/>
+            <a:ext cx="7772400" cy="320040"/>
           </a:xfrm>
           <a:prstGeom prst="rect">
             <a:avLst/>
@@ -915,8 +915,8 @@
         </p:nvSpPr>
         <p:spPr>
           <a:xfrm>
-            <a:off x="274320" y="502920"/>
-            <a:ext cx="8229600" cy="320040"/>
+            <a:off x="274320" y="411480"/>
+            <a:ext cx="7772400" cy="228600"/>
           </a:xfrm>
           <a:prstGeom prst="rect">
             <a:avLst/>
@@ -940,7 +940,7 @@
                 <a:ea typeface="Arial" pitchFamily="34" charset="-122"/>
                 <a:cs typeface="Arial" pitchFamily="34" charset="-120"/>
               </a:rPr>
-              <a:t>Detecting infrastructure faults impacting 5G subscribers with Amazon Managed Prometheus</a:t>
+              <a:t>This architecture shows how Amazon Managed Prometheus with Random Cut Forest detects 5G subscriber anomalies caused by infrastructure faults on Amazon EKS.</a:t>
             </a:r>
             <a:endParaRPr lang="en-US" sz="900" dirty="0"/>
           </a:p>
@@ -954,8 +954,8 @@
         </p:nvSpPr>
         <p:spPr>
           <a:xfrm>
-            <a:off x="274320" y="868680"/>
-            <a:ext cx="11612880" cy="0"/>
+            <a:off x="182880" y="685800"/>
+            <a:ext cx="11795760" cy="0"/>
           </a:xfrm>
           <a:prstGeom prst="line">
             <a:avLst/>
@@ -977,18 +977,18 @@
         </p:nvSpPr>
         <p:spPr>
           <a:xfrm>
-            <a:off x="8503920" y="1005840"/>
-            <a:ext cx="3383280" cy="5486400"/>
-          </a:xfrm>
-          <a:prstGeom prst="rect">
-            <a:avLst/>
-          </a:prstGeom>
-          <a:solidFill>
-            <a:srgbClr val="F2F2F2"/>
+            <a:off x="8092440" y="731520"/>
+            <a:ext cx="3886200" cy="5943600"/>
+          </a:xfrm>
+          <a:prstGeom prst="rect">
+            <a:avLst/>
+          </a:prstGeom>
+          <a:solidFill>
+            <a:srgbClr val="F5F5F5"/>
           </a:solidFill>
           <a:ln w="6350">
             <a:solidFill>
-              <a:srgbClr val="DDDDDD"/>
+              <a:srgbClr val="E0E0E0"/>
             </a:solidFill>
             <a:prstDash val="solid"/>
           </a:ln>
@@ -1002,8 +1002,8 @@
         </p:nvSpPr>
         <p:spPr>
           <a:xfrm>
-            <a:off x="8595360" y="1143000"/>
-            <a:ext cx="228600" cy="228600"/>
+            <a:off x="8202168" y="932688"/>
+            <a:ext cx="219456" cy="219456"/>
           </a:xfrm>
           <a:prstGeom prst="ellipse">
             <a:avLst/>
@@ -1021,7 +1021,7 @@
               <a:buNone/>
             </a:pPr>
             <a:r>
-              <a:rPr lang="en-US" sz="800" b="1" dirty="0">
+              <a:rPr lang="en-US" sz="900" b="1" dirty="0">
                 <a:solidFill>
                   <a:srgbClr val="FFFFFF"/>
                 </a:solidFill>
@@ -1031,7 +1031,7 @@
               </a:rPr>
               <a:t>1</a:t>
             </a:r>
-            <a:endParaRPr lang="en-US" sz="800" dirty="0"/>
+            <a:endParaRPr lang="en-US" sz="900" dirty="0"/>
           </a:p>
         </p:txBody>
       </p:sp>
@@ -1043,8 +1043,8 @@
         </p:nvSpPr>
         <p:spPr>
           <a:xfrm>
-            <a:off x="8869680" y="1143000"/>
-            <a:ext cx="2880360" cy="621792"/>
+            <a:off x="8494776" y="841248"/>
+            <a:ext cx="3291840" cy="676656"/>
           </a:xfrm>
           <a:prstGeom prst="rect">
             <a:avLst/>
@@ -1060,7 +1060,7 @@
               <a:buNone/>
             </a:pPr>
             <a:r>
-              <a:rPr lang="en-US" sz="750" dirty="0">
+              <a:rPr lang="en-US" sz="900" dirty="0">
                 <a:solidFill>
                   <a:srgbClr val="232F3E"/>
                 </a:solidFill>
@@ -1068,9 +1068,9 @@
                 <a:ea typeface="Arial" pitchFamily="34" charset="-122"/>
                 <a:cs typeface="Arial" pitchFamily="34" charset="-120"/>
               </a:rPr>
-              <a:t>UERANSIM simulates 100 5G UEs across 4 gNodeBs connecting via NGAP to 2 AMFs partitioned by Tracking Area Code.</a:t>
-            </a:r>
-            <a:endParaRPr lang="en-US" sz="750" dirty="0"/>
+              <a:t>100 UEs (UERANSIM) connect via 4 gNodeBs to 2 AMFs partitioned by Tracking Area Code.</a:t>
+            </a:r>
+            <a:endParaRPr lang="en-US" sz="900" dirty="0"/>
           </a:p>
         </p:txBody>
       </p:sp>
@@ -1082,8 +1082,8 @@
         </p:nvSpPr>
         <p:spPr>
           <a:xfrm>
-            <a:off x="8595360" y="1801368"/>
-            <a:ext cx="228600" cy="228600"/>
+            <a:off x="8202168" y="1655064"/>
+            <a:ext cx="219456" cy="219456"/>
           </a:xfrm>
           <a:prstGeom prst="ellipse">
             <a:avLst/>
@@ -1101,7 +1101,7 @@
               <a:buNone/>
             </a:pPr>
             <a:r>
-              <a:rPr lang="en-US" sz="800" b="1" dirty="0">
+              <a:rPr lang="en-US" sz="900" b="1" dirty="0">
                 <a:solidFill>
                   <a:srgbClr val="FFFFFF"/>
                 </a:solidFill>
@@ -1111,7 +1111,7 @@
               </a:rPr>
               <a:t>2</a:t>
             </a:r>
-            <a:endParaRPr lang="en-US" sz="800" dirty="0"/>
+            <a:endParaRPr lang="en-US" sz="900" dirty="0"/>
           </a:p>
         </p:txBody>
       </p:sp>
@@ -1123,8 +1123,8 @@
         </p:nvSpPr>
         <p:spPr>
           <a:xfrm>
-            <a:off x="8869680" y="1801368"/>
-            <a:ext cx="2880360" cy="621792"/>
+            <a:off x="8494776" y="1563624"/>
+            <a:ext cx="3291840" cy="676656"/>
           </a:xfrm>
           <a:prstGeom prst="rect">
             <a:avLst/>
@@ -1140,7 +1140,7 @@
               <a:buNone/>
             </a:pPr>
             <a:r>
-              <a:rPr lang="en-US" sz="750" dirty="0">
+              <a:rPr lang="en-US" sz="900" dirty="0">
                 <a:solidFill>
                   <a:srgbClr val="232F3E"/>
                 </a:solidFill>
@@ -1148,9 +1148,9 @@
                 <a:ea typeface="Arial" pitchFamily="34" charset="-122"/>
                 <a:cs typeface="Arial" pitchFamily="34" charset="-120"/>
               </a:rPr>
-              <a:t>open5gs 5G Core (AMF, SMF, UPF) runs on Amazon EKS. AMF handles registration; SMF manages PDU sessions via PFCP to UPF.</a:t>
-            </a:r>
-            <a:endParaRPr lang="en-US" sz="750" dirty="0"/>
+              <a:t>open5gs 5G Core on Amazon EKS: AMF registration, SMF session management, 4 UPF instances.</a:t>
+            </a:r>
+            <a:endParaRPr lang="en-US" sz="900" dirty="0"/>
           </a:p>
         </p:txBody>
       </p:sp>
@@ -1162,8 +1162,8 @@
         </p:nvSpPr>
         <p:spPr>
           <a:xfrm>
-            <a:off x="8595360" y="2459736"/>
-            <a:ext cx="228600" cy="228600"/>
+            <a:off x="8202168" y="2377440"/>
+            <a:ext cx="219456" cy="219456"/>
           </a:xfrm>
           <a:prstGeom prst="ellipse">
             <a:avLst/>
@@ -1181,7 +1181,7 @@
               <a:buNone/>
             </a:pPr>
             <a:r>
-              <a:rPr lang="en-US" sz="800" b="1" dirty="0">
+              <a:rPr lang="en-US" sz="900" b="1" dirty="0">
                 <a:solidFill>
                   <a:srgbClr val="FFFFFF"/>
                 </a:solidFill>
@@ -1191,7 +1191,7 @@
               </a:rPr>
               <a:t>3</a:t>
             </a:r>
-            <a:endParaRPr lang="en-US" sz="800" dirty="0"/>
+            <a:endParaRPr lang="en-US" sz="900" dirty="0"/>
           </a:p>
         </p:txBody>
       </p:sp>
@@ -1203,8 +1203,8 @@
         </p:nvSpPr>
         <p:spPr>
           <a:xfrm>
-            <a:off x="8869680" y="2459736"/>
-            <a:ext cx="2880360" cy="621792"/>
+            <a:off x="8494776" y="2286000"/>
+            <a:ext cx="3291840" cy="676656"/>
           </a:xfrm>
           <a:prstGeom prst="rect">
             <a:avLst/>
@@ -1220,7 +1220,7 @@
               <a:buNone/>
             </a:pPr>
             <a:r>
-              <a:rPr lang="en-US" sz="750" dirty="0">
+              <a:rPr lang="en-US" sz="900" dirty="0">
                 <a:solidFill>
                   <a:srgbClr val="232F3E"/>
                 </a:solidFill>
@@ -1228,9 +1228,9 @@
                 <a:ea typeface="Arial" pitchFamily="34" charset="-122"/>
                 <a:cs typeface="Arial" pitchFamily="34" charset="-120"/>
               </a:rPr>
-              <a:t>kube-prometheus-stack scrapes /metrics from all NFs every 15s using fallback_scrape_protocol for open5gs compatibility.</a:t>
-            </a:r>
-            <a:endParaRPr lang="en-US" sz="750" dirty="0"/>
+              <a:t>Prometheus scrapes NF metrics (/metrics:9090) every 15s with fallback scrape protocol.</a:t>
+            </a:r>
+            <a:endParaRPr lang="en-US" sz="900" dirty="0"/>
           </a:p>
         </p:txBody>
       </p:sp>
@@ -1242,8 +1242,8 @@
         </p:nvSpPr>
         <p:spPr>
           <a:xfrm>
-            <a:off x="8595360" y="3118104"/>
-            <a:ext cx="228600" cy="228600"/>
+            <a:off x="8202168" y="3099816"/>
+            <a:ext cx="219456" cy="219456"/>
           </a:xfrm>
           <a:prstGeom prst="ellipse">
             <a:avLst/>
@@ -1261,7 +1261,7 @@
               <a:buNone/>
             </a:pPr>
             <a:r>
-              <a:rPr lang="en-US" sz="800" b="1" dirty="0">
+              <a:rPr lang="en-US" sz="900" b="1" dirty="0">
                 <a:solidFill>
                   <a:srgbClr val="FFFFFF"/>
                 </a:solidFill>
@@ -1271,7 +1271,7 @@
               </a:rPr>
               <a:t>4</a:t>
             </a:r>
-            <a:endParaRPr lang="en-US" sz="800" dirty="0"/>
+            <a:endParaRPr lang="en-US" sz="900" dirty="0"/>
           </a:p>
         </p:txBody>
       </p:sp>
@@ -1283,8 +1283,8 @@
         </p:nvSpPr>
         <p:spPr>
           <a:xfrm>
-            <a:off x="8869680" y="3118104"/>
-            <a:ext cx="2880360" cy="621792"/>
+            <a:off x="8494776" y="3008376"/>
+            <a:ext cx="3291840" cy="676656"/>
           </a:xfrm>
           <a:prstGeom prst="rect">
             <a:avLst/>
@@ -1300,7 +1300,7 @@
               <a:buNone/>
             </a:pPr>
             <a:r>
-              <a:rPr lang="en-US" sz="750" dirty="0">
+              <a:rPr lang="en-US" sz="900" dirty="0">
                 <a:solidFill>
                   <a:srgbClr val="232F3E"/>
                 </a:solidFill>
@@ -1308,9 +1308,9 @@
                 <a:ea typeface="Arial" pitchFamily="34" charset="-122"/>
                 <a:cs typeface="Arial" pitchFamily="34" charset="-120"/>
               </a:rPr>
-              <a:t>Prometheus remote_writes metrics to Amazon Managed Service for Prometheus using SigV4 authentication via IRSA.</a:t>
-            </a:r>
-            <a:endParaRPr lang="en-US" sz="750" dirty="0"/>
+              <a:t>Prometheus remote_writes to Amazon Managed Service for Prometheus via SigV4 (IRSA).</a:t>
+            </a:r>
+            <a:endParaRPr lang="en-US" sz="900" dirty="0"/>
           </a:p>
         </p:txBody>
       </p:sp>
@@ -1322,8 +1322,8 @@
         </p:nvSpPr>
         <p:spPr>
           <a:xfrm>
-            <a:off x="8595360" y="3776472"/>
-            <a:ext cx="228600" cy="228600"/>
+            <a:off x="8202168" y="3822192"/>
+            <a:ext cx="219456" cy="219456"/>
           </a:xfrm>
           <a:prstGeom prst="ellipse">
             <a:avLst/>
@@ -1341,7 +1341,7 @@
               <a:buNone/>
             </a:pPr>
             <a:r>
-              <a:rPr lang="en-US" sz="800" b="1" dirty="0">
+              <a:rPr lang="en-US" sz="900" b="1" dirty="0">
                 <a:solidFill>
                   <a:srgbClr val="FFFFFF"/>
                 </a:solidFill>
@@ -1351,7 +1351,7 @@
               </a:rPr>
               <a:t>5</a:t>
             </a:r>
-            <a:endParaRPr lang="en-US" sz="800" dirty="0"/>
+            <a:endParaRPr lang="en-US" sz="900" dirty="0"/>
           </a:p>
         </p:txBody>
       </p:sp>
@@ -1363,8 +1363,8 @@
         </p:nvSpPr>
         <p:spPr>
           <a:xfrm>
-            <a:off x="8869680" y="3776472"/>
-            <a:ext cx="2880360" cy="621792"/>
+            <a:off x="8494776" y="3730752"/>
+            <a:ext cx="3291840" cy="676656"/>
           </a:xfrm>
           <a:prstGeom prst="rect">
             <a:avLst/>
@@ -1380,7 +1380,7 @@
               <a:buNone/>
             </a:pPr>
             <a:r>
-              <a:rPr lang="en-US" sz="750" dirty="0">
+              <a:rPr lang="en-US" sz="900" dirty="0">
                 <a:solidFill>
                   <a:srgbClr val="232F3E"/>
                 </a:solidFill>
@@ -1388,9 +1388,9 @@
                 <a:ea typeface="Arial" pitchFamily="34" charset="-122"/>
                 <a:cs typeface="Arial" pitchFamily="34" charset="-120"/>
               </a:rPr>
-              <a:t>RCF anomaly detector evaluates sum(registeredsubnbr) every 30s, learning baseline and publishing score/band metrics.</a:t>
-            </a:r>
-            <a:endParaRPr lang="en-US" sz="750" dirty="0"/>
+              <a:t>RCF anomaly detector evaluates sum(registeredsubnbr) every 30s; publishes score and bands.</a:t>
+            </a:r>
+            <a:endParaRPr lang="en-US" sz="900" dirty="0"/>
           </a:p>
         </p:txBody>
       </p:sp>
@@ -1402,8 +1402,8 @@
         </p:nvSpPr>
         <p:spPr>
           <a:xfrm>
-            <a:off x="8595360" y="4434840"/>
-            <a:ext cx="228600" cy="228600"/>
+            <a:off x="8202168" y="4544568"/>
+            <a:ext cx="219456" cy="219456"/>
           </a:xfrm>
           <a:prstGeom prst="ellipse">
             <a:avLst/>
@@ -1421,7 +1421,7 @@
               <a:buNone/>
             </a:pPr>
             <a:r>
-              <a:rPr lang="en-US" sz="800" b="1" dirty="0">
+              <a:rPr lang="en-US" sz="900" b="1" dirty="0">
                 <a:solidFill>
                   <a:srgbClr val="FFFFFF"/>
                 </a:solidFill>
@@ -1431,7 +1431,7 @@
               </a:rPr>
               <a:t>6</a:t>
             </a:r>
-            <a:endParaRPr lang="en-US" sz="800" dirty="0"/>
+            <a:endParaRPr lang="en-US" sz="900" dirty="0"/>
           </a:p>
         </p:txBody>
       </p:sp>
@@ -1443,8 +1443,8 @@
         </p:nvSpPr>
         <p:spPr>
           <a:xfrm>
-            <a:off x="8869680" y="4434840"/>
-            <a:ext cx="2880360" cy="621792"/>
+            <a:off x="8494776" y="4453128"/>
+            <a:ext cx="3291840" cy="676656"/>
           </a:xfrm>
           <a:prstGeom prst="rect">
             <a:avLst/>
@@ -1460,7 +1460,7 @@
               <a:buNone/>
             </a:pPr>
             <a:r>
-              <a:rPr lang="en-US" sz="750" dirty="0">
+              <a:rPr lang="en-US" sz="900" dirty="0">
                 <a:solidFill>
                   <a:srgbClr val="232F3E"/>
                 </a:solidFill>
@@ -1468,9 +1468,9 @@
                 <a:ea typeface="Arial" pitchFamily="34" charset="-122"/>
                 <a:cs typeface="Arial" pitchFamily="34" charset="-120"/>
               </a:rPr>
-              <a:t>Alert rule fires when anomaly_detector:score exceeds 0.1 with zero duration (onset detection).</a:t>
-            </a:r>
-            <a:endParaRPr lang="en-US" sz="750" dirty="0"/>
+              <a:t>Alert rule fires instantly (for: 0s) when anomaly_detector:score exceeds 0.1.</a:t>
+            </a:r>
+            <a:endParaRPr lang="en-US" sz="900" dirty="0"/>
           </a:p>
         </p:txBody>
       </p:sp>
@@ -1482,8 +1482,8 @@
         </p:nvSpPr>
         <p:spPr>
           <a:xfrm>
-            <a:off x="8595360" y="5093208"/>
-            <a:ext cx="228600" cy="228600"/>
+            <a:off x="8202168" y="5266944"/>
+            <a:ext cx="219456" cy="219456"/>
           </a:xfrm>
           <a:prstGeom prst="ellipse">
             <a:avLst/>
@@ -1501,7 +1501,7 @@
               <a:buNone/>
             </a:pPr>
             <a:r>
-              <a:rPr lang="en-US" sz="800" b="1" dirty="0">
+              <a:rPr lang="en-US" sz="900" b="1" dirty="0">
                 <a:solidFill>
                   <a:srgbClr val="FFFFFF"/>
                 </a:solidFill>
@@ -1511,7 +1511,7 @@
               </a:rPr>
               <a:t>7</a:t>
             </a:r>
-            <a:endParaRPr lang="en-US" sz="800" dirty="0"/>
+            <a:endParaRPr lang="en-US" sz="900" dirty="0"/>
           </a:p>
         </p:txBody>
       </p:sp>
@@ -1523,8 +1523,8 @@
         </p:nvSpPr>
         <p:spPr>
           <a:xfrm>
-            <a:off x="8869680" y="5093208"/>
-            <a:ext cx="2880360" cy="621792"/>
+            <a:off x="8494776" y="5175504"/>
+            <a:ext cx="3291840" cy="676656"/>
           </a:xfrm>
           <a:prstGeom prst="rect">
             <a:avLst/>
@@ -1540,7 +1540,7 @@
               <a:buNone/>
             </a:pPr>
             <a:r>
-              <a:rPr lang="en-US" sz="750" dirty="0">
+              <a:rPr lang="en-US" sz="900" dirty="0">
                 <a:solidFill>
                   <a:srgbClr val="232F3E"/>
                 </a:solidFill>
@@ -1548,9 +1548,9 @@
                 <a:ea typeface="Arial" pitchFamily="34" charset="-122"/>
                 <a:cs typeface="Arial" pitchFamily="34" charset="-120"/>
               </a:rPr>
-              <a:t>AWS Lambda (Prometheus MCP) provides PromQL query access via Amazon API Gateway with Amazon Cognito OAuth2 authentication.</a:t>
-            </a:r>
-            <a:endParaRPr lang="en-US" sz="750" dirty="0"/>
+              <a:t>AWS Lambda (Prometheus MCP) exposes PromQL via Amazon API Gateway + Amazon Cognito OAuth2.</a:t>
+            </a:r>
+            <a:endParaRPr lang="en-US" sz="900" dirty="0"/>
           </a:p>
         </p:txBody>
       </p:sp>
@@ -1562,8 +1562,8 @@
         </p:nvSpPr>
         <p:spPr>
           <a:xfrm>
-            <a:off x="8595360" y="5751576"/>
-            <a:ext cx="228600" cy="228600"/>
+            <a:off x="8202168" y="5989320"/>
+            <a:ext cx="219456" cy="219456"/>
           </a:xfrm>
           <a:prstGeom prst="ellipse">
             <a:avLst/>
@@ -1581,7 +1581,7 @@
               <a:buNone/>
             </a:pPr>
             <a:r>
-              <a:rPr lang="en-US" sz="800" b="1" dirty="0">
+              <a:rPr lang="en-US" sz="900" b="1" dirty="0">
                 <a:solidFill>
                   <a:srgbClr val="FFFFFF"/>
                 </a:solidFill>
@@ -1591,7 +1591,7 @@
               </a:rPr>
               <a:t>8</a:t>
             </a:r>
-            <a:endParaRPr lang="en-US" sz="800" dirty="0"/>
+            <a:endParaRPr lang="en-US" sz="900" dirty="0"/>
           </a:p>
         </p:txBody>
       </p:sp>
@@ -1603,8 +1603,8 @@
         </p:nvSpPr>
         <p:spPr>
           <a:xfrm>
-            <a:off x="8869680" y="5751576"/>
-            <a:ext cx="2880360" cy="621792"/>
+            <a:off x="8494776" y="5897880"/>
+            <a:ext cx="3291840" cy="676656"/>
           </a:xfrm>
           <a:prstGeom prst="rect">
             <a:avLst/>
@@ -1620,7 +1620,7 @@
               <a:buNone/>
             </a:pPr>
             <a:r>
-              <a:rPr lang="en-US" sz="750" dirty="0">
+              <a:rPr lang="en-US" sz="900" dirty="0">
                 <a:solidFill>
                   <a:srgbClr val="232F3E"/>
                 </a:solidFill>
@@ -1628,9 +1628,9 @@
                 <a:ea typeface="Arial" pitchFamily="34" charset="-122"/>
                 <a:cs typeface="Arial" pitchFamily="34" charset="-120"/>
               </a:rPr>
-              <a:t>DevOps Agent or Amazon SageMaker notebook queries AMP to correlate subscriber drop with pod restarts for root cause analysis.</a:t>
-            </a:r>
-            <a:endParaRPr lang="en-US" sz="750" dirty="0"/>
+              <a:t>Amazon SageMaker notebook or DevOps Agent correlates subscriber drop with pod restarts.</a:t>
+            </a:r>
+            <a:endParaRPr lang="en-US" sz="900" dirty="0"/>
           </a:p>
         </p:txBody>
       </p:sp>
@@ -1642,8 +1642,8 @@
         </p:nvSpPr>
         <p:spPr>
           <a:xfrm>
-            <a:off x="274320" y="1005840"/>
-            <a:ext cx="8046720" cy="5486400"/>
+            <a:off x="274320" y="731520"/>
+            <a:ext cx="7635240" cy="5943600"/>
           </a:xfrm>
           <a:prstGeom prst="rect">
             <a:avLst/>
@@ -1667,8 +1667,8 @@
         </p:nvSpPr>
         <p:spPr>
           <a:xfrm>
-            <a:off x="320040" y="1024128"/>
-            <a:ext cx="1097280" cy="182880"/>
+            <a:off x="365760" y="758952"/>
+            <a:ext cx="914400" cy="164592"/>
           </a:xfrm>
           <a:prstGeom prst="rect">
             <a:avLst/>
@@ -1706,16 +1706,16 @@
         </p:nvSpPr>
         <p:spPr>
           <a:xfrm>
-            <a:off x="411480" y="1234440"/>
-            <a:ext cx="7772400" cy="5120640"/>
-          </a:xfrm>
-          <a:prstGeom prst="rect">
-            <a:avLst/>
-          </a:prstGeom>
-          <a:solidFill>
-            <a:srgbClr val="FAFAFA"/>
-          </a:solidFill>
-          <a:ln w="12700">
+            <a:off x="457200" y="960120"/>
+            <a:ext cx="7269480" cy="5577840"/>
+          </a:xfrm>
+          <a:prstGeom prst="rect">
+            <a:avLst/>
+          </a:prstGeom>
+          <a:solidFill>
+            <a:srgbClr val="FCFCFC"/>
+          </a:solidFill>
+          <a:ln w="9525">
             <a:solidFill>
               <a:srgbClr val="0972D3"/>
             </a:solidFill>
@@ -1731,7 +1731,7 @@
         </p:nvSpPr>
         <p:spPr>
           <a:xfrm>
-            <a:off x="457200" y="1252728"/>
+            <a:off x="548640" y="987552"/>
             <a:ext cx="1371600" cy="164592"/>
           </a:xfrm>
           <a:prstGeom prst="rect">
@@ -1770,14 +1770,14 @@
         </p:nvSpPr>
         <p:spPr>
           <a:xfrm>
-            <a:off x="548640" y="1463040"/>
-            <a:ext cx="5029200" cy="3474720"/>
-          </a:xfrm>
-          <a:prstGeom prst="rect">
-            <a:avLst/>
-          </a:prstGeom>
-          <a:solidFill>
-            <a:srgbClr val="FFF8F0"/>
+            <a:off x="594360" y="1188720"/>
+            <a:ext cx="4023360" cy="5212080"/>
+          </a:xfrm>
+          <a:prstGeom prst="rect">
+            <a:avLst/>
+          </a:prstGeom>
+          <a:solidFill>
+            <a:srgbClr val="FFFCF8"/>
           </a:solidFill>
           <a:ln w="12700">
             <a:solidFill>
@@ -1795,7 +1795,7 @@
         </p:nvSpPr>
         <p:spPr>
           <a:xfrm>
-            <a:off x="594360" y="1481328"/>
+            <a:off x="667512" y="1216152"/>
             <a:ext cx="1097280" cy="164592"/>
           </a:xfrm>
           <a:prstGeom prst="rect">
@@ -1812,7 +1812,7 @@
               <a:buNone/>
             </a:pPr>
             <a:r>
-              <a:rPr lang="en-US" sz="700" b="1" dirty="0">
+              <a:rPr lang="en-US" sz="800" b="1" dirty="0">
                 <a:solidFill>
                   <a:srgbClr val="FF9900"/>
                 </a:solidFill>
@@ -1822,7 +1822,7 @@
               </a:rPr>
               <a:t>Amazon EKS</a:t>
             </a:r>
-            <a:endParaRPr lang="en-US" sz="700" dirty="0"/>
+            <a:endParaRPr lang="en-US" sz="800" dirty="0"/>
           </a:p>
         </p:txBody>
       </p:sp>
@@ -1834,16 +1834,16 @@
         </p:nvSpPr>
         <p:spPr>
           <a:xfrm>
-            <a:off x="640080" y="1691640"/>
-            <a:ext cx="2194560" cy="1097280"/>
-          </a:xfrm>
-          <a:prstGeom prst="rect">
-            <a:avLst/>
-          </a:prstGeom>
-          <a:solidFill>
-            <a:srgbClr val="E8F4FD"/>
-          </a:solidFill>
-          <a:ln w="9525">
+            <a:off x="685800" y="1444752"/>
+            <a:ext cx="3794760" cy="1051560"/>
+          </a:xfrm>
+          <a:prstGeom prst="rect">
+            <a:avLst/>
+          </a:prstGeom>
+          <a:solidFill>
+            <a:srgbClr val="EBF5FF"/>
+          </a:solidFill>
+          <a:ln w="6350">
             <a:solidFill>
               <a:srgbClr val="0972D3"/>
             </a:solidFill>
@@ -1859,8 +1859,8 @@
         </p:nvSpPr>
         <p:spPr>
           <a:xfrm>
-            <a:off x="685800" y="1709928"/>
-            <a:ext cx="1371600" cy="137160"/>
+            <a:off x="731520" y="1472184"/>
+            <a:ext cx="1371600" cy="146304"/>
           </a:xfrm>
           <a:prstGeom prst="rect">
             <a:avLst/>
@@ -1876,7 +1876,7 @@
               <a:buNone/>
             </a:pPr>
             <a:r>
-              <a:rPr lang="en-US" sz="650" b="1" dirty="0">
+              <a:rPr lang="en-US" sz="700" b="1" dirty="0">
                 <a:solidFill>
                   <a:srgbClr val="0972D3"/>
                 </a:solidFill>
@@ -1886,7 +1886,7 @@
               </a:rPr>
               <a:t>UERANSIM (RAN)</a:t>
             </a:r>
-            <a:endParaRPr lang="en-US" sz="650" dirty="0"/>
+            <a:endParaRPr lang="en-US" sz="700" dirty="0"/>
           </a:p>
         </p:txBody>
       </p:sp>
@@ -1898,8 +1898,8 @@
         </p:nvSpPr>
         <p:spPr>
           <a:xfrm>
-            <a:off x="731520" y="1920240"/>
-            <a:ext cx="475488" cy="502920"/>
+            <a:off x="777240" y="1673352"/>
+            <a:ext cx="822960" cy="685800"/>
           </a:xfrm>
           <a:prstGeom prst="rect">
             <a:avLst/>
@@ -1921,7 +1921,7 @@
               <a:buNone/>
             </a:pPr>
             <a:r>
-              <a:rPr lang="en-US" sz="600" dirty="0">
+              <a:rPr lang="en-US" sz="800" dirty="0">
                 <a:solidFill>
                   <a:srgbClr val="0972D3"/>
                 </a:solidFill>
@@ -1931,14 +1931,14 @@
               </a:rPr>
               <a:t>gNB-1a</a:t>
             </a:r>
-            <a:endParaRPr lang="en-US" sz="600" dirty="0"/>
-          </a:p>
-          <a:p>
-            <a:pPr algn="ctr" indent="0" marL="0">
-              <a:buNone/>
-            </a:pPr>
-            <a:r>
-              <a:rPr lang="en-US" sz="600" dirty="0">
+            <a:endParaRPr lang="en-US" sz="800" dirty="0"/>
+          </a:p>
+          <a:p>
+            <a:pPr algn="ctr" indent="0" marL="0">
+              <a:buNone/>
+            </a:pPr>
+            <a:r>
+              <a:rPr lang="en-US" sz="800" dirty="0">
                 <a:solidFill>
                   <a:srgbClr val="0972D3"/>
                 </a:solidFill>
@@ -1948,7 +1948,7 @@
               </a:rPr>
               <a:t>25 UEs</a:t>
             </a:r>
-            <a:endParaRPr lang="en-US" sz="600" dirty="0"/>
+            <a:endParaRPr lang="en-US" sz="800" dirty="0"/>
           </a:p>
         </p:txBody>
       </p:sp>
@@ -1960,8 +1960,8 @@
         </p:nvSpPr>
         <p:spPr>
           <a:xfrm>
-            <a:off x="1252728" y="1920240"/>
-            <a:ext cx="475488" cy="502920"/>
+            <a:off x="1691640" y="1673352"/>
+            <a:ext cx="822960" cy="685800"/>
           </a:xfrm>
           <a:prstGeom prst="rect">
             <a:avLst/>
@@ -1983,7 +1983,7 @@
               <a:buNone/>
             </a:pPr>
             <a:r>
-              <a:rPr lang="en-US" sz="600" dirty="0">
+              <a:rPr lang="en-US" sz="800" dirty="0">
                 <a:solidFill>
                   <a:srgbClr val="0972D3"/>
                 </a:solidFill>
@@ -1993,14 +1993,14 @@
               </a:rPr>
               <a:t>gNB-1b</a:t>
             </a:r>
-            <a:endParaRPr lang="en-US" sz="600" dirty="0"/>
-          </a:p>
-          <a:p>
-            <a:pPr algn="ctr" indent="0" marL="0">
-              <a:buNone/>
-            </a:pPr>
-            <a:r>
-              <a:rPr lang="en-US" sz="600" dirty="0">
+            <a:endParaRPr lang="en-US" sz="800" dirty="0"/>
+          </a:p>
+          <a:p>
+            <a:pPr algn="ctr" indent="0" marL="0">
+              <a:buNone/>
+            </a:pPr>
+            <a:r>
+              <a:rPr lang="en-US" sz="800" dirty="0">
                 <a:solidFill>
                   <a:srgbClr val="0972D3"/>
                 </a:solidFill>
@@ -2010,7 +2010,7 @@
               </a:rPr>
               <a:t>25 UEs</a:t>
             </a:r>
-            <a:endParaRPr lang="en-US" sz="600" dirty="0"/>
+            <a:endParaRPr lang="en-US" sz="800" dirty="0"/>
           </a:p>
         </p:txBody>
       </p:sp>
@@ -2022,8 +2022,8 @@
         </p:nvSpPr>
         <p:spPr>
           <a:xfrm>
-            <a:off x="1773936" y="1920240"/>
-            <a:ext cx="475488" cy="502920"/>
+            <a:off x="2606040" y="1673352"/>
+            <a:ext cx="822960" cy="685800"/>
           </a:xfrm>
           <a:prstGeom prst="rect">
             <a:avLst/>
@@ -2045,7 +2045,7 @@
               <a:buNone/>
             </a:pPr>
             <a:r>
-              <a:rPr lang="en-US" sz="600" dirty="0">
+              <a:rPr lang="en-US" sz="800" dirty="0">
                 <a:solidFill>
                   <a:srgbClr val="0972D3"/>
                 </a:solidFill>
@@ -2055,14 +2055,14 @@
               </a:rPr>
               <a:t>gNB-2a</a:t>
             </a:r>
-            <a:endParaRPr lang="en-US" sz="600" dirty="0"/>
-          </a:p>
-          <a:p>
-            <a:pPr algn="ctr" indent="0" marL="0">
-              <a:buNone/>
-            </a:pPr>
-            <a:r>
-              <a:rPr lang="en-US" sz="600" dirty="0">
+            <a:endParaRPr lang="en-US" sz="800" dirty="0"/>
+          </a:p>
+          <a:p>
+            <a:pPr algn="ctr" indent="0" marL="0">
+              <a:buNone/>
+            </a:pPr>
+            <a:r>
+              <a:rPr lang="en-US" sz="800" dirty="0">
                 <a:solidFill>
                   <a:srgbClr val="0972D3"/>
                 </a:solidFill>
@@ -2072,7 +2072,7 @@
               </a:rPr>
               <a:t>25 UEs</a:t>
             </a:r>
-            <a:endParaRPr lang="en-US" sz="600" dirty="0"/>
+            <a:endParaRPr lang="en-US" sz="800" dirty="0"/>
           </a:p>
         </p:txBody>
       </p:sp>
@@ -2084,8 +2084,8 @@
         </p:nvSpPr>
         <p:spPr>
           <a:xfrm>
-            <a:off x="2295144" y="1920240"/>
-            <a:ext cx="475488" cy="502920"/>
+            <a:off x="3520440" y="1673352"/>
+            <a:ext cx="822960" cy="685800"/>
           </a:xfrm>
           <a:prstGeom prst="rect">
             <a:avLst/>
@@ -2107,7 +2107,7 @@
               <a:buNone/>
             </a:pPr>
             <a:r>
-              <a:rPr lang="en-US" sz="600" dirty="0">
+              <a:rPr lang="en-US" sz="800" dirty="0">
                 <a:solidFill>
                   <a:srgbClr val="0972D3"/>
                 </a:solidFill>
@@ -2117,14 +2117,14 @@
               </a:rPr>
               <a:t>gNB-2b</a:t>
             </a:r>
-            <a:endParaRPr lang="en-US" sz="600" dirty="0"/>
-          </a:p>
-          <a:p>
-            <a:pPr algn="ctr" indent="0" marL="0">
-              <a:buNone/>
-            </a:pPr>
-            <a:r>
-              <a:rPr lang="en-US" sz="600" dirty="0">
+            <a:endParaRPr lang="en-US" sz="800" dirty="0"/>
+          </a:p>
+          <a:p>
+            <a:pPr algn="ctr" indent="0" marL="0">
+              <a:buNone/>
+            </a:pPr>
+            <a:r>
+              <a:rPr lang="en-US" sz="800" dirty="0">
                 <a:solidFill>
                   <a:srgbClr val="0972D3"/>
                 </a:solidFill>
@@ -2134,7 +2134,7 @@
               </a:rPr>
               <a:t>25 UEs</a:t>
             </a:r>
-            <a:endParaRPr lang="en-US" sz="600" dirty="0"/>
+            <a:endParaRPr lang="en-US" sz="800" dirty="0"/>
           </a:p>
         </p:txBody>
       </p:sp>
@@ -2146,7 +2146,7 @@
         </p:nvSpPr>
         <p:spPr>
           <a:xfrm>
-            <a:off x="640080" y="2468880"/>
+            <a:off x="4160520" y="1472184"/>
             <a:ext cx="182880" cy="182880"/>
           </a:xfrm>
           <a:prstGeom prst="ellipse">
@@ -2165,7 +2165,7 @@
               <a:buNone/>
             </a:pPr>
             <a:r>
-              <a:rPr lang="en-US" sz="700" b="1" dirty="0">
+              <a:rPr lang="en-US" sz="800" b="1" dirty="0">
                 <a:solidFill>
                   <a:srgbClr val="FFFFFF"/>
                 </a:solidFill>
@@ -2175,7 +2175,7 @@
               </a:rPr>
               <a:t>1</a:t>
             </a:r>
-            <a:endParaRPr lang="en-US" sz="700" dirty="0"/>
+            <a:endParaRPr lang="en-US" sz="800" dirty="0"/>
           </a:p>
         </p:txBody>
       </p:sp>
@@ -2187,16 +2187,16 @@
         </p:nvSpPr>
         <p:spPr>
           <a:xfrm>
-            <a:off x="640080" y="2834640"/>
-            <a:ext cx="4846320" cy="1920240"/>
-          </a:xfrm>
-          <a:prstGeom prst="rect">
-            <a:avLst/>
-          </a:prstGeom>
-          <a:solidFill>
-            <a:srgbClr val="FFF4E6"/>
-          </a:solidFill>
-          <a:ln w="9525">
+            <a:off x="685800" y="2587752"/>
+            <a:ext cx="3794760" cy="1600200"/>
+          </a:xfrm>
+          <a:prstGeom prst="rect">
+            <a:avLst/>
+          </a:prstGeom>
+          <a:solidFill>
+            <a:srgbClr val="FFF6ED"/>
+          </a:solidFill>
+          <a:ln w="6350">
             <a:solidFill>
               <a:srgbClr val="FF9900"/>
             </a:solidFill>
@@ -2212,8 +2212,8 @@
         </p:nvSpPr>
         <p:spPr>
           <a:xfrm>
-            <a:off x="685800" y="2852928"/>
-            <a:ext cx="1371600" cy="137160"/>
+            <a:off x="731520" y="2615184"/>
+            <a:ext cx="1371600" cy="146304"/>
           </a:xfrm>
           <a:prstGeom prst="rect">
             <a:avLst/>
@@ -2229,7 +2229,7 @@
               <a:buNone/>
             </a:pPr>
             <a:r>
-              <a:rPr lang="en-US" sz="650" b="1" dirty="0">
+              <a:rPr lang="en-US" sz="700" b="1" dirty="0">
                 <a:solidFill>
                   <a:srgbClr val="FF9900"/>
                 </a:solidFill>
@@ -2239,7 +2239,7 @@
               </a:rPr>
               <a:t>open5gs 5G Core</a:t>
             </a:r>
-            <a:endParaRPr lang="en-US" sz="650" dirty="0"/>
+            <a:endParaRPr lang="en-US" sz="700" dirty="0"/>
           </a:p>
         </p:txBody>
       </p:sp>
@@ -2251,8 +2251,8 @@
         </p:nvSpPr>
         <p:spPr>
           <a:xfrm>
-            <a:off x="731520" y="3063240"/>
-            <a:ext cx="685800" cy="640080"/>
+            <a:off x="777240" y="2816352"/>
+            <a:ext cx="822960" cy="502920"/>
           </a:xfrm>
           <a:prstGeom prst="rect">
             <a:avLst/>
@@ -2274,7 +2274,7 @@
               <a:buNone/>
             </a:pPr>
             <a:r>
-              <a:rPr lang="en-US" sz="600" dirty="0">
+              <a:rPr lang="en-US" sz="800" dirty="0">
                 <a:solidFill>
                   <a:srgbClr val="232F3E"/>
                 </a:solidFill>
@@ -2284,14 +2284,14 @@
               </a:rPr>
               <a:t>AMF-1</a:t>
             </a:r>
-            <a:endParaRPr lang="en-US" sz="600" dirty="0"/>
-          </a:p>
-          <a:p>
-            <a:pPr algn="ctr" indent="0" marL="0">
-              <a:buNone/>
-            </a:pPr>
-            <a:r>
-              <a:rPr lang="en-US" sz="600" dirty="0">
+            <a:endParaRPr lang="en-US" sz="800" dirty="0"/>
+          </a:p>
+          <a:p>
+            <a:pPr algn="ctr" indent="0" marL="0">
+              <a:buNone/>
+            </a:pPr>
+            <a:r>
+              <a:rPr lang="en-US" sz="800" dirty="0">
                 <a:solidFill>
                   <a:srgbClr val="232F3E"/>
                 </a:solidFill>
@@ -2301,24 +2301,7 @@
               </a:rPr>
               <a:t>TAC=1</a:t>
             </a:r>
-            <a:endParaRPr lang="en-US" sz="600" dirty="0"/>
-          </a:p>
-          <a:p>
-            <a:pPr algn="ctr" indent="0" marL="0">
-              <a:buNone/>
-            </a:pPr>
-            <a:r>
-              <a:rPr lang="en-US" sz="600" dirty="0">
-                <a:solidFill>
-                  <a:srgbClr val="232F3E"/>
-                </a:solidFill>
-                <a:latin typeface="Arial" pitchFamily="34" charset="0"/>
-                <a:ea typeface="Arial" pitchFamily="34" charset="-122"/>
-                <a:cs typeface="Arial" pitchFamily="34" charset="-120"/>
-              </a:rPr>
-              <a:t>50 UEs</a:t>
-            </a:r>
-            <a:endParaRPr lang="en-US" sz="600" dirty="0"/>
+            <a:endParaRPr lang="en-US" sz="800" dirty="0"/>
           </a:p>
         </p:txBody>
       </p:sp>
@@ -2330,8 +2313,8 @@
         </p:nvSpPr>
         <p:spPr>
           <a:xfrm>
-            <a:off x="1508760" y="3063240"/>
-            <a:ext cx="685800" cy="640080"/>
+            <a:off x="1691640" y="2816352"/>
+            <a:ext cx="822960" cy="502920"/>
           </a:xfrm>
           <a:prstGeom prst="rect">
             <a:avLst/>
@@ -2353,7 +2336,7 @@
               <a:buNone/>
             </a:pPr>
             <a:r>
-              <a:rPr lang="en-US" sz="600" dirty="0">
+              <a:rPr lang="en-US" sz="800" dirty="0">
                 <a:solidFill>
                   <a:srgbClr val="232F3E"/>
                 </a:solidFill>
@@ -2363,14 +2346,14 @@
               </a:rPr>
               <a:t>AMF-2</a:t>
             </a:r>
-            <a:endParaRPr lang="en-US" sz="600" dirty="0"/>
-          </a:p>
-          <a:p>
-            <a:pPr algn="ctr" indent="0" marL="0">
-              <a:buNone/>
-            </a:pPr>
-            <a:r>
-              <a:rPr lang="en-US" sz="600" dirty="0">
+            <a:endParaRPr lang="en-US" sz="800" dirty="0"/>
+          </a:p>
+          <a:p>
+            <a:pPr algn="ctr" indent="0" marL="0">
+              <a:buNone/>
+            </a:pPr>
+            <a:r>
+              <a:rPr lang="en-US" sz="800" dirty="0">
                 <a:solidFill>
                   <a:srgbClr val="232F3E"/>
                 </a:solidFill>
@@ -2380,24 +2363,7 @@
               </a:rPr>
               <a:t>TAC=2</a:t>
             </a:r>
-            <a:endParaRPr lang="en-US" sz="600" dirty="0"/>
-          </a:p>
-          <a:p>
-            <a:pPr algn="ctr" indent="0" marL="0">
-              <a:buNone/>
-            </a:pPr>
-            <a:r>
-              <a:rPr lang="en-US" sz="600" dirty="0">
-                <a:solidFill>
-                  <a:srgbClr val="232F3E"/>
-                </a:solidFill>
-                <a:latin typeface="Arial" pitchFamily="34" charset="0"/>
-                <a:ea typeface="Arial" pitchFamily="34" charset="-122"/>
-                <a:cs typeface="Arial" pitchFamily="34" charset="-120"/>
-              </a:rPr>
-              <a:t>50 UEs</a:t>
-            </a:r>
-            <a:endParaRPr lang="en-US" sz="600" dirty="0"/>
+            <a:endParaRPr lang="en-US" sz="800" dirty="0"/>
           </a:p>
         </p:txBody>
       </p:sp>
@@ -2409,8 +2375,8 @@
         </p:nvSpPr>
         <p:spPr>
           <a:xfrm>
-            <a:off x="2377440" y="3154680"/>
-            <a:ext cx="548640" cy="457200"/>
+            <a:off x="2606040" y="2907792"/>
+            <a:ext cx="640080" cy="365760"/>
           </a:xfrm>
           <a:prstGeom prst="rect">
             <a:avLst/>
@@ -2432,7 +2398,7 @@
               <a:buNone/>
             </a:pPr>
             <a:r>
-              <a:rPr lang="en-US" sz="700" dirty="0">
+              <a:rPr lang="en-US" sz="900" dirty="0">
                 <a:solidFill>
                   <a:srgbClr val="232F3E"/>
                 </a:solidFill>
@@ -2442,7 +2408,7 @@
               </a:rPr>
               <a:t>SMF</a:t>
             </a:r>
-            <a:endParaRPr lang="en-US" sz="700" dirty="0"/>
+            <a:endParaRPr lang="en-US" sz="900" dirty="0"/>
           </a:p>
         </p:txBody>
       </p:sp>
@@ -2454,8 +2420,8 @@
         </p:nvSpPr>
         <p:spPr>
           <a:xfrm>
-            <a:off x="3108960" y="3154680"/>
-            <a:ext cx="502920" cy="457200"/>
+            <a:off x="3337560" y="2907792"/>
+            <a:ext cx="822960" cy="365760"/>
           </a:xfrm>
           <a:prstGeom prst="rect">
             <a:avLst/>
@@ -2477,7 +2443,7 @@
               <a:buNone/>
             </a:pPr>
             <a:r>
-              <a:rPr lang="en-US" sz="600" dirty="0">
+              <a:rPr lang="en-US" sz="900" dirty="0">
                 <a:solidFill>
                   <a:srgbClr val="232F3E"/>
                 </a:solidFill>
@@ -2485,9 +2451,9 @@
                 <a:ea typeface="Arial" pitchFamily="34" charset="-122"/>
                 <a:cs typeface="Arial" pitchFamily="34" charset="-120"/>
               </a:rPr>
-              <a:t>UPF-1</a:t>
-            </a:r>
-            <a:endParaRPr lang="en-US" sz="600" dirty="0"/>
+              <a:t>UPF 1–4</a:t>
+            </a:r>
+            <a:endParaRPr lang="en-US" sz="900" dirty="0"/>
           </a:p>
         </p:txBody>
       </p:sp>
@@ -2499,18 +2465,18 @@
         </p:nvSpPr>
         <p:spPr>
           <a:xfrm>
-            <a:off x="3657600" y="3154680"/>
-            <a:ext cx="502920" cy="457200"/>
-          </a:xfrm>
-          <a:prstGeom prst="rect">
-            <a:avLst/>
-          </a:prstGeom>
-          <a:solidFill>
-            <a:srgbClr val="FFE8CC"/>
+            <a:off x="777240" y="3456432"/>
+            <a:ext cx="3566160" cy="274320"/>
+          </a:xfrm>
+          <a:prstGeom prst="rect">
+            <a:avLst/>
+          </a:prstGeom>
+          <a:solidFill>
+            <a:srgbClr val="FFF9F2"/>
           </a:solidFill>
           <a:ln w="6350">
             <a:solidFill>
-              <a:srgbClr val="FF9900"/>
+              <a:srgbClr val="DDDDDD"/>
             </a:solidFill>
           </a:ln>
         </p:spPr>
@@ -2522,17 +2488,17 @@
               <a:buNone/>
             </a:pPr>
             <a:r>
-              <a:rPr lang="en-US" sz="600" dirty="0">
-                <a:solidFill>
-                  <a:srgbClr val="232F3E"/>
-                </a:solidFill>
-                <a:latin typeface="Arial" pitchFamily="34" charset="0"/>
-                <a:ea typeface="Arial" pitchFamily="34" charset="-122"/>
-                <a:cs typeface="Arial" pitchFamily="34" charset="-120"/>
-              </a:rPr>
-              <a:t>UPF-2</a:t>
-            </a:r>
-            <a:endParaRPr lang="en-US" sz="600" dirty="0"/>
+              <a:rPr lang="en-US" sz="700" dirty="0">
+                <a:solidFill>
+                  <a:srgbClr val="666666"/>
+                </a:solidFill>
+                <a:latin typeface="Arial" pitchFamily="34" charset="0"/>
+                <a:ea typeface="Arial" pitchFamily="34" charset="-122"/>
+                <a:cs typeface="Arial" pitchFamily="34" charset="-120"/>
+              </a:rPr>
+              <a:t>NRF | AUSF | UDM | UDR | PCF | NSSF | BSF</a:t>
+            </a:r>
+            <a:endParaRPr lang="en-US" sz="700" dirty="0"/>
           </a:p>
         </p:txBody>
       </p:sp>
@@ -2544,40 +2510,36 @@
         </p:nvSpPr>
         <p:spPr>
           <a:xfrm>
-            <a:off x="4206240" y="3154680"/>
-            <a:ext cx="502920" cy="457200"/>
-          </a:xfrm>
-          <a:prstGeom prst="rect">
-            <a:avLst/>
-          </a:prstGeom>
-          <a:solidFill>
-            <a:srgbClr val="FFE8CC"/>
-          </a:solidFill>
-          <a:ln w="6350">
-            <a:solidFill>
-              <a:srgbClr val="FF9900"/>
-            </a:solidFill>
-          </a:ln>
-        </p:spPr>
-        <p:txBody>
-          <a:bodyPr wrap="square" rtlCol="0" anchor="ctr"/>
-          <a:lstStyle/>
-          <a:p>
-            <a:pPr algn="ctr" indent="0" marL="0">
-              <a:buNone/>
-            </a:pPr>
-            <a:r>
-              <a:rPr lang="en-US" sz="600" dirty="0">
-                <a:solidFill>
-                  <a:srgbClr val="232F3E"/>
-                </a:solidFill>
-                <a:latin typeface="Arial" pitchFamily="34" charset="0"/>
-                <a:ea typeface="Arial" pitchFamily="34" charset="-122"/>
-                <a:cs typeface="Arial" pitchFamily="34" charset="-120"/>
-              </a:rPr>
-              <a:t>UPF-3</a:t>
-            </a:r>
-            <a:endParaRPr lang="en-US" sz="600" dirty="0"/>
+            <a:off x="777240" y="3822192"/>
+            <a:ext cx="1828800" cy="256032"/>
+          </a:xfrm>
+          <a:prstGeom prst="rect">
+            <a:avLst/>
+          </a:prstGeom>
+          <a:solidFill>
+            <a:srgbClr val="D13212"/>
+          </a:solidFill>
+          <a:ln/>
+        </p:spPr>
+        <p:txBody>
+          <a:bodyPr wrap="square" rtlCol="0" anchor="ctr"/>
+          <a:lstStyle/>
+          <a:p>
+            <a:pPr algn="ctr" indent="0" marL="0">
+              <a:buNone/>
+            </a:pPr>
+            <a:r>
+              <a:rPr lang="en-US" sz="700" dirty="0">
+                <a:solidFill>
+                  <a:srgbClr val="FFFFFF"/>
+                </a:solidFill>
+                <a:latin typeface="Arial" pitchFamily="34" charset="0"/>
+                <a:ea typeface="Arial" pitchFamily="34" charset="-122"/>
+                <a:cs typeface="Arial" pitchFamily="34" charset="-120"/>
+              </a:rPr>
+              <a:t>⚠ Fault: Bad Config → AMF-1</a:t>
+            </a:r>
+            <a:endParaRPr lang="en-US" sz="700" dirty="0"/>
           </a:p>
         </p:txBody>
       </p:sp>
@@ -2589,40 +2551,36 @@
         </p:nvSpPr>
         <p:spPr>
           <a:xfrm>
-            <a:off x="4754880" y="3154680"/>
-            <a:ext cx="502920" cy="457200"/>
-          </a:xfrm>
-          <a:prstGeom prst="rect">
-            <a:avLst/>
-          </a:prstGeom>
-          <a:solidFill>
-            <a:srgbClr val="FFE8CC"/>
-          </a:solidFill>
-          <a:ln w="6350">
-            <a:solidFill>
-              <a:srgbClr val="FF9900"/>
-            </a:solidFill>
-          </a:ln>
-        </p:spPr>
-        <p:txBody>
-          <a:bodyPr wrap="square" rtlCol="0" anchor="ctr"/>
-          <a:lstStyle/>
-          <a:p>
-            <a:pPr algn="ctr" indent="0" marL="0">
-              <a:buNone/>
-            </a:pPr>
-            <a:r>
-              <a:rPr lang="en-US" sz="600" dirty="0">
-                <a:solidFill>
-                  <a:srgbClr val="232F3E"/>
-                </a:solidFill>
-                <a:latin typeface="Arial" pitchFamily="34" charset="0"/>
-                <a:ea typeface="Arial" pitchFamily="34" charset="-122"/>
-                <a:cs typeface="Arial" pitchFamily="34" charset="-120"/>
-              </a:rPr>
-              <a:t>UPF-4</a:t>
-            </a:r>
-            <a:endParaRPr lang="en-US" sz="600" dirty="0"/>
+            <a:off x="4160520" y="2615184"/>
+            <a:ext cx="182880" cy="182880"/>
+          </a:xfrm>
+          <a:prstGeom prst="ellipse">
+            <a:avLst/>
+          </a:prstGeom>
+          <a:solidFill>
+            <a:srgbClr val="FF9900"/>
+          </a:solidFill>
+          <a:ln/>
+        </p:spPr>
+        <p:txBody>
+          <a:bodyPr wrap="square" rtlCol="0" anchor="ctr"/>
+          <a:lstStyle/>
+          <a:p>
+            <a:pPr algn="ctr" indent="0" marL="0">
+              <a:buNone/>
+            </a:pPr>
+            <a:r>
+              <a:rPr lang="en-US" sz="800" b="1" dirty="0">
+                <a:solidFill>
+                  <a:srgbClr val="FFFFFF"/>
+                </a:solidFill>
+                <a:latin typeface="Arial" pitchFamily="34" charset="0"/>
+                <a:ea typeface="Arial" pitchFamily="34" charset="-122"/>
+                <a:cs typeface="Arial" pitchFamily="34" charset="-120"/>
+              </a:rPr>
+              <a:t>2</a:t>
+            </a:r>
+            <a:endParaRPr lang="en-US" sz="800" dirty="0"/>
           </a:p>
         </p:txBody>
       </p:sp>
@@ -2634,100 +2592,14 @@
         </p:nvSpPr>
         <p:spPr>
           <a:xfrm>
-            <a:off x="731520" y="3840480"/>
-            <a:ext cx="3200400" cy="274320"/>
-          </a:xfrm>
-          <a:prstGeom prst="rect">
-            <a:avLst/>
-          </a:prstGeom>
-          <a:solidFill>
-            <a:srgbClr val="FFF9F0"/>
-          </a:solidFill>
-          <a:ln w="6350">
-            <a:solidFill>
-              <a:srgbClr val="000000"/>
-            </a:solidFill>
-          </a:ln>
-        </p:spPr>
-        <p:txBody>
-          <a:bodyPr wrap="square" rtlCol="0" anchor="ctr"/>
-          <a:lstStyle/>
-          <a:p>
-            <a:pPr algn="l" indent="0" marL="0">
-              <a:buNone/>
-            </a:pPr>
-            <a:r>
-              <a:rPr lang="en-US" sz="600" dirty="0">
-                <a:solidFill>
-                  <a:srgbClr val="666666"/>
-                </a:solidFill>
-                <a:latin typeface="Arial" pitchFamily="34" charset="0"/>
-                <a:ea typeface="Arial" pitchFamily="34" charset="-122"/>
-                <a:cs typeface="Arial" pitchFamily="34" charset="-120"/>
-              </a:rPr>
-              <a:t>NRF | AUSF | UDM | UDR | PCF | NSSF | BSF</a:t>
-            </a:r>
-            <a:endParaRPr lang="en-US" sz="600" dirty="0"/>
-          </a:p>
-        </p:txBody>
-      </p:sp>
-      <p:sp>
-        <p:nvSpPr>
-          <p:cNvPr id="45" name="Text 43"/>
-          <p:cNvSpPr/>
-          <p:nvPr/>
-        </p:nvSpPr>
-        <p:spPr>
-          <a:xfrm>
-            <a:off x="5029200" y="2834640"/>
-            <a:ext cx="182880" cy="182880"/>
-          </a:xfrm>
-          <a:prstGeom prst="ellipse">
-            <a:avLst/>
-          </a:prstGeom>
-          <a:solidFill>
-            <a:srgbClr val="FF9900"/>
-          </a:solidFill>
-          <a:ln/>
-        </p:spPr>
-        <p:txBody>
-          <a:bodyPr wrap="square" rtlCol="0" anchor="ctr"/>
-          <a:lstStyle/>
-          <a:p>
-            <a:pPr algn="ctr" indent="0" marL="0">
-              <a:buNone/>
-            </a:pPr>
-            <a:r>
-              <a:rPr lang="en-US" sz="700" b="1" dirty="0">
-                <a:solidFill>
-                  <a:srgbClr val="FFFFFF"/>
-                </a:solidFill>
-                <a:latin typeface="Arial" pitchFamily="34" charset="0"/>
-                <a:ea typeface="Arial" pitchFamily="34" charset="-122"/>
-                <a:cs typeface="Arial" pitchFamily="34" charset="-120"/>
-              </a:rPr>
-              <a:t>2</a:t>
-            </a:r>
-            <a:endParaRPr lang="en-US" sz="700" dirty="0"/>
-          </a:p>
-        </p:txBody>
-      </p:sp>
-      <p:sp>
-        <p:nvSpPr>
-          <p:cNvPr id="46" name="Text 44"/>
-          <p:cNvSpPr/>
-          <p:nvPr/>
-        </p:nvSpPr>
-        <p:spPr>
-          <a:xfrm>
-            <a:off x="731520" y="4251960"/>
-            <a:ext cx="1463040" cy="502920"/>
-          </a:xfrm>
-          <a:prstGeom prst="rect">
-            <a:avLst/>
-          </a:prstGeom>
-          <a:solidFill>
-            <a:srgbClr val="E8F8E8"/>
+            <a:off x="777240" y="4279392"/>
+            <a:ext cx="2194560" cy="548640"/>
+          </a:xfrm>
+          <a:prstGeom prst="rect">
+            <a:avLst/>
+          </a:prstGeom>
+          <a:solidFill>
+            <a:srgbClr val="E0F5E0"/>
           </a:solidFill>
           <a:ln w="9525">
             <a:solidFill>
@@ -2743,7 +2615,7 @@
               <a:buNone/>
             </a:pPr>
             <a:r>
-              <a:rPr lang="en-US" sz="650" dirty="0">
+              <a:rPr lang="en-US" sz="800" dirty="0">
                 <a:solidFill>
                   <a:srgbClr val="1B8B1B"/>
                 </a:solidFill>
@@ -2753,14 +2625,14 @@
               </a:rPr>
               <a:t>Prometheus</a:t>
             </a:r>
-            <a:endParaRPr lang="en-US" sz="650" dirty="0"/>
-          </a:p>
-          <a:p>
-            <a:pPr algn="ctr" indent="0" marL="0">
-              <a:buNone/>
-            </a:pPr>
-            <a:r>
-              <a:rPr lang="en-US" sz="650" dirty="0">
+            <a:endParaRPr lang="en-US" sz="800" dirty="0"/>
+          </a:p>
+          <a:p>
+            <a:pPr algn="ctr" indent="0" marL="0">
+              <a:buNone/>
+            </a:pPr>
+            <a:r>
+              <a:rPr lang="en-US" sz="800" dirty="0">
                 <a:solidFill>
                   <a:srgbClr val="1B8B1B"/>
                 </a:solidFill>
@@ -2770,19 +2642,19 @@
               </a:rPr>
               <a:t>(kube-prometheus-stack)</a:t>
             </a:r>
-            <a:endParaRPr lang="en-US" sz="650" dirty="0"/>
-          </a:p>
-        </p:txBody>
-      </p:sp>
-      <p:sp>
-        <p:nvSpPr>
-          <p:cNvPr id="47" name="Text 45"/>
-          <p:cNvSpPr/>
-          <p:nvPr/>
-        </p:nvSpPr>
-        <p:spPr>
-          <a:xfrm>
-            <a:off x="2286000" y="4343400"/>
+            <a:endParaRPr lang="en-US" sz="800" dirty="0"/>
+          </a:p>
+        </p:txBody>
+      </p:sp>
+      <p:sp>
+        <p:nvSpPr>
+          <p:cNvPr id="45" name="Text 43"/>
+          <p:cNvSpPr/>
+          <p:nvPr/>
+        </p:nvSpPr>
+        <p:spPr>
+          <a:xfrm>
+            <a:off x="3063240" y="4416552"/>
             <a:ext cx="182880" cy="182880"/>
           </a:xfrm>
           <a:prstGeom prst="ellipse">
@@ -2801,7 +2673,7 @@
               <a:buNone/>
             </a:pPr>
             <a:r>
-              <a:rPr lang="en-US" sz="700" b="1" dirty="0">
+              <a:rPr lang="en-US" sz="800" b="1" dirty="0">
                 <a:solidFill>
                   <a:srgbClr val="FFFFFF"/>
                 </a:solidFill>
@@ -2811,783 +2683,66 @@
               </a:rPr>
               <a:t>3</a:t>
             </a:r>
-            <a:endParaRPr lang="en-US" sz="700" dirty="0"/>
-          </a:p>
-        </p:txBody>
-      </p:sp>
-      <p:sp>
-        <p:nvSpPr>
-          <p:cNvPr id="48" name="Text 46"/>
-          <p:cNvSpPr/>
-          <p:nvPr/>
-        </p:nvSpPr>
-        <p:spPr>
-          <a:xfrm>
-            <a:off x="5669280" y="1554480"/>
-            <a:ext cx="2011680" cy="640080"/>
-          </a:xfrm>
-          <a:prstGeom prst="rect">
-            <a:avLst/>
-          </a:prstGeom>
-          <a:solidFill>
-            <a:srgbClr val="C8E8C8"/>
-          </a:solidFill>
-          <a:ln w="12700">
+            <a:endParaRPr lang="en-US" sz="800" dirty="0"/>
+          </a:p>
+        </p:txBody>
+      </p:sp>
+      <p:sp>
+        <p:nvSpPr>
+          <p:cNvPr id="46" name="Shape 44"/>
+          <p:cNvSpPr/>
+          <p:nvPr/>
+        </p:nvSpPr>
+        <p:spPr>
+          <a:xfrm>
+            <a:off x="2971800" y="4553712"/>
+            <a:ext cx="1737360" cy="0"/>
+          </a:xfrm>
+          <a:prstGeom prst="line">
+            <a:avLst/>
+          </a:prstGeom>
+          <a:noFill/>
+          <a:ln w="15875">
             <a:solidFill>
               <a:srgbClr val="1B8B1B"/>
             </a:solidFill>
+            <a:prstDash val="solid"/>
           </a:ln>
         </p:spPr>
-        <p:txBody>
-          <a:bodyPr wrap="square" rtlCol="0" anchor="ctr"/>
-          <a:lstStyle/>
-          <a:p>
-            <a:pPr algn="ctr" indent="0" marL="0">
-              <a:buNone/>
-            </a:pPr>
-            <a:r>
-              <a:rPr lang="en-US" sz="750" b="1" dirty="0">
-                <a:solidFill>
-                  <a:srgbClr val="1B8B1B"/>
-                </a:solidFill>
-                <a:latin typeface="Arial" pitchFamily="34" charset="0"/>
-                <a:ea typeface="Arial" pitchFamily="34" charset="-122"/>
-                <a:cs typeface="Arial" pitchFamily="34" charset="-120"/>
-              </a:rPr>
-              <a:t>Amazon Managed Service</a:t>
-            </a:r>
-            <a:endParaRPr lang="en-US" sz="750" dirty="0"/>
-          </a:p>
-          <a:p>
-            <a:pPr algn="ctr" indent="0" marL="0">
-              <a:buNone/>
-            </a:pPr>
-            <a:r>
-              <a:rPr lang="en-US" sz="750" b="1" dirty="0">
-                <a:solidFill>
-                  <a:srgbClr val="1B8B1B"/>
-                </a:solidFill>
-                <a:latin typeface="Arial" pitchFamily="34" charset="0"/>
-                <a:ea typeface="Arial" pitchFamily="34" charset="-122"/>
-                <a:cs typeface="Arial" pitchFamily="34" charset="-120"/>
-              </a:rPr>
-              <a:t>for Prometheus</a:t>
-            </a:r>
-            <a:endParaRPr lang="en-US" sz="750" dirty="0"/>
-          </a:p>
-        </p:txBody>
-      </p:sp>
-      <p:sp>
-        <p:nvSpPr>
-          <p:cNvPr id="49" name="Text 47"/>
-          <p:cNvSpPr/>
-          <p:nvPr/>
-        </p:nvSpPr>
-        <p:spPr>
-          <a:xfrm>
-            <a:off x="7772400" y="1737360"/>
-            <a:ext cx="182880" cy="182880"/>
-          </a:xfrm>
-          <a:prstGeom prst="ellipse">
-            <a:avLst/>
-          </a:prstGeom>
-          <a:solidFill>
-            <a:srgbClr val="FF9900"/>
-          </a:solidFill>
-          <a:ln/>
-        </p:spPr>
-        <p:txBody>
-          <a:bodyPr wrap="square" rtlCol="0" anchor="ctr"/>
-          <a:lstStyle/>
-          <a:p>
-            <a:pPr algn="ctr" indent="0" marL="0">
-              <a:buNone/>
-            </a:pPr>
-            <a:r>
-              <a:rPr lang="en-US" sz="700" b="1" dirty="0">
-                <a:solidFill>
-                  <a:srgbClr val="FFFFFF"/>
-                </a:solidFill>
-                <a:latin typeface="Arial" pitchFamily="34" charset="0"/>
-                <a:ea typeface="Arial" pitchFamily="34" charset="-122"/>
-                <a:cs typeface="Arial" pitchFamily="34" charset="-120"/>
-              </a:rPr>
-              <a:t>4</a:t>
-            </a:r>
-            <a:endParaRPr lang="en-US" sz="700" dirty="0"/>
-          </a:p>
-        </p:txBody>
-      </p:sp>
-      <p:sp>
-        <p:nvSpPr>
-          <p:cNvPr id="50" name="Text 48"/>
-          <p:cNvSpPr/>
-          <p:nvPr/>
-        </p:nvSpPr>
-        <p:spPr>
-          <a:xfrm>
-            <a:off x="5669280" y="2377440"/>
-            <a:ext cx="1280160" cy="548640"/>
-          </a:xfrm>
-          <a:prstGeom prst="rect">
-            <a:avLst/>
-          </a:prstGeom>
-          <a:solidFill>
-            <a:srgbClr val="1B8B1B"/>
-          </a:solidFill>
-          <a:ln w="12700">
+      </p:sp>
+      <p:sp>
+        <p:nvSpPr>
+          <p:cNvPr id="47" name="Shape 45"/>
+          <p:cNvSpPr/>
+          <p:nvPr/>
+        </p:nvSpPr>
+        <p:spPr>
+          <a:xfrm>
+            <a:off x="4709160" y="1572768"/>
+            <a:ext cx="0" cy="2980944"/>
+          </a:xfrm>
+          <a:prstGeom prst="line">
+            <a:avLst/>
+          </a:prstGeom>
+          <a:noFill/>
+          <a:ln w="15875">
             <a:solidFill>
               <a:srgbClr val="1B8B1B"/>
             </a:solidFill>
+            <a:prstDash val="solid"/>
           </a:ln>
         </p:spPr>
-        <p:txBody>
-          <a:bodyPr wrap="square" rtlCol="0" anchor="ctr"/>
-          <a:lstStyle/>
-          <a:p>
-            <a:pPr algn="ctr" indent="0" marL="0">
-              <a:buNone/>
-            </a:pPr>
-            <a:r>
-              <a:rPr lang="en-US" sz="750" b="1" dirty="0">
-                <a:solidFill>
-                  <a:srgbClr val="FFFFFF"/>
-                </a:solidFill>
-                <a:latin typeface="Arial" pitchFamily="34" charset="0"/>
-                <a:ea typeface="Arial" pitchFamily="34" charset="-122"/>
-                <a:cs typeface="Arial" pitchFamily="34" charset="-120"/>
-              </a:rPr>
-              <a:t>RCF Anomaly</a:t>
-            </a:r>
-            <a:endParaRPr lang="en-US" sz="750" dirty="0"/>
-          </a:p>
-          <a:p>
-            <a:pPr algn="ctr" indent="0" marL="0">
-              <a:buNone/>
-            </a:pPr>
-            <a:r>
-              <a:rPr lang="en-US" sz="750" b="1" dirty="0">
-                <a:solidFill>
-                  <a:srgbClr val="FFFFFF"/>
-                </a:solidFill>
-                <a:latin typeface="Arial" pitchFamily="34" charset="0"/>
-                <a:ea typeface="Arial" pitchFamily="34" charset="-122"/>
-                <a:cs typeface="Arial" pitchFamily="34" charset="-120"/>
-              </a:rPr>
-              <a:t>Detector</a:t>
-            </a:r>
-            <a:endParaRPr lang="en-US" sz="750" dirty="0"/>
-          </a:p>
-        </p:txBody>
-      </p:sp>
-      <p:sp>
-        <p:nvSpPr>
-          <p:cNvPr id="51" name="Text 49"/>
-          <p:cNvSpPr/>
-          <p:nvPr/>
-        </p:nvSpPr>
-        <p:spPr>
-          <a:xfrm>
-            <a:off x="7040880" y="2468880"/>
-            <a:ext cx="182880" cy="182880"/>
-          </a:xfrm>
-          <a:prstGeom prst="ellipse">
-            <a:avLst/>
-          </a:prstGeom>
-          <a:solidFill>
-            <a:srgbClr val="FF9900"/>
-          </a:solidFill>
-          <a:ln/>
-        </p:spPr>
-        <p:txBody>
-          <a:bodyPr wrap="square" rtlCol="0" anchor="ctr"/>
-          <a:lstStyle/>
-          <a:p>
-            <a:pPr algn="ctr" indent="0" marL="0">
-              <a:buNone/>
-            </a:pPr>
-            <a:r>
-              <a:rPr lang="en-US" sz="700" b="1" dirty="0">
-                <a:solidFill>
-                  <a:srgbClr val="FFFFFF"/>
-                </a:solidFill>
-                <a:latin typeface="Arial" pitchFamily="34" charset="0"/>
-                <a:ea typeface="Arial" pitchFamily="34" charset="-122"/>
-                <a:cs typeface="Arial" pitchFamily="34" charset="-120"/>
-              </a:rPr>
-              <a:t>5</a:t>
-            </a:r>
-            <a:endParaRPr lang="en-US" sz="700" dirty="0"/>
-          </a:p>
-        </p:txBody>
-      </p:sp>
-      <p:sp>
-        <p:nvSpPr>
-          <p:cNvPr id="52" name="Text 50"/>
-          <p:cNvSpPr/>
-          <p:nvPr/>
-        </p:nvSpPr>
-        <p:spPr>
-          <a:xfrm>
-            <a:off x="7132320" y="2377440"/>
-            <a:ext cx="1097280" cy="548640"/>
-          </a:xfrm>
-          <a:prstGeom prst="rect">
-            <a:avLst/>
-          </a:prstGeom>
-          <a:solidFill>
-            <a:srgbClr val="D13212"/>
-          </a:solidFill>
-          <a:ln w="12700">
-            <a:solidFill>
-              <a:srgbClr val="D13212"/>
-            </a:solidFill>
-          </a:ln>
-        </p:spPr>
-        <p:txBody>
-          <a:bodyPr wrap="square" rtlCol="0" anchor="ctr"/>
-          <a:lstStyle/>
-          <a:p>
-            <a:pPr algn="ctr" indent="0" marL="0">
-              <a:buNone/>
-            </a:pPr>
-            <a:r>
-              <a:rPr lang="en-US" sz="700" b="1" dirty="0">
-                <a:solidFill>
-                  <a:srgbClr val="FFFFFF"/>
-                </a:solidFill>
-                <a:latin typeface="Arial" pitchFamily="34" charset="0"/>
-                <a:ea typeface="Arial" pitchFamily="34" charset="-122"/>
-                <a:cs typeface="Arial" pitchFamily="34" charset="-120"/>
-              </a:rPr>
-              <a:t>Alert Rule</a:t>
-            </a:r>
-            <a:endParaRPr lang="en-US" sz="700" dirty="0"/>
-          </a:p>
-          <a:p>
-            <a:pPr algn="ctr" indent="0" marL="0">
-              <a:buNone/>
-            </a:pPr>
-            <a:r>
-              <a:rPr lang="en-US" sz="700" b="1" dirty="0">
-                <a:solidFill>
-                  <a:srgbClr val="FFFFFF"/>
-                </a:solidFill>
-                <a:latin typeface="Arial" pitchFamily="34" charset="0"/>
-                <a:ea typeface="Arial" pitchFamily="34" charset="-122"/>
-                <a:cs typeface="Arial" pitchFamily="34" charset="-120"/>
-              </a:rPr>
-              <a:t>(score &gt; 0.1)</a:t>
-            </a:r>
-            <a:endParaRPr lang="en-US" sz="700" dirty="0"/>
-          </a:p>
-        </p:txBody>
-      </p:sp>
-      <p:sp>
-        <p:nvSpPr>
-          <p:cNvPr id="53" name="Text 51"/>
-          <p:cNvSpPr/>
-          <p:nvPr/>
-        </p:nvSpPr>
-        <p:spPr>
-          <a:xfrm>
-            <a:off x="7772400" y="2971800"/>
-            <a:ext cx="182880" cy="182880"/>
-          </a:xfrm>
-          <a:prstGeom prst="ellipse">
-            <a:avLst/>
-          </a:prstGeom>
-          <a:solidFill>
-            <a:srgbClr val="FF9900"/>
-          </a:solidFill>
-          <a:ln/>
-        </p:spPr>
-        <p:txBody>
-          <a:bodyPr wrap="square" rtlCol="0" anchor="ctr"/>
-          <a:lstStyle/>
-          <a:p>
-            <a:pPr algn="ctr" indent="0" marL="0">
-              <a:buNone/>
-            </a:pPr>
-            <a:r>
-              <a:rPr lang="en-US" sz="700" b="1" dirty="0">
-                <a:solidFill>
-                  <a:srgbClr val="FFFFFF"/>
-                </a:solidFill>
-                <a:latin typeface="Arial" pitchFamily="34" charset="0"/>
-                <a:ea typeface="Arial" pitchFamily="34" charset="-122"/>
-                <a:cs typeface="Arial" pitchFamily="34" charset="-120"/>
-              </a:rPr>
-              <a:t>6</a:t>
-            </a:r>
-            <a:endParaRPr lang="en-US" sz="700" dirty="0"/>
-          </a:p>
-        </p:txBody>
-      </p:sp>
-      <p:sp>
-        <p:nvSpPr>
-          <p:cNvPr id="54" name="Text 52"/>
-          <p:cNvSpPr/>
-          <p:nvPr/>
-        </p:nvSpPr>
-        <p:spPr>
-          <a:xfrm>
-            <a:off x="5669280" y="3200400"/>
-            <a:ext cx="1280160" cy="502920"/>
-          </a:xfrm>
-          <a:prstGeom prst="rect">
-            <a:avLst/>
-          </a:prstGeom>
-          <a:solidFill>
-            <a:srgbClr val="F4E6FF"/>
-          </a:solidFill>
-          <a:ln w="9525">
-            <a:solidFill>
-              <a:srgbClr val="7C3AED"/>
-            </a:solidFill>
-          </a:ln>
-        </p:spPr>
-        <p:txBody>
-          <a:bodyPr wrap="square" rtlCol="0" anchor="ctr"/>
-          <a:lstStyle/>
-          <a:p>
-            <a:pPr algn="ctr" indent="0" marL="0">
-              <a:buNone/>
-            </a:pPr>
-            <a:r>
-              <a:rPr lang="en-US" sz="650" dirty="0">
-                <a:solidFill>
-                  <a:srgbClr val="7C3AED"/>
-                </a:solidFill>
-                <a:latin typeface="Arial" pitchFamily="34" charset="0"/>
-                <a:ea typeface="Arial" pitchFamily="34" charset="-122"/>
-                <a:cs typeface="Arial" pitchFamily="34" charset="-120"/>
-              </a:rPr>
-              <a:t>AWS Lambda</a:t>
-            </a:r>
-            <a:endParaRPr lang="en-US" sz="650" dirty="0"/>
-          </a:p>
-          <a:p>
-            <a:pPr algn="ctr" indent="0" marL="0">
-              <a:buNone/>
-            </a:pPr>
-            <a:r>
-              <a:rPr lang="en-US" sz="650" dirty="0">
-                <a:solidFill>
-                  <a:srgbClr val="7C3AED"/>
-                </a:solidFill>
-                <a:latin typeface="Arial" pitchFamily="34" charset="0"/>
-                <a:ea typeface="Arial" pitchFamily="34" charset="-122"/>
-                <a:cs typeface="Arial" pitchFamily="34" charset="-120"/>
-              </a:rPr>
-              <a:t>(Prometheus MCP)</a:t>
-            </a:r>
-            <a:endParaRPr lang="en-US" sz="650" dirty="0"/>
-          </a:p>
-        </p:txBody>
-      </p:sp>
-      <p:sp>
-        <p:nvSpPr>
-          <p:cNvPr id="55" name="Text 53"/>
-          <p:cNvSpPr/>
-          <p:nvPr/>
-        </p:nvSpPr>
-        <p:spPr>
-          <a:xfrm>
-            <a:off x="7040880" y="3200400"/>
-            <a:ext cx="914400" cy="502920"/>
-          </a:xfrm>
-          <a:prstGeom prst="rect">
-            <a:avLst/>
-          </a:prstGeom>
-          <a:solidFill>
-            <a:srgbClr val="F4E6FF"/>
-          </a:solidFill>
-          <a:ln w="9525">
-            <a:solidFill>
-              <a:srgbClr val="7C3AED"/>
-            </a:solidFill>
-          </a:ln>
-        </p:spPr>
-        <p:txBody>
-          <a:bodyPr wrap="square" rtlCol="0" anchor="ctr"/>
-          <a:lstStyle/>
-          <a:p>
-            <a:pPr algn="ctr" indent="0" marL="0">
-              <a:buNone/>
-            </a:pPr>
-            <a:r>
-              <a:rPr lang="en-US" sz="650" dirty="0">
-                <a:solidFill>
-                  <a:srgbClr val="7C3AED"/>
-                </a:solidFill>
-                <a:latin typeface="Arial" pitchFamily="34" charset="0"/>
-                <a:ea typeface="Arial" pitchFamily="34" charset="-122"/>
-                <a:cs typeface="Arial" pitchFamily="34" charset="-120"/>
-              </a:rPr>
-              <a:t>Amazon</a:t>
-            </a:r>
-            <a:endParaRPr lang="en-US" sz="650" dirty="0"/>
-          </a:p>
-          <a:p>
-            <a:pPr algn="ctr" indent="0" marL="0">
-              <a:buNone/>
-            </a:pPr>
-            <a:r>
-              <a:rPr lang="en-US" sz="650" dirty="0">
-                <a:solidFill>
-                  <a:srgbClr val="7C3AED"/>
-                </a:solidFill>
-                <a:latin typeface="Arial" pitchFamily="34" charset="0"/>
-                <a:ea typeface="Arial" pitchFamily="34" charset="-122"/>
-                <a:cs typeface="Arial" pitchFamily="34" charset="-120"/>
-              </a:rPr>
-              <a:t>API Gateway</a:t>
-            </a:r>
-            <a:endParaRPr lang="en-US" sz="650" dirty="0"/>
-          </a:p>
-        </p:txBody>
-      </p:sp>
-      <p:sp>
-        <p:nvSpPr>
-          <p:cNvPr id="56" name="Text 54"/>
-          <p:cNvSpPr/>
-          <p:nvPr/>
-        </p:nvSpPr>
-        <p:spPr>
-          <a:xfrm>
-            <a:off x="8046720" y="3200400"/>
-            <a:ext cx="731520" cy="502920"/>
-          </a:xfrm>
-          <a:prstGeom prst="rect">
-            <a:avLst/>
-          </a:prstGeom>
-          <a:solidFill>
-            <a:srgbClr val="F4E6FF"/>
-          </a:solidFill>
-          <a:ln w="9525">
-            <a:solidFill>
-              <a:srgbClr val="7C3AED"/>
-            </a:solidFill>
-          </a:ln>
-        </p:spPr>
-        <p:txBody>
-          <a:bodyPr wrap="square" rtlCol="0" anchor="ctr"/>
-          <a:lstStyle/>
-          <a:p>
-            <a:pPr algn="ctr" indent="0" marL="0">
-              <a:buNone/>
-            </a:pPr>
-            <a:r>
-              <a:rPr lang="en-US" sz="650" dirty="0">
-                <a:solidFill>
-                  <a:srgbClr val="7C3AED"/>
-                </a:solidFill>
-                <a:latin typeface="Arial" pitchFamily="34" charset="0"/>
-                <a:ea typeface="Arial" pitchFamily="34" charset="-122"/>
-                <a:cs typeface="Arial" pitchFamily="34" charset="-120"/>
-              </a:rPr>
-              <a:t>Amazon</a:t>
-            </a:r>
-            <a:endParaRPr lang="en-US" sz="650" dirty="0"/>
-          </a:p>
-          <a:p>
-            <a:pPr algn="ctr" indent="0" marL="0">
-              <a:buNone/>
-            </a:pPr>
-            <a:r>
-              <a:rPr lang="en-US" sz="650" dirty="0">
-                <a:solidFill>
-                  <a:srgbClr val="7C3AED"/>
-                </a:solidFill>
-                <a:latin typeface="Arial" pitchFamily="34" charset="0"/>
-                <a:ea typeface="Arial" pitchFamily="34" charset="-122"/>
-                <a:cs typeface="Arial" pitchFamily="34" charset="-120"/>
-              </a:rPr>
-              <a:t>Cognito</a:t>
-            </a:r>
-            <a:endParaRPr lang="en-US" sz="650" dirty="0"/>
-          </a:p>
-        </p:txBody>
-      </p:sp>
-      <p:sp>
-        <p:nvSpPr>
-          <p:cNvPr id="57" name="Text 55"/>
-          <p:cNvSpPr/>
-          <p:nvPr/>
-        </p:nvSpPr>
-        <p:spPr>
-          <a:xfrm>
-            <a:off x="8046720" y="3749040"/>
-            <a:ext cx="182880" cy="182880"/>
-          </a:xfrm>
-          <a:prstGeom prst="ellipse">
-            <a:avLst/>
-          </a:prstGeom>
-          <a:solidFill>
-            <a:srgbClr val="FF9900"/>
-          </a:solidFill>
-          <a:ln/>
-        </p:spPr>
-        <p:txBody>
-          <a:bodyPr wrap="square" rtlCol="0" anchor="ctr"/>
-          <a:lstStyle/>
-          <a:p>
-            <a:pPr algn="ctr" indent="0" marL="0">
-              <a:buNone/>
-            </a:pPr>
-            <a:r>
-              <a:rPr lang="en-US" sz="700" b="1" dirty="0">
-                <a:solidFill>
-                  <a:srgbClr val="FFFFFF"/>
-                </a:solidFill>
-                <a:latin typeface="Arial" pitchFamily="34" charset="0"/>
-                <a:ea typeface="Arial" pitchFamily="34" charset="-122"/>
-                <a:cs typeface="Arial" pitchFamily="34" charset="-120"/>
-              </a:rPr>
-              <a:t>7</a:t>
-            </a:r>
-            <a:endParaRPr lang="en-US" sz="700" dirty="0"/>
-          </a:p>
-        </p:txBody>
-      </p:sp>
-      <p:sp>
-        <p:nvSpPr>
-          <p:cNvPr id="58" name="Text 56"/>
-          <p:cNvSpPr/>
-          <p:nvPr/>
-        </p:nvSpPr>
-        <p:spPr>
-          <a:xfrm>
-            <a:off x="5669280" y="3931920"/>
-            <a:ext cx="1280160" cy="502920"/>
-          </a:xfrm>
-          <a:prstGeom prst="rect">
-            <a:avLst/>
-          </a:prstGeom>
-          <a:solidFill>
-            <a:srgbClr val="E8F4FD"/>
-          </a:solidFill>
-          <a:ln w="9525">
-            <a:solidFill>
-              <a:srgbClr val="0972D3"/>
-            </a:solidFill>
-          </a:ln>
-        </p:spPr>
-        <p:txBody>
-          <a:bodyPr wrap="square" rtlCol="0" anchor="ctr"/>
-          <a:lstStyle/>
-          <a:p>
-            <a:pPr algn="ctr" indent="0" marL="0">
-              <a:buNone/>
-            </a:pPr>
-            <a:r>
-              <a:rPr lang="en-US" sz="650" dirty="0">
-                <a:solidFill>
-                  <a:srgbClr val="0972D3"/>
-                </a:solidFill>
-                <a:latin typeface="Arial" pitchFamily="34" charset="0"/>
-                <a:ea typeface="Arial" pitchFamily="34" charset="-122"/>
-                <a:cs typeface="Arial" pitchFamily="34" charset="-120"/>
-              </a:rPr>
-              <a:t>Amazon SageMaker</a:t>
-            </a:r>
-            <a:endParaRPr lang="en-US" sz="650" dirty="0"/>
-          </a:p>
-          <a:p>
-            <a:pPr algn="ctr" indent="0" marL="0">
-              <a:buNone/>
-            </a:pPr>
-            <a:r>
-              <a:rPr lang="en-US" sz="650" dirty="0">
-                <a:solidFill>
-                  <a:srgbClr val="0972D3"/>
-                </a:solidFill>
-                <a:latin typeface="Arial" pitchFamily="34" charset="0"/>
-                <a:ea typeface="Arial" pitchFamily="34" charset="-122"/>
-                <a:cs typeface="Arial" pitchFamily="34" charset="-120"/>
-              </a:rPr>
-              <a:t>Notebook</a:t>
-            </a:r>
-            <a:endParaRPr lang="en-US" sz="650" dirty="0"/>
-          </a:p>
-        </p:txBody>
-      </p:sp>
-      <p:sp>
-        <p:nvSpPr>
-          <p:cNvPr id="59" name="Text 57"/>
-          <p:cNvSpPr/>
-          <p:nvPr/>
-        </p:nvSpPr>
-        <p:spPr>
-          <a:xfrm>
-            <a:off x="7040880" y="3931920"/>
-            <a:ext cx="1097280" cy="502920"/>
-          </a:xfrm>
-          <a:prstGeom prst="rect">
-            <a:avLst/>
-          </a:prstGeom>
-          <a:solidFill>
-            <a:srgbClr val="E8F4FD"/>
-          </a:solidFill>
-          <a:ln w="9525">
-            <a:solidFill>
-              <a:srgbClr val="0972D3"/>
-            </a:solidFill>
-          </a:ln>
-        </p:spPr>
-        <p:txBody>
-          <a:bodyPr wrap="square" rtlCol="0" anchor="ctr"/>
-          <a:lstStyle/>
-          <a:p>
-            <a:pPr algn="ctr" indent="0" marL="0">
-              <a:buNone/>
-            </a:pPr>
-            <a:r>
-              <a:rPr lang="en-US" sz="650" dirty="0">
-                <a:solidFill>
-                  <a:srgbClr val="0972D3"/>
-                </a:solidFill>
-                <a:latin typeface="Arial" pitchFamily="34" charset="0"/>
-                <a:ea typeface="Arial" pitchFamily="34" charset="-122"/>
-                <a:cs typeface="Arial" pitchFamily="34" charset="-120"/>
-              </a:rPr>
-              <a:t>DevOps Agent</a:t>
-            </a:r>
-            <a:endParaRPr lang="en-US" sz="650" dirty="0"/>
-          </a:p>
-          <a:p>
-            <a:pPr algn="ctr" indent="0" marL="0">
-              <a:buNone/>
-            </a:pPr>
-            <a:r>
-              <a:rPr lang="en-US" sz="650" dirty="0">
-                <a:solidFill>
-                  <a:srgbClr val="0972D3"/>
-                </a:solidFill>
-                <a:latin typeface="Arial" pitchFamily="34" charset="0"/>
-                <a:ea typeface="Arial" pitchFamily="34" charset="-122"/>
-                <a:cs typeface="Arial" pitchFamily="34" charset="-120"/>
-              </a:rPr>
-              <a:t>(MCP Client)</a:t>
-            </a:r>
-            <a:endParaRPr lang="en-US" sz="650" dirty="0"/>
-          </a:p>
-        </p:txBody>
-      </p:sp>
-      <p:sp>
-        <p:nvSpPr>
-          <p:cNvPr id="60" name="Text 58"/>
-          <p:cNvSpPr/>
-          <p:nvPr/>
-        </p:nvSpPr>
-        <p:spPr>
-          <a:xfrm>
-            <a:off x="8229600" y="4023360"/>
-            <a:ext cx="182880" cy="182880"/>
-          </a:xfrm>
-          <a:prstGeom prst="ellipse">
-            <a:avLst/>
-          </a:prstGeom>
-          <a:solidFill>
-            <a:srgbClr val="FF9900"/>
-          </a:solidFill>
-          <a:ln/>
-        </p:spPr>
-        <p:txBody>
-          <a:bodyPr wrap="square" rtlCol="0" anchor="ctr"/>
-          <a:lstStyle/>
-          <a:p>
-            <a:pPr algn="ctr" indent="0" marL="0">
-              <a:buNone/>
-            </a:pPr>
-            <a:r>
-              <a:rPr lang="en-US" sz="700" b="1" dirty="0">
-                <a:solidFill>
-                  <a:srgbClr val="FFFFFF"/>
-                </a:solidFill>
-                <a:latin typeface="Arial" pitchFamily="34" charset="0"/>
-                <a:ea typeface="Arial" pitchFamily="34" charset="-122"/>
-                <a:cs typeface="Arial" pitchFamily="34" charset="-120"/>
-              </a:rPr>
-              <a:t>8</a:t>
-            </a:r>
-            <a:endParaRPr lang="en-US" sz="700" dirty="0"/>
-          </a:p>
-        </p:txBody>
-      </p:sp>
-      <p:sp>
-        <p:nvSpPr>
-          <p:cNvPr id="61" name="Text 59"/>
-          <p:cNvSpPr/>
-          <p:nvPr/>
-        </p:nvSpPr>
-        <p:spPr>
-          <a:xfrm>
-            <a:off x="3108960" y="4251960"/>
-            <a:ext cx="1371600" cy="502920"/>
-          </a:xfrm>
-          <a:prstGeom prst="rect">
-            <a:avLst/>
-          </a:prstGeom>
-          <a:solidFill>
-            <a:srgbClr val="D13212"/>
-          </a:solidFill>
-          <a:ln w="9525">
-            <a:solidFill>
-              <a:srgbClr val="D13212"/>
-            </a:solidFill>
-          </a:ln>
-        </p:spPr>
-        <p:txBody>
-          <a:bodyPr wrap="square" rtlCol="0" anchor="ctr"/>
-          <a:lstStyle/>
-          <a:p>
-            <a:pPr algn="ctr" indent="0" marL="0">
-              <a:buNone/>
-            </a:pPr>
-            <a:r>
-              <a:rPr lang="en-US" sz="650" dirty="0">
-                <a:solidFill>
-                  <a:srgbClr val="FFFFFF"/>
-                </a:solidFill>
-                <a:latin typeface="Arial" pitchFamily="34" charset="0"/>
-                <a:ea typeface="Arial" pitchFamily="34" charset="-122"/>
-                <a:cs typeface="Arial" pitchFamily="34" charset="-120"/>
-              </a:rPr>
-              <a:t>⚠ Fault Injection</a:t>
-            </a:r>
-            <a:endParaRPr lang="en-US" sz="650" dirty="0"/>
-          </a:p>
-          <a:p>
-            <a:pPr algn="ctr" indent="0" marL="0">
-              <a:buNone/>
-            </a:pPr>
-            <a:r>
-              <a:rPr lang="en-US" sz="650" dirty="0">
-                <a:solidFill>
-                  <a:srgbClr val="FFFFFF"/>
-                </a:solidFill>
-                <a:latin typeface="Arial" pitchFamily="34" charset="0"/>
-                <a:ea typeface="Arial" pitchFamily="34" charset="-122"/>
-                <a:cs typeface="Arial" pitchFamily="34" charset="-120"/>
-              </a:rPr>
-              <a:t>(Bad Config Push)</a:t>
-            </a:r>
-            <a:endParaRPr lang="en-US" sz="650" dirty="0"/>
-          </a:p>
-        </p:txBody>
-      </p:sp>
-      <p:sp>
-        <p:nvSpPr>
-          <p:cNvPr id="62" name="Shape 60"/>
-          <p:cNvSpPr/>
-          <p:nvPr/>
-        </p:nvSpPr>
-        <p:spPr>
-          <a:xfrm>
-            <a:off x="2194560" y="4480560"/>
-            <a:ext cx="3931920" cy="0"/>
+      </p:sp>
+      <p:sp>
+        <p:nvSpPr>
+          <p:cNvPr id="48" name="Shape 46"/>
+          <p:cNvSpPr/>
+          <p:nvPr/>
+        </p:nvSpPr>
+        <p:spPr>
+          <a:xfrm>
+            <a:off x="4709160" y="1572768"/>
+            <a:ext cx="137160" cy="0"/>
           </a:xfrm>
           <a:prstGeom prst="line">
             <a:avLst/>
@@ -3604,14 +2759,14 @@
       </p:sp>
       <p:sp>
         <p:nvSpPr>
-          <p:cNvPr id="63" name="Text 61"/>
-          <p:cNvSpPr/>
-          <p:nvPr/>
-        </p:nvSpPr>
-        <p:spPr>
-          <a:xfrm>
-            <a:off x="2834640" y="4206240"/>
-            <a:ext cx="1828800" cy="182880"/>
+          <p:cNvPr id="49" name="Text 47"/>
+          <p:cNvSpPr/>
+          <p:nvPr/>
+        </p:nvSpPr>
+        <p:spPr>
+          <a:xfrm>
+            <a:off x="4754880" y="3200400"/>
+            <a:ext cx="822960" cy="365760"/>
           </a:xfrm>
           <a:prstGeom prst="rect">
             <a:avLst/>
@@ -3627,7 +2782,7 @@
               <a:buNone/>
             </a:pPr>
             <a:r>
-              <a:rPr lang="en-US" sz="600" dirty="0">
+              <a:rPr lang="en-US" sz="700" i="1" dirty="0">
                 <a:solidFill>
                   <a:srgbClr val="1B8B1B"/>
                 </a:solidFill>
@@ -3635,22 +2790,852 @@
                 <a:ea typeface="Arial" pitchFamily="34" charset="-122"/>
                 <a:cs typeface="Arial" pitchFamily="34" charset="-120"/>
               </a:rPr>
-              <a:t>remote_write (SigV4/IRSA)</a:t>
-            </a:r>
-            <a:endParaRPr lang="en-US" sz="600" dirty="0"/>
-          </a:p>
-        </p:txBody>
-      </p:sp>
-      <p:sp>
-        <p:nvSpPr>
-          <p:cNvPr id="64" name="Text 62"/>
-          <p:cNvSpPr/>
-          <p:nvPr/>
-        </p:nvSpPr>
-        <p:spPr>
-          <a:xfrm>
-            <a:off x="274320" y="6492240"/>
-            <a:ext cx="9144000" cy="228600"/>
+              <a:t>remote_write</a:t>
+            </a:r>
+            <a:endParaRPr lang="en-US" sz="700" dirty="0"/>
+          </a:p>
+          <a:p>
+            <a:pPr indent="0" marL="0">
+              <a:buNone/>
+            </a:pPr>
+            <a:r>
+              <a:rPr lang="en-US" sz="700" i="1" dirty="0">
+                <a:solidFill>
+                  <a:srgbClr val="1B8B1B"/>
+                </a:solidFill>
+                <a:latin typeface="Arial" pitchFamily="34" charset="0"/>
+                <a:ea typeface="Arial" pitchFamily="34" charset="-122"/>
+                <a:cs typeface="Arial" pitchFamily="34" charset="-120"/>
+              </a:rPr>
+              <a:t>(SigV4/IRSA)</a:t>
+            </a:r>
+            <a:endParaRPr lang="en-US" sz="700" dirty="0"/>
+          </a:p>
+        </p:txBody>
+      </p:sp>
+      <p:sp>
+        <p:nvSpPr>
+          <p:cNvPr id="50" name="Text 48"/>
+          <p:cNvSpPr/>
+          <p:nvPr/>
+        </p:nvSpPr>
+        <p:spPr>
+          <a:xfrm>
+            <a:off x="4617720" y="2743200"/>
+            <a:ext cx="182880" cy="182880"/>
+          </a:xfrm>
+          <a:prstGeom prst="ellipse">
+            <a:avLst/>
+          </a:prstGeom>
+          <a:solidFill>
+            <a:srgbClr val="FF9900"/>
+          </a:solidFill>
+          <a:ln/>
+        </p:spPr>
+        <p:txBody>
+          <a:bodyPr wrap="square" rtlCol="0" anchor="ctr"/>
+          <a:lstStyle/>
+          <a:p>
+            <a:pPr algn="ctr" indent="0" marL="0">
+              <a:buNone/>
+            </a:pPr>
+            <a:r>
+              <a:rPr lang="en-US" sz="800" b="1" dirty="0">
+                <a:solidFill>
+                  <a:srgbClr val="FFFFFF"/>
+                </a:solidFill>
+                <a:latin typeface="Arial" pitchFamily="34" charset="0"/>
+                <a:ea typeface="Arial" pitchFamily="34" charset="-122"/>
+                <a:cs typeface="Arial" pitchFamily="34" charset="-120"/>
+              </a:rPr>
+              <a:t>4</a:t>
+            </a:r>
+            <a:endParaRPr lang="en-US" sz="800" dirty="0"/>
+          </a:p>
+        </p:txBody>
+      </p:sp>
+      <p:sp>
+        <p:nvSpPr>
+          <p:cNvPr id="51" name="Text 49"/>
+          <p:cNvSpPr/>
+          <p:nvPr/>
+        </p:nvSpPr>
+        <p:spPr>
+          <a:xfrm>
+            <a:off x="5029200" y="1234440"/>
+            <a:ext cx="2560320" cy="685800"/>
+          </a:xfrm>
+          <a:prstGeom prst="rect">
+            <a:avLst/>
+          </a:prstGeom>
+          <a:solidFill>
+            <a:srgbClr val="C8E8C8"/>
+          </a:solidFill>
+          <a:ln w="12700">
+            <a:solidFill>
+              <a:srgbClr val="1B8B1B"/>
+            </a:solidFill>
+          </a:ln>
+        </p:spPr>
+        <p:txBody>
+          <a:bodyPr wrap="square" rtlCol="0" anchor="ctr"/>
+          <a:lstStyle/>
+          <a:p>
+            <a:pPr algn="ctr" indent="0" marL="0">
+              <a:buNone/>
+            </a:pPr>
+            <a:r>
+              <a:rPr lang="en-US" sz="1000" b="1" dirty="0">
+                <a:solidFill>
+                  <a:srgbClr val="1B8B1B"/>
+                </a:solidFill>
+                <a:latin typeface="Arial" pitchFamily="34" charset="0"/>
+                <a:ea typeface="Arial" pitchFamily="34" charset="-122"/>
+                <a:cs typeface="Arial" pitchFamily="34" charset="-120"/>
+              </a:rPr>
+              <a:t>Amazon Managed</a:t>
+            </a:r>
+            <a:endParaRPr lang="en-US" sz="1000" dirty="0"/>
+          </a:p>
+          <a:p>
+            <a:pPr algn="ctr" indent="0" marL="0">
+              <a:buNone/>
+            </a:pPr>
+            <a:r>
+              <a:rPr lang="en-US" sz="1000" b="1" dirty="0">
+                <a:solidFill>
+                  <a:srgbClr val="1B8B1B"/>
+                </a:solidFill>
+                <a:latin typeface="Arial" pitchFamily="34" charset="0"/>
+                <a:ea typeface="Arial" pitchFamily="34" charset="-122"/>
+                <a:cs typeface="Arial" pitchFamily="34" charset="-120"/>
+              </a:rPr>
+              <a:t>Service for Prometheus</a:t>
+            </a:r>
+            <a:endParaRPr lang="en-US" sz="1000" dirty="0"/>
+          </a:p>
+        </p:txBody>
+      </p:sp>
+      <p:sp>
+        <p:nvSpPr>
+          <p:cNvPr id="52" name="Text 50"/>
+          <p:cNvSpPr/>
+          <p:nvPr/>
+        </p:nvSpPr>
+        <p:spPr>
+          <a:xfrm>
+            <a:off x="5029200" y="2103120"/>
+            <a:ext cx="1188720" cy="548640"/>
+          </a:xfrm>
+          <a:prstGeom prst="rect">
+            <a:avLst/>
+          </a:prstGeom>
+          <a:solidFill>
+            <a:srgbClr val="2E7D32"/>
+          </a:solidFill>
+          <a:ln/>
+        </p:spPr>
+        <p:txBody>
+          <a:bodyPr wrap="square" rtlCol="0" anchor="ctr"/>
+          <a:lstStyle/>
+          <a:p>
+            <a:pPr algn="ctr" indent="0" marL="0">
+              <a:buNone/>
+            </a:pPr>
+            <a:r>
+              <a:rPr lang="en-US" sz="900" b="1" dirty="0">
+                <a:solidFill>
+                  <a:srgbClr val="FFFFFF"/>
+                </a:solidFill>
+                <a:latin typeface="Arial" pitchFamily="34" charset="0"/>
+                <a:ea typeface="Arial" pitchFamily="34" charset="-122"/>
+                <a:cs typeface="Arial" pitchFamily="34" charset="-120"/>
+              </a:rPr>
+              <a:t>RCF Anomaly</a:t>
+            </a:r>
+            <a:endParaRPr lang="en-US" sz="900" dirty="0"/>
+          </a:p>
+          <a:p>
+            <a:pPr algn="ctr" indent="0" marL="0">
+              <a:buNone/>
+            </a:pPr>
+            <a:r>
+              <a:rPr lang="en-US" sz="900" b="1" dirty="0">
+                <a:solidFill>
+                  <a:srgbClr val="FFFFFF"/>
+                </a:solidFill>
+                <a:latin typeface="Arial" pitchFamily="34" charset="0"/>
+                <a:ea typeface="Arial" pitchFamily="34" charset="-122"/>
+                <a:cs typeface="Arial" pitchFamily="34" charset="-120"/>
+              </a:rPr>
+              <a:t>Detector</a:t>
+            </a:r>
+            <a:endParaRPr lang="en-US" sz="900" dirty="0"/>
+          </a:p>
+        </p:txBody>
+      </p:sp>
+      <p:sp>
+        <p:nvSpPr>
+          <p:cNvPr id="53" name="Text 51"/>
+          <p:cNvSpPr/>
+          <p:nvPr/>
+        </p:nvSpPr>
+        <p:spPr>
+          <a:xfrm>
+            <a:off x="6355080" y="2103120"/>
+            <a:ext cx="1188720" cy="548640"/>
+          </a:xfrm>
+          <a:prstGeom prst="rect">
+            <a:avLst/>
+          </a:prstGeom>
+          <a:solidFill>
+            <a:srgbClr val="D13212"/>
+          </a:solidFill>
+          <a:ln/>
+        </p:spPr>
+        <p:txBody>
+          <a:bodyPr wrap="square" rtlCol="0" anchor="ctr"/>
+          <a:lstStyle/>
+          <a:p>
+            <a:pPr algn="ctr" indent="0" marL="0">
+              <a:buNone/>
+            </a:pPr>
+            <a:r>
+              <a:rPr lang="en-US" sz="900" b="1" dirty="0">
+                <a:solidFill>
+                  <a:srgbClr val="FFFFFF"/>
+                </a:solidFill>
+                <a:latin typeface="Arial" pitchFamily="34" charset="0"/>
+                <a:ea typeface="Arial" pitchFamily="34" charset="-122"/>
+                <a:cs typeface="Arial" pitchFamily="34" charset="-120"/>
+              </a:rPr>
+              <a:t>Alert Rule</a:t>
+            </a:r>
+            <a:endParaRPr lang="en-US" sz="900" dirty="0"/>
+          </a:p>
+          <a:p>
+            <a:pPr algn="ctr" indent="0" marL="0">
+              <a:buNone/>
+            </a:pPr>
+            <a:r>
+              <a:rPr lang="en-US" sz="900" b="1" dirty="0">
+                <a:solidFill>
+                  <a:srgbClr val="FFFFFF"/>
+                </a:solidFill>
+                <a:latin typeface="Arial" pitchFamily="34" charset="0"/>
+                <a:ea typeface="Arial" pitchFamily="34" charset="-122"/>
+                <a:cs typeface="Arial" pitchFamily="34" charset="-120"/>
+              </a:rPr>
+              <a:t>score &gt; 0.1</a:t>
+            </a:r>
+            <a:endParaRPr lang="en-US" sz="900" dirty="0"/>
+          </a:p>
+        </p:txBody>
+      </p:sp>
+      <p:sp>
+        <p:nvSpPr>
+          <p:cNvPr id="54" name="Text 52"/>
+          <p:cNvSpPr/>
+          <p:nvPr/>
+        </p:nvSpPr>
+        <p:spPr>
+          <a:xfrm>
+            <a:off x="6080760" y="2148840"/>
+            <a:ext cx="182880" cy="182880"/>
+          </a:xfrm>
+          <a:prstGeom prst="ellipse">
+            <a:avLst/>
+          </a:prstGeom>
+          <a:solidFill>
+            <a:srgbClr val="FF9900"/>
+          </a:solidFill>
+          <a:ln/>
+        </p:spPr>
+        <p:txBody>
+          <a:bodyPr wrap="square" rtlCol="0" anchor="ctr"/>
+          <a:lstStyle/>
+          <a:p>
+            <a:pPr algn="ctr" indent="0" marL="0">
+              <a:buNone/>
+            </a:pPr>
+            <a:r>
+              <a:rPr lang="en-US" sz="800" b="1" dirty="0">
+                <a:solidFill>
+                  <a:srgbClr val="FFFFFF"/>
+                </a:solidFill>
+                <a:latin typeface="Arial" pitchFamily="34" charset="0"/>
+                <a:ea typeface="Arial" pitchFamily="34" charset="-122"/>
+                <a:cs typeface="Arial" pitchFamily="34" charset="-120"/>
+              </a:rPr>
+              <a:t>5</a:t>
+            </a:r>
+            <a:endParaRPr lang="en-US" sz="800" dirty="0"/>
+          </a:p>
+        </p:txBody>
+      </p:sp>
+      <p:sp>
+        <p:nvSpPr>
+          <p:cNvPr id="55" name="Text 53"/>
+          <p:cNvSpPr/>
+          <p:nvPr/>
+        </p:nvSpPr>
+        <p:spPr>
+          <a:xfrm>
+            <a:off x="7360920" y="2148840"/>
+            <a:ext cx="182880" cy="182880"/>
+          </a:xfrm>
+          <a:prstGeom prst="ellipse">
+            <a:avLst/>
+          </a:prstGeom>
+          <a:solidFill>
+            <a:srgbClr val="FF9900"/>
+          </a:solidFill>
+          <a:ln/>
+        </p:spPr>
+        <p:txBody>
+          <a:bodyPr wrap="square" rtlCol="0" anchor="ctr"/>
+          <a:lstStyle/>
+          <a:p>
+            <a:pPr algn="ctr" indent="0" marL="0">
+              <a:buNone/>
+            </a:pPr>
+            <a:r>
+              <a:rPr lang="en-US" sz="800" b="1" dirty="0">
+                <a:solidFill>
+                  <a:srgbClr val="FFFFFF"/>
+                </a:solidFill>
+                <a:latin typeface="Arial" pitchFamily="34" charset="0"/>
+                <a:ea typeface="Arial" pitchFamily="34" charset="-122"/>
+                <a:cs typeface="Arial" pitchFamily="34" charset="-120"/>
+              </a:rPr>
+              <a:t>6</a:t>
+            </a:r>
+            <a:endParaRPr lang="en-US" sz="800" dirty="0"/>
+          </a:p>
+        </p:txBody>
+      </p:sp>
+      <p:sp>
+        <p:nvSpPr>
+          <p:cNvPr id="56" name="Text 54"/>
+          <p:cNvSpPr/>
+          <p:nvPr/>
+        </p:nvSpPr>
+        <p:spPr>
+          <a:xfrm>
+            <a:off x="5029200" y="2834640"/>
+            <a:ext cx="1051560" cy="502920"/>
+          </a:xfrm>
+          <a:prstGeom prst="rect">
+            <a:avLst/>
+          </a:prstGeom>
+          <a:solidFill>
+            <a:srgbClr val="F0E6FF"/>
+          </a:solidFill>
+          <a:ln w="6350">
+            <a:solidFill>
+              <a:srgbClr val="7C3AED"/>
+            </a:solidFill>
+          </a:ln>
+        </p:spPr>
+        <p:txBody>
+          <a:bodyPr wrap="square" rtlCol="0" anchor="ctr"/>
+          <a:lstStyle/>
+          <a:p>
+            <a:pPr algn="ctr" indent="0" marL="0">
+              <a:buNone/>
+            </a:pPr>
+            <a:r>
+              <a:rPr lang="en-US" sz="750" dirty="0">
+                <a:solidFill>
+                  <a:srgbClr val="7C3AED"/>
+                </a:solidFill>
+                <a:latin typeface="Arial" pitchFamily="34" charset="0"/>
+                <a:ea typeface="Arial" pitchFamily="34" charset="-122"/>
+                <a:cs typeface="Arial" pitchFamily="34" charset="-120"/>
+              </a:rPr>
+              <a:t>AWS Lambda</a:t>
+            </a:r>
+            <a:endParaRPr lang="en-US" sz="750" dirty="0"/>
+          </a:p>
+          <a:p>
+            <a:pPr algn="ctr" indent="0" marL="0">
+              <a:buNone/>
+            </a:pPr>
+            <a:r>
+              <a:rPr lang="en-US" sz="750" dirty="0">
+                <a:solidFill>
+                  <a:srgbClr val="7C3AED"/>
+                </a:solidFill>
+                <a:latin typeface="Arial" pitchFamily="34" charset="0"/>
+                <a:ea typeface="Arial" pitchFamily="34" charset="-122"/>
+                <a:cs typeface="Arial" pitchFamily="34" charset="-120"/>
+              </a:rPr>
+              <a:t>(Prometheus MCP)</a:t>
+            </a:r>
+            <a:endParaRPr lang="en-US" sz="750" dirty="0"/>
+          </a:p>
+        </p:txBody>
+      </p:sp>
+      <p:sp>
+        <p:nvSpPr>
+          <p:cNvPr id="57" name="Text 55"/>
+          <p:cNvSpPr/>
+          <p:nvPr/>
+        </p:nvSpPr>
+        <p:spPr>
+          <a:xfrm>
+            <a:off x="6126480" y="2834640"/>
+            <a:ext cx="822960" cy="502920"/>
+          </a:xfrm>
+          <a:prstGeom prst="rect">
+            <a:avLst/>
+          </a:prstGeom>
+          <a:solidFill>
+            <a:srgbClr val="F0E6FF"/>
+          </a:solidFill>
+          <a:ln w="6350">
+            <a:solidFill>
+              <a:srgbClr val="7C3AED"/>
+            </a:solidFill>
+          </a:ln>
+        </p:spPr>
+        <p:txBody>
+          <a:bodyPr wrap="square" rtlCol="0" anchor="ctr"/>
+          <a:lstStyle/>
+          <a:p>
+            <a:pPr algn="ctr" indent="0" marL="0">
+              <a:buNone/>
+            </a:pPr>
+            <a:r>
+              <a:rPr lang="en-US" sz="750" dirty="0">
+                <a:solidFill>
+                  <a:srgbClr val="7C3AED"/>
+                </a:solidFill>
+                <a:latin typeface="Arial" pitchFamily="34" charset="0"/>
+                <a:ea typeface="Arial" pitchFamily="34" charset="-122"/>
+                <a:cs typeface="Arial" pitchFamily="34" charset="-120"/>
+              </a:rPr>
+              <a:t>Amazon</a:t>
+            </a:r>
+            <a:endParaRPr lang="en-US" sz="750" dirty="0"/>
+          </a:p>
+          <a:p>
+            <a:pPr algn="ctr" indent="0" marL="0">
+              <a:buNone/>
+            </a:pPr>
+            <a:r>
+              <a:rPr lang="en-US" sz="750" dirty="0">
+                <a:solidFill>
+                  <a:srgbClr val="7C3AED"/>
+                </a:solidFill>
+                <a:latin typeface="Arial" pitchFamily="34" charset="0"/>
+                <a:ea typeface="Arial" pitchFamily="34" charset="-122"/>
+                <a:cs typeface="Arial" pitchFamily="34" charset="-120"/>
+              </a:rPr>
+              <a:t>API Gateway</a:t>
+            </a:r>
+            <a:endParaRPr lang="en-US" sz="750" dirty="0"/>
+          </a:p>
+        </p:txBody>
+      </p:sp>
+      <p:sp>
+        <p:nvSpPr>
+          <p:cNvPr id="58" name="Text 56"/>
+          <p:cNvSpPr/>
+          <p:nvPr/>
+        </p:nvSpPr>
+        <p:spPr>
+          <a:xfrm>
+            <a:off x="6995160" y="2834640"/>
+            <a:ext cx="594360" cy="502920"/>
+          </a:xfrm>
+          <a:prstGeom prst="rect">
+            <a:avLst/>
+          </a:prstGeom>
+          <a:solidFill>
+            <a:srgbClr val="F0E6FF"/>
+          </a:solidFill>
+          <a:ln w="6350">
+            <a:solidFill>
+              <a:srgbClr val="7C3AED"/>
+            </a:solidFill>
+          </a:ln>
+        </p:spPr>
+        <p:txBody>
+          <a:bodyPr wrap="square" rtlCol="0" anchor="ctr"/>
+          <a:lstStyle/>
+          <a:p>
+            <a:pPr algn="ctr" indent="0" marL="0">
+              <a:buNone/>
+            </a:pPr>
+            <a:r>
+              <a:rPr lang="en-US" sz="750" dirty="0">
+                <a:solidFill>
+                  <a:srgbClr val="7C3AED"/>
+                </a:solidFill>
+                <a:latin typeface="Arial" pitchFamily="34" charset="0"/>
+                <a:ea typeface="Arial" pitchFamily="34" charset="-122"/>
+                <a:cs typeface="Arial" pitchFamily="34" charset="-120"/>
+              </a:rPr>
+              <a:t>Amazon</a:t>
+            </a:r>
+            <a:endParaRPr lang="en-US" sz="750" dirty="0"/>
+          </a:p>
+          <a:p>
+            <a:pPr algn="ctr" indent="0" marL="0">
+              <a:buNone/>
+            </a:pPr>
+            <a:r>
+              <a:rPr lang="en-US" sz="750" dirty="0">
+                <a:solidFill>
+                  <a:srgbClr val="7C3AED"/>
+                </a:solidFill>
+                <a:latin typeface="Arial" pitchFamily="34" charset="0"/>
+                <a:ea typeface="Arial" pitchFamily="34" charset="-122"/>
+                <a:cs typeface="Arial" pitchFamily="34" charset="-120"/>
+              </a:rPr>
+              <a:t>Cognito</a:t>
+            </a:r>
+            <a:endParaRPr lang="en-US" sz="750" dirty="0"/>
+          </a:p>
+        </p:txBody>
+      </p:sp>
+      <p:sp>
+        <p:nvSpPr>
+          <p:cNvPr id="59" name="Text 57"/>
+          <p:cNvSpPr/>
+          <p:nvPr/>
+        </p:nvSpPr>
+        <p:spPr>
+          <a:xfrm>
+            <a:off x="7360920" y="3154680"/>
+            <a:ext cx="182880" cy="182880"/>
+          </a:xfrm>
+          <a:prstGeom prst="ellipse">
+            <a:avLst/>
+          </a:prstGeom>
+          <a:solidFill>
+            <a:srgbClr val="FF9900"/>
+          </a:solidFill>
+          <a:ln/>
+        </p:spPr>
+        <p:txBody>
+          <a:bodyPr wrap="square" rtlCol="0" anchor="ctr"/>
+          <a:lstStyle/>
+          <a:p>
+            <a:pPr algn="ctr" indent="0" marL="0">
+              <a:buNone/>
+            </a:pPr>
+            <a:r>
+              <a:rPr lang="en-US" sz="800" b="1" dirty="0">
+                <a:solidFill>
+                  <a:srgbClr val="FFFFFF"/>
+                </a:solidFill>
+                <a:latin typeface="Arial" pitchFamily="34" charset="0"/>
+                <a:ea typeface="Arial" pitchFamily="34" charset="-122"/>
+                <a:cs typeface="Arial" pitchFamily="34" charset="-120"/>
+              </a:rPr>
+              <a:t>7</a:t>
+            </a:r>
+            <a:endParaRPr lang="en-US" sz="800" dirty="0"/>
+          </a:p>
+        </p:txBody>
+      </p:sp>
+      <p:sp>
+        <p:nvSpPr>
+          <p:cNvPr id="60" name="Text 58"/>
+          <p:cNvSpPr/>
+          <p:nvPr/>
+        </p:nvSpPr>
+        <p:spPr>
+          <a:xfrm>
+            <a:off x="5029200" y="3520440"/>
+            <a:ext cx="1188720" cy="502920"/>
+          </a:xfrm>
+          <a:prstGeom prst="rect">
+            <a:avLst/>
+          </a:prstGeom>
+          <a:solidFill>
+            <a:srgbClr val="E8F4FD"/>
+          </a:solidFill>
+          <a:ln w="6350">
+            <a:solidFill>
+              <a:srgbClr val="0972D3"/>
+            </a:solidFill>
+          </a:ln>
+        </p:spPr>
+        <p:txBody>
+          <a:bodyPr wrap="square" rtlCol="0" anchor="ctr"/>
+          <a:lstStyle/>
+          <a:p>
+            <a:pPr algn="ctr" indent="0" marL="0">
+              <a:buNone/>
+            </a:pPr>
+            <a:r>
+              <a:rPr lang="en-US" sz="800" dirty="0">
+                <a:solidFill>
+                  <a:srgbClr val="0972D3"/>
+                </a:solidFill>
+                <a:latin typeface="Arial" pitchFamily="34" charset="0"/>
+                <a:ea typeface="Arial" pitchFamily="34" charset="-122"/>
+                <a:cs typeface="Arial" pitchFamily="34" charset="-120"/>
+              </a:rPr>
+              <a:t>Amazon SageMaker</a:t>
+            </a:r>
+            <a:endParaRPr lang="en-US" sz="800" dirty="0"/>
+          </a:p>
+          <a:p>
+            <a:pPr algn="ctr" indent="0" marL="0">
+              <a:buNone/>
+            </a:pPr>
+            <a:r>
+              <a:rPr lang="en-US" sz="800" dirty="0">
+                <a:solidFill>
+                  <a:srgbClr val="0972D3"/>
+                </a:solidFill>
+                <a:latin typeface="Arial" pitchFamily="34" charset="0"/>
+                <a:ea typeface="Arial" pitchFamily="34" charset="-122"/>
+                <a:cs typeface="Arial" pitchFamily="34" charset="-120"/>
+              </a:rPr>
+              <a:t>Notebook</a:t>
+            </a:r>
+            <a:endParaRPr lang="en-US" sz="800" dirty="0"/>
+          </a:p>
+        </p:txBody>
+      </p:sp>
+      <p:sp>
+        <p:nvSpPr>
+          <p:cNvPr id="61" name="Text 59"/>
+          <p:cNvSpPr/>
+          <p:nvPr/>
+        </p:nvSpPr>
+        <p:spPr>
+          <a:xfrm>
+            <a:off x="6309360" y="3520440"/>
+            <a:ext cx="1188720" cy="502920"/>
+          </a:xfrm>
+          <a:prstGeom prst="rect">
+            <a:avLst/>
+          </a:prstGeom>
+          <a:solidFill>
+            <a:srgbClr val="E8F4FD"/>
+          </a:solidFill>
+          <a:ln w="6350">
+            <a:solidFill>
+              <a:srgbClr val="0972D3"/>
+            </a:solidFill>
+          </a:ln>
+        </p:spPr>
+        <p:txBody>
+          <a:bodyPr wrap="square" rtlCol="0" anchor="ctr"/>
+          <a:lstStyle/>
+          <a:p>
+            <a:pPr algn="ctr" indent="0" marL="0">
+              <a:buNone/>
+            </a:pPr>
+            <a:r>
+              <a:rPr lang="en-US" sz="800" dirty="0">
+                <a:solidFill>
+                  <a:srgbClr val="0972D3"/>
+                </a:solidFill>
+                <a:latin typeface="Arial" pitchFamily="34" charset="0"/>
+                <a:ea typeface="Arial" pitchFamily="34" charset="-122"/>
+                <a:cs typeface="Arial" pitchFamily="34" charset="-120"/>
+              </a:rPr>
+              <a:t>DevOps Agent</a:t>
+            </a:r>
+            <a:endParaRPr lang="en-US" sz="800" dirty="0"/>
+          </a:p>
+          <a:p>
+            <a:pPr algn="ctr" indent="0" marL="0">
+              <a:buNone/>
+            </a:pPr>
+            <a:r>
+              <a:rPr lang="en-US" sz="800" dirty="0">
+                <a:solidFill>
+                  <a:srgbClr val="0972D3"/>
+                </a:solidFill>
+                <a:latin typeface="Arial" pitchFamily="34" charset="0"/>
+                <a:ea typeface="Arial" pitchFamily="34" charset="-122"/>
+                <a:cs typeface="Arial" pitchFamily="34" charset="-120"/>
+              </a:rPr>
+              <a:t>(MCP Client)</a:t>
+            </a:r>
+            <a:endParaRPr lang="en-US" sz="800" dirty="0"/>
+          </a:p>
+        </p:txBody>
+      </p:sp>
+      <p:sp>
+        <p:nvSpPr>
+          <p:cNvPr id="62" name="Text 60"/>
+          <p:cNvSpPr/>
+          <p:nvPr/>
+        </p:nvSpPr>
+        <p:spPr>
+          <a:xfrm>
+            <a:off x="7360920" y="3611880"/>
+            <a:ext cx="182880" cy="182880"/>
+          </a:xfrm>
+          <a:prstGeom prst="ellipse">
+            <a:avLst/>
+          </a:prstGeom>
+          <a:solidFill>
+            <a:srgbClr val="FF9900"/>
+          </a:solidFill>
+          <a:ln/>
+        </p:spPr>
+        <p:txBody>
+          <a:bodyPr wrap="square" rtlCol="0" anchor="ctr"/>
+          <a:lstStyle/>
+          <a:p>
+            <a:pPr algn="ctr" indent="0" marL="0">
+              <a:buNone/>
+            </a:pPr>
+            <a:r>
+              <a:rPr lang="en-US" sz="800" b="1" dirty="0">
+                <a:solidFill>
+                  <a:srgbClr val="FFFFFF"/>
+                </a:solidFill>
+                <a:latin typeface="Arial" pitchFamily="34" charset="0"/>
+                <a:ea typeface="Arial" pitchFamily="34" charset="-122"/>
+                <a:cs typeface="Arial" pitchFamily="34" charset="-120"/>
+              </a:rPr>
+              <a:t>8</a:t>
+            </a:r>
+            <a:endParaRPr lang="en-US" sz="800" dirty="0"/>
+          </a:p>
+        </p:txBody>
+      </p:sp>
+      <p:sp>
+        <p:nvSpPr>
+          <p:cNvPr id="63" name="Shape 61"/>
+          <p:cNvSpPr/>
+          <p:nvPr/>
+        </p:nvSpPr>
+        <p:spPr>
+          <a:xfrm>
+            <a:off x="5623560" y="1920240"/>
+            <a:ext cx="0" cy="182880"/>
+          </a:xfrm>
+          <a:prstGeom prst="line">
+            <a:avLst/>
+          </a:prstGeom>
+          <a:noFill/>
+          <a:ln w="15875">
+            <a:solidFill>
+              <a:srgbClr val="1B8B1B"/>
+            </a:solidFill>
+            <a:prstDash val="solid"/>
+            <a:tailEnd type="arrow"/>
+          </a:ln>
+        </p:spPr>
+      </p:sp>
+      <p:sp>
+        <p:nvSpPr>
+          <p:cNvPr id="64" name="Shape 62"/>
+          <p:cNvSpPr/>
+          <p:nvPr/>
+        </p:nvSpPr>
+        <p:spPr>
+          <a:xfrm>
+            <a:off x="6217920" y="2377440"/>
+            <a:ext cx="137160" cy="0"/>
+          </a:xfrm>
+          <a:prstGeom prst="line">
+            <a:avLst/>
+          </a:prstGeom>
+          <a:noFill/>
+          <a:ln w="15875">
+            <a:solidFill>
+              <a:srgbClr val="D13212"/>
+            </a:solidFill>
+            <a:prstDash val="solid"/>
+            <a:tailEnd type="arrow"/>
+          </a:ln>
+        </p:spPr>
+      </p:sp>
+      <p:sp>
+        <p:nvSpPr>
+          <p:cNvPr id="65" name="Shape 63"/>
+          <p:cNvSpPr/>
+          <p:nvPr/>
+        </p:nvSpPr>
+        <p:spPr>
+          <a:xfrm>
+            <a:off x="5577840" y="2651760"/>
+            <a:ext cx="0" cy="182880"/>
+          </a:xfrm>
+          <a:prstGeom prst="line">
+            <a:avLst/>
+          </a:prstGeom>
+          <a:noFill/>
+          <a:ln w="15875">
+            <a:solidFill>
+              <a:srgbClr val="7C3AED"/>
+            </a:solidFill>
+            <a:prstDash val="solid"/>
+            <a:tailEnd type="arrow"/>
+          </a:ln>
+        </p:spPr>
+      </p:sp>
+      <p:sp>
+        <p:nvSpPr>
+          <p:cNvPr id="66" name="Shape 64"/>
+          <p:cNvSpPr/>
+          <p:nvPr/>
+        </p:nvSpPr>
+        <p:spPr>
+          <a:xfrm>
+            <a:off x="5623560" y="3337560"/>
+            <a:ext cx="0" cy="182880"/>
+          </a:xfrm>
+          <a:prstGeom prst="line">
+            <a:avLst/>
+          </a:prstGeom>
+          <a:noFill/>
+          <a:ln w="15875">
+            <a:solidFill>
+              <a:srgbClr val="0972D3"/>
+            </a:solidFill>
+            <a:prstDash val="solid"/>
+            <a:tailEnd type="arrow"/>
+          </a:ln>
+        </p:spPr>
+      </p:sp>
+      <p:sp>
+        <p:nvSpPr>
+          <p:cNvPr id="67" name="Shape 65"/>
+          <p:cNvSpPr/>
+          <p:nvPr/>
+        </p:nvSpPr>
+        <p:spPr>
+          <a:xfrm>
+            <a:off x="2286000" y="2359152"/>
+            <a:ext cx="0" cy="228600"/>
+          </a:xfrm>
+          <a:prstGeom prst="line">
+            <a:avLst/>
+          </a:prstGeom>
+          <a:noFill/>
+          <a:ln w="15875">
+            <a:solidFill>
+              <a:srgbClr val="232F3E"/>
+            </a:solidFill>
+            <a:prstDash val="solid"/>
+            <a:tailEnd type="arrow"/>
+          </a:ln>
+        </p:spPr>
+      </p:sp>
+      <p:sp>
+        <p:nvSpPr>
+          <p:cNvPr id="68" name="Text 66"/>
+          <p:cNvSpPr/>
+          <p:nvPr/>
+        </p:nvSpPr>
+        <p:spPr>
+          <a:xfrm>
+            <a:off x="274320" y="6537960"/>
+            <a:ext cx="7315200" cy="182880"/>
           </a:xfrm>
           <a:prstGeom prst="rect">
             <a:avLst/>

</xml_diff>

<commit_message>
Use official AWS Architecture Icons in the Guidance diagram
- Rasterized the official service icons (aws-icons set) into docs/diagrams/icons/:
  EKS, Managed Service for Prometheus, SNS, Lambda, Secrets Manager, DevOps Agent,
  Cognito, API Gateway, SageMaker (incl. the real AWS DevOps Agent icon).
- generate-guidance-pptx.cjs now embeds these icons via addImage for AWS services;
  non-AWS elements (open5gs, UERANSIM, Prometheus agent) stay as labeled boxes.
- Regenerated 5g-rcf-architecture-guidance.pptx: 10 official icons, 18 numbered
  callouts, single slide 13.33x7.5, geometry-validated (in-bounds).
</commit_message>
<xml_diff>
--- a/docs/diagrams/5g-rcf-architecture-guidance.pptx
+++ b/docs/diagrams/5g-rcf-architecture-guidance.pptx
@@ -1861,8 +1861,8 @@
             <a:avLst/>
           </a:prstGeom>
           <a:solidFill>
-            <a:srgbClr val="DCEBFA">
-              <a:alpha val="35000"/>
+            <a:srgbClr val="EAF3FB">
+              <a:alpha val="65000"/>
             </a:srgbClr>
           </a:solidFill>
           <a:ln w="12700">
@@ -1873,16 +1873,40 @@
           </a:ln>
         </p:spPr>
       </p:sp>
-      <p:sp>
-        <p:nvSpPr>
-          <p:cNvPr id="29" name="Text 27"/>
-          <p:cNvSpPr/>
-          <p:nvPr/>
-        </p:nvSpPr>
-        <p:spPr>
-          <a:xfrm>
-            <a:off x="713232" y="1399032"/>
-            <a:ext cx="2651760" cy="182880"/>
+      <p:pic>
+        <p:nvPicPr>
+          <p:cNvPr id="29" name="Image 0" descr="/Users/mdsherif/Library/CloudStorage/WorkDocsDrive-Documents/MyMac/06Tools/24-ai-devops-amp/docs/diagrams/icons/AmazonElasticKubernetesService.png">    </p:cNvPr>
+          <p:cNvPicPr>
+            <a:picLocks noChangeAspect="1"/>
+          </p:cNvPicPr>
+          <p:nvPr/>
+        </p:nvPicPr>
+        <p:blipFill>
+          <a:blip r:embed="rId1"/>
+          <a:stretch>
+            <a:fillRect/>
+          </a:stretch>
+        </p:blipFill>
+        <p:spPr>
+          <a:xfrm>
+            <a:off x="713232" y="1417320"/>
+            <a:ext cx="292608" cy="292608"/>
+          </a:xfrm>
+          <a:prstGeom prst="rect">
+            <a:avLst/>
+          </a:prstGeom>
+        </p:spPr>
+      </p:pic>
+      <p:sp>
+        <p:nvSpPr>
+          <p:cNvPr id="30" name="Text 27"/>
+          <p:cNvSpPr/>
+          <p:nvPr/>
+        </p:nvSpPr>
+        <p:spPr>
+          <a:xfrm>
+            <a:off x="1042416" y="1435608"/>
+            <a:ext cx="2286000" cy="274320"/>
           </a:xfrm>
           <a:prstGeom prst="rect">
             <a:avLst/>
@@ -1906,7 +1930,7 @@
                 <a:ea typeface="Arial" pitchFamily="34" charset="-122"/>
                 <a:cs typeface="Arial" pitchFamily="34" charset="-120"/>
               </a:rPr>
-              <a:t>Amazon EKS  ·  open5gs-amp-cluster</a:t>
+              <a:t>Amazon EKS · open5gs-amp-cluster</a:t>
             </a:r>
             <a:endParaRPr lang="en-US" sz="800" dirty="0"/>
           </a:p>
@@ -1914,24 +1938,24 @@
       </p:sp>
       <p:sp>
         <p:nvSpPr>
-          <p:cNvPr id="30" name="Text 28"/>
-          <p:cNvSpPr/>
-          <p:nvPr/>
-        </p:nvSpPr>
-        <p:spPr>
-          <a:xfrm>
-            <a:off x="777240" y="1645920"/>
-            <a:ext cx="2514600" cy="502920"/>
-          </a:xfrm>
-          <a:prstGeom prst="rect">
-            <a:avLst/>
-          </a:prstGeom>
-          <a:solidFill>
-            <a:srgbClr val="FFE9CC"/>
+          <p:cNvPr id="31" name="Text 28"/>
+          <p:cNvSpPr/>
+          <p:nvPr/>
+        </p:nvSpPr>
+        <p:spPr>
+          <a:xfrm>
+            <a:off x="777240" y="1828800"/>
+            <a:ext cx="2514600" cy="457200"/>
+          </a:xfrm>
+          <a:prstGeom prst="rect">
+            <a:avLst/>
+          </a:prstGeom>
+          <a:solidFill>
+            <a:srgbClr val="FFFFFF"/>
           </a:solidFill>
           <a:ln w="12700">
             <a:solidFill>
-              <a:srgbClr val="FF9900"/>
+              <a:srgbClr val="666666"/>
             </a:solidFill>
           </a:ln>
         </p:spPr>
@@ -1943,7 +1967,7 @@
               <a:buNone/>
             </a:pPr>
             <a:r>
-              <a:rPr lang="en-US" sz="850" b="1" dirty="0">
+              <a:rPr lang="en-US" sz="800" b="1" dirty="0">
                 <a:solidFill>
                   <a:srgbClr val="232F3E"/>
                 </a:solidFill>
@@ -1951,49 +1975,32 @@
                 <a:ea typeface="Arial" pitchFamily="34" charset="-122"/>
                 <a:cs typeface="Arial" pitchFamily="34" charset="-120"/>
               </a:rPr>
-              <a:t>UERANSIM RAN</a:t>
-            </a:r>
-            <a:endParaRPr lang="en-US" sz="850" dirty="0"/>
-          </a:p>
-          <a:p>
-            <a:pPr algn="ctr" indent="0" marL="0">
-              <a:buNone/>
-            </a:pPr>
-            <a:r>
-              <a:rPr lang="en-US" sz="850" b="1" dirty="0">
-                <a:solidFill>
-                  <a:srgbClr val="232F3E"/>
-                </a:solidFill>
-                <a:latin typeface="Arial" pitchFamily="34" charset="0"/>
-                <a:ea typeface="Arial" pitchFamily="34" charset="-122"/>
-                <a:cs typeface="Arial" pitchFamily="34" charset="-120"/>
-              </a:rPr>
-              <a:t>100 gNodeBs · 1,000 UEs</a:t>
-            </a:r>
-            <a:endParaRPr lang="en-US" sz="850" dirty="0"/>
-          </a:p>
-        </p:txBody>
-      </p:sp>
-      <p:sp>
-        <p:nvSpPr>
-          <p:cNvPr id="31" name="Text 29"/>
-          <p:cNvSpPr/>
-          <p:nvPr/>
-        </p:nvSpPr>
-        <p:spPr>
-          <a:xfrm>
-            <a:off x="777240" y="2240280"/>
-            <a:ext cx="2514600" cy="777240"/>
-          </a:xfrm>
-          <a:prstGeom prst="rect">
-            <a:avLst/>
-          </a:prstGeom>
-          <a:solidFill>
-            <a:srgbClr val="FFE9CC"/>
+              <a:t>UERANSIM RAN — 100 gNodeBs · 1,000 UEs</a:t>
+            </a:r>
+            <a:endParaRPr lang="en-US" sz="800" dirty="0"/>
+          </a:p>
+        </p:txBody>
+      </p:sp>
+      <p:sp>
+        <p:nvSpPr>
+          <p:cNvPr id="32" name="Text 29"/>
+          <p:cNvSpPr/>
+          <p:nvPr/>
+        </p:nvSpPr>
+        <p:spPr>
+          <a:xfrm>
+            <a:off x="777240" y="2377440"/>
+            <a:ext cx="2514600" cy="685800"/>
+          </a:xfrm>
+          <a:prstGeom prst="rect">
+            <a:avLst/>
+          </a:prstGeom>
+          <a:solidFill>
+            <a:srgbClr val="FFFFFF"/>
           </a:solidFill>
           <a:ln w="12700">
             <a:solidFill>
-              <a:srgbClr val="FF9900"/>
+              <a:srgbClr val="666666"/>
             </a:solidFill>
           </a:ln>
         </p:spPr>
@@ -2038,14 +2045,14 @@
       </p:sp>
       <p:sp>
         <p:nvSpPr>
-          <p:cNvPr id="32" name="Text 30"/>
-          <p:cNvSpPr/>
-          <p:nvPr/>
-        </p:nvSpPr>
-        <p:spPr>
-          <a:xfrm>
-            <a:off x="777240" y="3108960"/>
-            <a:ext cx="2514600" cy="777240"/>
+          <p:cNvPr id="33" name="Text 30"/>
+          <p:cNvSpPr/>
+          <p:nvPr/>
+        </p:nvSpPr>
+        <p:spPr>
+          <a:xfrm>
+            <a:off x="777240" y="3200400"/>
+            <a:ext cx="2514600" cy="640080"/>
           </a:xfrm>
           <a:prstGeom prst="rect">
             <a:avLst/>
@@ -2100,7 +2107,7 @@
       </p:sp>
       <p:sp>
         <p:nvSpPr>
-          <p:cNvPr id="33" name="Text 31"/>
+          <p:cNvPr id="34" name="Text 31"/>
           <p:cNvSpPr/>
           <p:nvPr/>
         </p:nvSpPr>
@@ -2139,16 +2146,96 @@
           </a:p>
         </p:txBody>
       </p:sp>
-      <p:sp>
-        <p:nvSpPr>
-          <p:cNvPr id="34" name="Text 32"/>
-          <p:cNvSpPr/>
-          <p:nvPr/>
-        </p:nvSpPr>
-        <p:spPr>
-          <a:xfrm>
-            <a:off x="3794760" y="1463040"/>
-            <a:ext cx="2148840" cy="822960"/>
+      <p:pic>
+        <p:nvPicPr>
+          <p:cNvPr id="35" name="Image 1" descr="/Users/mdsherif/Library/CloudStorage/WorkDocsDrive-Documents/MyMac/06Tools/24-ai-devops-amp/docs/diagrams/icons/AmazonManagedServiceforPrometheus.png">    </p:cNvPr>
+          <p:cNvPicPr>
+            <a:picLocks noChangeAspect="1"/>
+          </p:cNvPicPr>
+          <p:nvPr/>
+        </p:nvPicPr>
+        <p:blipFill>
+          <a:blip r:embed="rId2"/>
+          <a:stretch>
+            <a:fillRect/>
+          </a:stretch>
+        </p:blipFill>
+        <p:spPr>
+          <a:xfrm>
+            <a:off x="4617720" y="1371600"/>
+            <a:ext cx="457200" cy="457200"/>
+          </a:xfrm>
+          <a:prstGeom prst="rect">
+            <a:avLst/>
+          </a:prstGeom>
+        </p:spPr>
+      </p:pic>
+      <p:sp>
+        <p:nvSpPr>
+          <p:cNvPr id="36" name="Text 32"/>
+          <p:cNvSpPr/>
+          <p:nvPr/>
+        </p:nvSpPr>
+        <p:spPr>
+          <a:xfrm>
+            <a:off x="3703320" y="1837944"/>
+            <a:ext cx="2286000" cy="365760"/>
+          </a:xfrm>
+          <a:prstGeom prst="rect">
+            <a:avLst/>
+          </a:prstGeom>
+          <a:noFill/>
+          <a:ln/>
+        </p:spPr>
+        <p:txBody>
+          <a:bodyPr wrap="square" rtlCol="0" anchor="t"/>
+          <a:lstStyle/>
+          <a:p>
+            <a:pPr algn="ctr" indent="0" marL="0">
+              <a:buNone/>
+            </a:pPr>
+            <a:r>
+              <a:rPr lang="en-US" sz="800" dirty="0">
+                <a:solidFill>
+                  <a:srgbClr val="232F3E"/>
+                </a:solidFill>
+                <a:latin typeface="Arial" pitchFamily="34" charset="0"/>
+                <a:ea typeface="Arial" pitchFamily="34" charset="-122"/>
+                <a:cs typeface="Arial" pitchFamily="34" charset="-120"/>
+              </a:rPr>
+              <a:t>Amazon Managed Service</a:t>
+            </a:r>
+            <a:endParaRPr lang="en-US" sz="800" dirty="0"/>
+          </a:p>
+          <a:p>
+            <a:pPr algn="ctr" indent="0" marL="0">
+              <a:buNone/>
+            </a:pPr>
+            <a:r>
+              <a:rPr lang="en-US" sz="800" dirty="0">
+                <a:solidFill>
+                  <a:srgbClr val="232F3E"/>
+                </a:solidFill>
+                <a:latin typeface="Arial" pitchFamily="34" charset="0"/>
+                <a:ea typeface="Arial" pitchFamily="34" charset="-122"/>
+                <a:cs typeface="Arial" pitchFamily="34" charset="-120"/>
+              </a:rPr>
+              <a:t>for Prometheus</a:t>
+            </a:r>
+            <a:endParaRPr lang="en-US" sz="800" dirty="0"/>
+          </a:p>
+        </p:txBody>
+      </p:sp>
+      <p:sp>
+        <p:nvSpPr>
+          <p:cNvPr id="37" name="Text 33"/>
+          <p:cNvSpPr/>
+          <p:nvPr/>
+        </p:nvSpPr>
+        <p:spPr>
+          <a:xfrm>
+            <a:off x="3977640" y="2331720"/>
+            <a:ext cx="1737360" cy="457200"/>
           </a:xfrm>
           <a:prstGeom prst="rect">
             <a:avLst/>
@@ -2170,7 +2257,7 @@
               <a:buNone/>
             </a:pPr>
             <a:r>
-              <a:rPr lang="en-US" sz="900" b="1" dirty="0">
+              <a:rPr lang="en-US" sz="750" b="1" dirty="0">
                 <a:solidFill>
                   <a:srgbClr val="232F3E"/>
                 </a:solidFill>
@@ -2178,16 +2265,144 @@
                 <a:ea typeface="Arial" pitchFamily="34" charset="-122"/>
                 <a:cs typeface="Arial" pitchFamily="34" charset="-120"/>
               </a:rPr>
-              <a:t>Amazon Managed</a:t>
-            </a:r>
-            <a:endParaRPr lang="en-US" sz="900" dirty="0"/>
-          </a:p>
+              <a:t>RCF anomaly detector — score &gt; 0.1 · 30s</a:t>
+            </a:r>
+            <a:endParaRPr lang="en-US" sz="750" dirty="0"/>
+          </a:p>
+        </p:txBody>
+      </p:sp>
+      <p:sp>
+        <p:nvSpPr>
+          <p:cNvPr id="38" name="Text 34"/>
+          <p:cNvSpPr/>
+          <p:nvPr/>
+        </p:nvSpPr>
+        <p:spPr>
+          <a:xfrm>
+            <a:off x="3703320" y="1426464"/>
+            <a:ext cx="219456" cy="219456"/>
+          </a:xfrm>
+          <a:prstGeom prst="ellipse">
+            <a:avLst/>
+          </a:prstGeom>
+          <a:solidFill>
+            <a:srgbClr val="FF9900"/>
+          </a:solidFill>
+          <a:ln/>
+        </p:spPr>
+        <p:txBody>
+          <a:bodyPr wrap="square" rtlCol="0" anchor="ctr"/>
+          <a:lstStyle/>
           <a:p>
             <a:pPr algn="ctr" indent="0" marL="0">
               <a:buNone/>
             </a:pPr>
             <a:r>
-              <a:rPr lang="en-US" sz="900" b="1" dirty="0">
+              <a:rPr lang="en-US" sz="850" b="1" dirty="0">
+                <a:solidFill>
+                  <a:srgbClr val="FFFFFF"/>
+                </a:solidFill>
+                <a:latin typeface="Arial" pitchFamily="34" charset="0"/>
+                <a:ea typeface="Arial" pitchFamily="34" charset="-122"/>
+                <a:cs typeface="Arial" pitchFamily="34" charset="-120"/>
+              </a:rPr>
+              <a:t>2</a:t>
+            </a:r>
+            <a:endParaRPr lang="en-US" sz="850" dirty="0"/>
+          </a:p>
+        </p:txBody>
+      </p:sp>
+      <p:sp>
+        <p:nvSpPr>
+          <p:cNvPr id="39" name="Text 35"/>
+          <p:cNvSpPr/>
+          <p:nvPr/>
+        </p:nvSpPr>
+        <p:spPr>
+          <a:xfrm>
+            <a:off x="5486400" y="1426464"/>
+            <a:ext cx="219456" cy="219456"/>
+          </a:xfrm>
+          <a:prstGeom prst="ellipse">
+            <a:avLst/>
+          </a:prstGeom>
+          <a:solidFill>
+            <a:srgbClr val="FF9900"/>
+          </a:solidFill>
+          <a:ln/>
+        </p:spPr>
+        <p:txBody>
+          <a:bodyPr wrap="square" rtlCol="0" anchor="ctr"/>
+          <a:lstStyle/>
+          <a:p>
+            <a:pPr algn="ctr" indent="0" marL="0">
+              <a:buNone/>
+            </a:pPr>
+            <a:r>
+              <a:rPr lang="en-US" sz="850" b="1" dirty="0">
+                <a:solidFill>
+                  <a:srgbClr val="FFFFFF"/>
+                </a:solidFill>
+                <a:latin typeface="Arial" pitchFamily="34" charset="0"/>
+                <a:ea typeface="Arial" pitchFamily="34" charset="-122"/>
+                <a:cs typeface="Arial" pitchFamily="34" charset="-120"/>
+              </a:rPr>
+              <a:t>3</a:t>
+            </a:r>
+            <a:endParaRPr lang="en-US" sz="850" dirty="0"/>
+          </a:p>
+        </p:txBody>
+      </p:sp>
+      <p:pic>
+        <p:nvPicPr>
+          <p:cNvPr id="40" name="Image 2" descr="/Users/mdsherif/Library/CloudStorage/WorkDocsDrive-Documents/MyMac/06Tools/24-ai-devops-amp/docs/diagrams/icons/AmazonSimpleNotificationService.png">    </p:cNvPr>
+          <p:cNvPicPr>
+            <a:picLocks noChangeAspect="1"/>
+          </p:cNvPicPr>
+          <p:nvPr/>
+        </p:nvPicPr>
+        <p:blipFill>
+          <a:blip r:embed="rId3"/>
+          <a:stretch>
+            <a:fillRect/>
+          </a:stretch>
+        </p:blipFill>
+        <p:spPr>
+          <a:xfrm>
+            <a:off x="6812280" y="1371600"/>
+            <a:ext cx="457200" cy="457200"/>
+          </a:xfrm>
+          <a:prstGeom prst="rect">
+            <a:avLst/>
+          </a:prstGeom>
+        </p:spPr>
+      </p:pic>
+      <p:sp>
+        <p:nvSpPr>
+          <p:cNvPr id="41" name="Text 36"/>
+          <p:cNvSpPr/>
+          <p:nvPr/>
+        </p:nvSpPr>
+        <p:spPr>
+          <a:xfrm>
+            <a:off x="6172200" y="1837944"/>
+            <a:ext cx="1737360" cy="365760"/>
+          </a:xfrm>
+          <a:prstGeom prst="rect">
+            <a:avLst/>
+          </a:prstGeom>
+          <a:noFill/>
+          <a:ln/>
+        </p:spPr>
+        <p:txBody>
+          <a:bodyPr wrap="square" rtlCol="0" anchor="t"/>
+          <a:lstStyle/>
+          <a:p>
+            <a:pPr algn="ctr" indent="0" marL="0">
+              <a:buNone/>
+            </a:pPr>
+            <a:r>
+              <a:rPr lang="en-US" sz="800" dirty="0">
                 <a:solidFill>
                   <a:srgbClr val="232F3E"/>
                 </a:solidFill>
@@ -2195,34 +2410,47 @@
                 <a:ea typeface="Arial" pitchFamily="34" charset="-122"/>
                 <a:cs typeface="Arial" pitchFamily="34" charset="-120"/>
               </a:rPr>
-              <a:t>Service for Prometheus</a:t>
-            </a:r>
-            <a:endParaRPr lang="en-US" sz="900" dirty="0"/>
-          </a:p>
-        </p:txBody>
-      </p:sp>
-      <p:sp>
-        <p:nvSpPr>
-          <p:cNvPr id="35" name="Text 33"/>
-          <p:cNvSpPr/>
-          <p:nvPr/>
-        </p:nvSpPr>
-        <p:spPr>
-          <a:xfrm>
-            <a:off x="3794760" y="2377440"/>
-            <a:ext cx="2148840" cy="566928"/>
-          </a:xfrm>
-          <a:prstGeom prst="rect">
-            <a:avLst/>
-          </a:prstGeom>
-          <a:solidFill>
-            <a:srgbClr val="DCEEDC"/>
-          </a:solidFill>
-          <a:ln w="12700">
-            <a:solidFill>
-              <a:srgbClr val="1B8B1B"/>
-            </a:solidFill>
-          </a:ln>
+              <a:t>Amazon SNS</a:t>
+            </a:r>
+            <a:endParaRPr lang="en-US" sz="800" dirty="0"/>
+          </a:p>
+          <a:p>
+            <a:pPr algn="ctr" indent="0" marL="0">
+              <a:buNone/>
+            </a:pPr>
+            <a:r>
+              <a:rPr lang="en-US" sz="800" dirty="0">
+                <a:solidFill>
+                  <a:srgbClr val="232F3E"/>
+                </a:solidFill>
+                <a:latin typeface="Arial" pitchFamily="34" charset="0"/>
+                <a:ea typeface="Arial" pitchFamily="34" charset="-122"/>
+                <a:cs typeface="Arial" pitchFamily="34" charset="-120"/>
+              </a:rPr>
+              <a:t>RCA trigger topic</a:t>
+            </a:r>
+            <a:endParaRPr lang="en-US" sz="800" dirty="0"/>
+          </a:p>
+        </p:txBody>
+      </p:sp>
+      <p:sp>
+        <p:nvSpPr>
+          <p:cNvPr id="42" name="Text 37"/>
+          <p:cNvSpPr/>
+          <p:nvPr/>
+        </p:nvSpPr>
+        <p:spPr>
+          <a:xfrm>
+            <a:off x="6035040" y="1426464"/>
+            <a:ext cx="219456" cy="219456"/>
+          </a:xfrm>
+          <a:prstGeom prst="ellipse">
+            <a:avLst/>
+          </a:prstGeom>
+          <a:solidFill>
+            <a:srgbClr val="FF9900"/>
+          </a:solidFill>
+          <a:ln/>
         </p:spPr>
         <p:txBody>
           <a:bodyPr wrap="square" rtlCol="0" anchor="ctr"/>
@@ -2232,7 +2460,70 @@
               <a:buNone/>
             </a:pPr>
             <a:r>
-              <a:rPr lang="en-US" sz="800" b="1" dirty="0">
+              <a:rPr lang="en-US" sz="850" b="1" dirty="0">
+                <a:solidFill>
+                  <a:srgbClr val="FFFFFF"/>
+                </a:solidFill>
+                <a:latin typeface="Arial" pitchFamily="34" charset="0"/>
+                <a:ea typeface="Arial" pitchFamily="34" charset="-122"/>
+                <a:cs typeface="Arial" pitchFamily="34" charset="-120"/>
+              </a:rPr>
+              <a:t>4</a:t>
+            </a:r>
+            <a:endParaRPr lang="en-US" sz="850" dirty="0"/>
+          </a:p>
+        </p:txBody>
+      </p:sp>
+      <p:pic>
+        <p:nvPicPr>
+          <p:cNvPr id="43" name="Image 3" descr="/Users/mdsherif/Library/CloudStorage/WorkDocsDrive-Documents/MyMac/06Tools/24-ai-devops-amp/docs/diagrams/icons/AWSLambda.png">    </p:cNvPr>
+          <p:cNvPicPr>
+            <a:picLocks noChangeAspect="1"/>
+          </p:cNvPicPr>
+          <p:nvPr/>
+        </p:nvPicPr>
+        <p:blipFill>
+          <a:blip r:embed="rId4"/>
+          <a:stretch>
+            <a:fillRect/>
+          </a:stretch>
+        </p:blipFill>
+        <p:spPr>
+          <a:xfrm>
+            <a:off x="6812280" y="2743200"/>
+            <a:ext cx="457200" cy="457200"/>
+          </a:xfrm>
+          <a:prstGeom prst="rect">
+            <a:avLst/>
+          </a:prstGeom>
+        </p:spPr>
+      </p:pic>
+      <p:sp>
+        <p:nvSpPr>
+          <p:cNvPr id="44" name="Text 38"/>
+          <p:cNvSpPr/>
+          <p:nvPr/>
+        </p:nvSpPr>
+        <p:spPr>
+          <a:xfrm>
+            <a:off x="6172200" y="3209544"/>
+            <a:ext cx="1737360" cy="365760"/>
+          </a:xfrm>
+          <a:prstGeom prst="rect">
+            <a:avLst/>
+          </a:prstGeom>
+          <a:noFill/>
+          <a:ln/>
+        </p:spPr>
+        <p:txBody>
+          <a:bodyPr wrap="square" rtlCol="0" anchor="t"/>
+          <a:lstStyle/>
+          <a:p>
+            <a:pPr algn="ctr" indent="0" marL="0">
+              <a:buNone/>
+            </a:pPr>
+            <a:r>
+              <a:rPr lang="en-US" sz="800" dirty="0">
                 <a:solidFill>
                   <a:srgbClr val="232F3E"/>
                 </a:solidFill>
@@ -2240,7 +2531,7 @@
                 <a:ea typeface="Arial" pitchFamily="34" charset="-122"/>
                 <a:cs typeface="Arial" pitchFamily="34" charset="-120"/>
               </a:rPr>
-              <a:t>RCF anomaly detector</a:t>
+              <a:t>AWS Lambda</a:t>
             </a:r>
             <a:endParaRPr lang="en-US" sz="800" dirty="0"/>
           </a:p>
@@ -2249,7 +2540,7 @@
               <a:buNone/>
             </a:pPr>
             <a:r>
-              <a:rPr lang="en-US" sz="800" b="1" dirty="0">
+              <a:rPr lang="en-US" sz="800" dirty="0">
                 <a:solidFill>
                   <a:srgbClr val="232F3E"/>
                 </a:solidFill>
@@ -2257,7 +2548,7 @@
                 <a:ea typeface="Arial" pitchFamily="34" charset="-122"/>
                 <a:cs typeface="Arial" pitchFamily="34" charset="-120"/>
               </a:rPr>
-              <a:t>score &gt; 0.1 · 30s</a:t>
+              <a:t>Root-cause analysis</a:t>
             </a:r>
             <a:endParaRPr lang="en-US" sz="800" dirty="0"/>
           </a:p>
@@ -2265,13 +2556,13 @@
       </p:sp>
       <p:sp>
         <p:nvSpPr>
-          <p:cNvPr id="36" name="Text 34"/>
-          <p:cNvSpPr/>
-          <p:nvPr/>
-        </p:nvSpPr>
-        <p:spPr>
-          <a:xfrm>
-            <a:off x="3566160" y="1517904"/>
+          <p:cNvPr id="45" name="Text 39"/>
+          <p:cNvSpPr/>
+          <p:nvPr/>
+        </p:nvSpPr>
+        <p:spPr>
+          <a:xfrm>
+            <a:off x="6035040" y="2798064"/>
             <a:ext cx="219456" cy="219456"/>
           </a:xfrm>
           <a:prstGeom prst="ellipse">
@@ -2298,7 +2589,7 @@
                 <a:ea typeface="Arial" pitchFamily="34" charset="-122"/>
                 <a:cs typeface="Arial" pitchFamily="34" charset="-120"/>
               </a:rPr>
-              <a:t>2</a:t>
+              <a:t>5</a:t>
             </a:r>
             <a:endParaRPr lang="en-US" sz="850" dirty="0"/>
           </a:p>
@@ -2306,13 +2597,13 @@
       </p:sp>
       <p:sp>
         <p:nvSpPr>
-          <p:cNvPr id="37" name="Text 35"/>
-          <p:cNvSpPr/>
-          <p:nvPr/>
-        </p:nvSpPr>
-        <p:spPr>
-          <a:xfrm>
-            <a:off x="3840480" y="2432304"/>
+          <p:cNvPr id="46" name="Text 40"/>
+          <p:cNvSpPr/>
+          <p:nvPr/>
+        </p:nvSpPr>
+        <p:spPr>
+          <a:xfrm>
+            <a:off x="5760720" y="2697480"/>
             <a:ext cx="219456" cy="219456"/>
           </a:xfrm>
           <a:prstGeom prst="ellipse">
@@ -2339,34 +2630,110 @@
                 <a:ea typeface="Arial" pitchFamily="34" charset="-122"/>
                 <a:cs typeface="Arial" pitchFamily="34" charset="-120"/>
               </a:rPr>
-              <a:t>3</a:t>
+              <a:t>6</a:t>
             </a:r>
             <a:endParaRPr lang="en-US" sz="850" dirty="0"/>
           </a:p>
         </p:txBody>
       </p:sp>
-      <p:sp>
-        <p:nvSpPr>
-          <p:cNvPr id="38" name="Text 36"/>
-          <p:cNvSpPr/>
-          <p:nvPr/>
-        </p:nvSpPr>
-        <p:spPr>
-          <a:xfrm>
-            <a:off x="6263640" y="1463040"/>
-            <a:ext cx="1600200" cy="822960"/>
-          </a:xfrm>
-          <a:prstGeom prst="rect">
-            <a:avLst/>
-          </a:prstGeom>
-          <a:solidFill>
-            <a:srgbClr val="ECE3FB"/>
-          </a:solidFill>
-          <a:ln w="12700">
-            <a:solidFill>
-              <a:srgbClr val="7C3AED"/>
-            </a:solidFill>
-          </a:ln>
+      <p:pic>
+        <p:nvPicPr>
+          <p:cNvPr id="47" name="Image 4" descr="/Users/mdsherif/Library/CloudStorage/WorkDocsDrive-Documents/MyMac/06Tools/24-ai-devops-amp/docs/diagrams/icons/AWSSecretsManager.png">    </p:cNvPr>
+          <p:cNvPicPr>
+            <a:picLocks noChangeAspect="1"/>
+          </p:cNvPicPr>
+          <p:nvPr/>
+        </p:nvPicPr>
+        <p:blipFill>
+          <a:blip r:embed="rId5"/>
+          <a:stretch>
+            <a:fillRect/>
+          </a:stretch>
+        </p:blipFill>
+        <p:spPr>
+          <a:xfrm>
+            <a:off x="4434840" y="3246120"/>
+            <a:ext cx="457200" cy="457200"/>
+          </a:xfrm>
+          <a:prstGeom prst="rect">
+            <a:avLst/>
+          </a:prstGeom>
+        </p:spPr>
+      </p:pic>
+      <p:sp>
+        <p:nvSpPr>
+          <p:cNvPr id="48" name="Text 41"/>
+          <p:cNvSpPr/>
+          <p:nvPr/>
+        </p:nvSpPr>
+        <p:spPr>
+          <a:xfrm>
+            <a:off x="3794760" y="3712464"/>
+            <a:ext cx="1737360" cy="365760"/>
+          </a:xfrm>
+          <a:prstGeom prst="rect">
+            <a:avLst/>
+          </a:prstGeom>
+          <a:noFill/>
+          <a:ln/>
+        </p:spPr>
+        <p:txBody>
+          <a:bodyPr wrap="square" rtlCol="0" anchor="t"/>
+          <a:lstStyle/>
+          <a:p>
+            <a:pPr algn="ctr" indent="0" marL="0">
+              <a:buNone/>
+            </a:pPr>
+            <a:r>
+              <a:rPr lang="en-US" sz="800" dirty="0">
+                <a:solidFill>
+                  <a:srgbClr val="232F3E"/>
+                </a:solidFill>
+                <a:latin typeface="Arial" pitchFamily="34" charset="0"/>
+                <a:ea typeface="Arial" pitchFamily="34" charset="-122"/>
+                <a:cs typeface="Arial" pitchFamily="34" charset="-120"/>
+              </a:rPr>
+              <a:t>AWS Secrets Manager</a:t>
+            </a:r>
+            <a:endParaRPr lang="en-US" sz="800" dirty="0"/>
+          </a:p>
+          <a:p>
+            <a:pPr algn="ctr" indent="0" marL="0">
+              <a:buNone/>
+            </a:pPr>
+            <a:r>
+              <a:rPr lang="en-US" sz="800" dirty="0">
+                <a:solidFill>
+                  <a:srgbClr val="232F3E"/>
+                </a:solidFill>
+                <a:latin typeface="Arial" pitchFamily="34" charset="0"/>
+                <a:ea typeface="Arial" pitchFamily="34" charset="-122"/>
+                <a:cs typeface="Arial" pitchFamily="34" charset="-120"/>
+              </a:rPr>
+              <a:t>agent webhook url+token</a:t>
+            </a:r>
+            <a:endParaRPr lang="en-US" sz="800" dirty="0"/>
+          </a:p>
+        </p:txBody>
+      </p:sp>
+      <p:sp>
+        <p:nvSpPr>
+          <p:cNvPr id="49" name="Text 42"/>
+          <p:cNvSpPr/>
+          <p:nvPr/>
+        </p:nvSpPr>
+        <p:spPr>
+          <a:xfrm>
+            <a:off x="5257800" y="3200400"/>
+            <a:ext cx="219456" cy="219456"/>
+          </a:xfrm>
+          <a:prstGeom prst="ellipse">
+            <a:avLst/>
+          </a:prstGeom>
+          <a:solidFill>
+            <a:srgbClr val="FF9900"/>
+          </a:solidFill>
+          <a:ln/>
         </p:spPr>
         <p:txBody>
           <a:bodyPr wrap="square" rtlCol="0" anchor="ctr"/>
@@ -2378,30 +2745,238 @@
             <a:r>
               <a:rPr lang="en-US" sz="850" b="1" dirty="0">
                 <a:solidFill>
+                  <a:srgbClr val="FFFFFF"/>
+                </a:solidFill>
+                <a:latin typeface="Arial" pitchFamily="34" charset="0"/>
+                <a:ea typeface="Arial" pitchFamily="34" charset="-122"/>
+                <a:cs typeface="Arial" pitchFamily="34" charset="-120"/>
+              </a:rPr>
+              <a:t>7</a:t>
+            </a:r>
+            <a:endParaRPr lang="en-US" sz="850" dirty="0"/>
+          </a:p>
+        </p:txBody>
+      </p:sp>
+      <p:pic>
+        <p:nvPicPr>
+          <p:cNvPr id="50" name="Image 5" descr="/Users/mdsherif/Library/CloudStorage/WorkDocsDrive-Documents/MyMac/06Tools/24-ai-devops-amp/docs/diagrams/icons/AWSDevOpsAgent.png">    </p:cNvPr>
+          <p:cNvPicPr>
+            <a:picLocks noChangeAspect="1"/>
+          </p:cNvPicPr>
+          <p:nvPr/>
+        </p:nvPicPr>
+        <p:blipFill>
+          <a:blip r:embed="rId6"/>
+          <a:stretch>
+            <a:fillRect/>
+          </a:stretch>
+        </p:blipFill>
+        <p:spPr>
+          <a:xfrm>
+            <a:off x="6812280" y="4069080"/>
+            <a:ext cx="457200" cy="457200"/>
+          </a:xfrm>
+          <a:prstGeom prst="rect">
+            <a:avLst/>
+          </a:prstGeom>
+        </p:spPr>
+      </p:pic>
+      <p:sp>
+        <p:nvSpPr>
+          <p:cNvPr id="51" name="Text 43"/>
+          <p:cNvSpPr/>
+          <p:nvPr/>
+        </p:nvSpPr>
+        <p:spPr>
+          <a:xfrm>
+            <a:off x="6172200" y="4535424"/>
+            <a:ext cx="1737360" cy="365760"/>
+          </a:xfrm>
+          <a:prstGeom prst="rect">
+            <a:avLst/>
+          </a:prstGeom>
+          <a:noFill/>
+          <a:ln/>
+        </p:spPr>
+        <p:txBody>
+          <a:bodyPr wrap="square" rtlCol="0" anchor="t"/>
+          <a:lstStyle/>
+          <a:p>
+            <a:pPr algn="ctr" indent="0" marL="0">
+              <a:buNone/>
+            </a:pPr>
+            <a:r>
+              <a:rPr lang="en-US" sz="800" dirty="0">
+                <a:solidFill>
                   <a:srgbClr val="232F3E"/>
                 </a:solidFill>
                 <a:latin typeface="Arial" pitchFamily="34" charset="0"/>
                 <a:ea typeface="Arial" pitchFamily="34" charset="-122"/>
                 <a:cs typeface="Arial" pitchFamily="34" charset="-120"/>
               </a:rPr>
-              <a:t>Amazon SNS</a:t>
+              <a:t>AWS DevOps Agent</a:t>
+            </a:r>
+            <a:endParaRPr lang="en-US" sz="800" dirty="0"/>
+          </a:p>
+          <a:p>
+            <a:pPr algn="ctr" indent="0" marL="0">
+              <a:buNone/>
+            </a:pPr>
+            <a:r>
+              <a:rPr lang="en-US" sz="800" dirty="0">
+                <a:solidFill>
+                  <a:srgbClr val="232F3E"/>
+                </a:solidFill>
+                <a:latin typeface="Arial" pitchFamily="34" charset="0"/>
+                <a:ea typeface="Arial" pitchFamily="34" charset="-122"/>
+                <a:cs typeface="Arial" pitchFamily="34" charset="-120"/>
+              </a:rPr>
+              <a:t>autonomous investigation</a:t>
+            </a:r>
+            <a:endParaRPr lang="en-US" sz="800" dirty="0"/>
+          </a:p>
+        </p:txBody>
+      </p:sp>
+      <p:sp>
+        <p:nvSpPr>
+          <p:cNvPr id="52" name="Text 44"/>
+          <p:cNvSpPr/>
+          <p:nvPr/>
+        </p:nvSpPr>
+        <p:spPr>
+          <a:xfrm>
+            <a:off x="6035040" y="4123944"/>
+            <a:ext cx="219456" cy="219456"/>
+          </a:xfrm>
+          <a:prstGeom prst="ellipse">
+            <a:avLst/>
+          </a:prstGeom>
+          <a:solidFill>
+            <a:srgbClr val="FF9900"/>
+          </a:solidFill>
+          <a:ln/>
+        </p:spPr>
+        <p:txBody>
+          <a:bodyPr wrap="square" rtlCol="0" anchor="ctr"/>
+          <a:lstStyle/>
+          <a:p>
+            <a:pPr algn="ctr" indent="0" marL="0">
+              <a:buNone/>
+            </a:pPr>
+            <a:r>
+              <a:rPr lang="en-US" sz="850" b="1" dirty="0">
+                <a:solidFill>
+                  <a:srgbClr val="FFFFFF"/>
+                </a:solidFill>
+                <a:latin typeface="Arial" pitchFamily="34" charset="0"/>
+                <a:ea typeface="Arial" pitchFamily="34" charset="-122"/>
+                <a:cs typeface="Arial" pitchFamily="34" charset="-120"/>
+              </a:rPr>
+              <a:t>8</a:t>
             </a:r>
             <a:endParaRPr lang="en-US" sz="850" dirty="0"/>
           </a:p>
+        </p:txBody>
+      </p:sp>
+      <p:pic>
+        <p:nvPicPr>
+          <p:cNvPr id="53" name="Image 6" descr="/Users/mdsherif/Library/CloudStorage/WorkDocsDrive-Documents/MyMac/06Tools/24-ai-devops-amp/docs/diagrams/icons/AmazonSageMaker.png">    </p:cNvPr>
+          <p:cNvPicPr>
+            <a:picLocks noChangeAspect="1"/>
+          </p:cNvPicPr>
+          <p:nvPr/>
+        </p:nvPicPr>
+        <p:blipFill>
+          <a:blip r:embed="rId7"/>
+          <a:stretch>
+            <a:fillRect/>
+          </a:stretch>
+        </p:blipFill>
+        <p:spPr>
+          <a:xfrm>
+            <a:off x="1600200" y="4709160"/>
+            <a:ext cx="457200" cy="457200"/>
+          </a:xfrm>
+          <a:prstGeom prst="rect">
+            <a:avLst/>
+          </a:prstGeom>
+        </p:spPr>
+      </p:pic>
+      <p:sp>
+        <p:nvSpPr>
+          <p:cNvPr id="54" name="Text 45"/>
+          <p:cNvSpPr/>
+          <p:nvPr/>
+        </p:nvSpPr>
+        <p:spPr>
+          <a:xfrm>
+            <a:off x="777240" y="5175504"/>
+            <a:ext cx="2103120" cy="365760"/>
+          </a:xfrm>
+          <a:prstGeom prst="rect">
+            <a:avLst/>
+          </a:prstGeom>
+          <a:noFill/>
+          <a:ln/>
+        </p:spPr>
+        <p:txBody>
+          <a:bodyPr wrap="square" rtlCol="0" anchor="t"/>
+          <a:lstStyle/>
           <a:p>
             <a:pPr algn="ctr" indent="0" marL="0">
               <a:buNone/>
             </a:pPr>
             <a:r>
+              <a:rPr lang="en-US" sz="800" dirty="0">
+                <a:solidFill>
+                  <a:srgbClr val="232F3E"/>
+                </a:solidFill>
+                <a:latin typeface="Arial" pitchFamily="34" charset="0"/>
+                <a:ea typeface="Arial" pitchFamily="34" charset="-122"/>
+                <a:cs typeface="Arial" pitchFamily="34" charset="-120"/>
+              </a:rPr>
+              <a:t>Amazon SageMaker — Demo notebook</a:t>
+            </a:r>
+            <a:endParaRPr lang="en-US" sz="800" dirty="0"/>
+          </a:p>
+        </p:txBody>
+      </p:sp>
+      <p:sp>
+        <p:nvSpPr>
+          <p:cNvPr id="55" name="Text 46"/>
+          <p:cNvSpPr/>
+          <p:nvPr/>
+        </p:nvSpPr>
+        <p:spPr>
+          <a:xfrm>
+            <a:off x="603504" y="4736592"/>
+            <a:ext cx="219456" cy="219456"/>
+          </a:xfrm>
+          <a:prstGeom prst="ellipse">
+            <a:avLst/>
+          </a:prstGeom>
+          <a:solidFill>
+            <a:srgbClr val="FF9900"/>
+          </a:solidFill>
+          <a:ln/>
+        </p:spPr>
+        <p:txBody>
+          <a:bodyPr wrap="square" rtlCol="0" anchor="ctr"/>
+          <a:lstStyle/>
+          <a:p>
+            <a:pPr algn="ctr" indent="0" marL="0">
+              <a:buNone/>
+            </a:pPr>
+            <a:r>
               <a:rPr lang="en-US" sz="850" b="1" dirty="0">
                 <a:solidFill>
-                  <a:srgbClr val="232F3E"/>
-                </a:solidFill>
-                <a:latin typeface="Arial" pitchFamily="34" charset="0"/>
-                <a:ea typeface="Arial" pitchFamily="34" charset="-122"/>
-                <a:cs typeface="Arial" pitchFamily="34" charset="-120"/>
-              </a:rPr>
-              <a:t>RCA trigger topic</a:t>
+                  <a:srgbClr val="FFFFFF"/>
+                </a:solidFill>
+                <a:latin typeface="Arial" pitchFamily="34" charset="0"/>
+                <a:ea typeface="Arial" pitchFamily="34" charset="-122"/>
+                <a:cs typeface="Arial" pitchFamily="34" charset="-120"/>
+              </a:rPr>
+              <a:t>9</a:t>
             </a:r>
             <a:endParaRPr lang="en-US" sz="850" dirty="0"/>
           </a:p>
@@ -2409,515 +2984,21 @@
       </p:sp>
       <p:sp>
         <p:nvSpPr>
-          <p:cNvPr id="39" name="Text 37"/>
-          <p:cNvSpPr/>
-          <p:nvPr/>
-        </p:nvSpPr>
-        <p:spPr>
-          <a:xfrm>
-            <a:off x="6089904" y="1517904"/>
-            <a:ext cx="219456" cy="219456"/>
-          </a:xfrm>
-          <a:prstGeom prst="ellipse">
-            <a:avLst/>
-          </a:prstGeom>
-          <a:solidFill>
-            <a:srgbClr val="FF9900"/>
-          </a:solidFill>
-          <a:ln/>
-        </p:spPr>
-        <p:txBody>
-          <a:bodyPr wrap="square" rtlCol="0" anchor="ctr"/>
-          <a:lstStyle/>
-          <a:p>
-            <a:pPr algn="ctr" indent="0" marL="0">
-              <a:buNone/>
-            </a:pPr>
-            <a:r>
-              <a:rPr lang="en-US" sz="850" b="1" dirty="0">
-                <a:solidFill>
-                  <a:srgbClr val="FFFFFF"/>
-                </a:solidFill>
-                <a:latin typeface="Arial" pitchFamily="34" charset="0"/>
-                <a:ea typeface="Arial" pitchFamily="34" charset="-122"/>
-                <a:cs typeface="Arial" pitchFamily="34" charset="-120"/>
-              </a:rPr>
-              <a:t>4</a:t>
-            </a:r>
-            <a:endParaRPr lang="en-US" sz="850" dirty="0"/>
-          </a:p>
-        </p:txBody>
-      </p:sp>
-      <p:sp>
-        <p:nvSpPr>
-          <p:cNvPr id="40" name="Text 38"/>
-          <p:cNvSpPr/>
-          <p:nvPr/>
-        </p:nvSpPr>
-        <p:spPr>
-          <a:xfrm>
-            <a:off x="6263640" y="2743200"/>
-            <a:ext cx="1600200" cy="822960"/>
-          </a:xfrm>
-          <a:prstGeom prst="rect">
-            <a:avLst/>
-          </a:prstGeom>
-          <a:solidFill>
-            <a:srgbClr val="FFE9CC"/>
-          </a:solidFill>
-          <a:ln w="12700">
-            <a:solidFill>
-              <a:srgbClr val="FF9900"/>
-            </a:solidFill>
-          </a:ln>
-        </p:spPr>
-        <p:txBody>
-          <a:bodyPr wrap="square" rtlCol="0" anchor="ctr"/>
-          <a:lstStyle/>
-          <a:p>
-            <a:pPr algn="ctr" indent="0" marL="0">
-              <a:buNone/>
-            </a:pPr>
-            <a:r>
-              <a:rPr lang="en-US" sz="850" b="1" dirty="0">
-                <a:solidFill>
-                  <a:srgbClr val="232F3E"/>
-                </a:solidFill>
-                <a:latin typeface="Arial" pitchFamily="34" charset="0"/>
-                <a:ea typeface="Arial" pitchFamily="34" charset="-122"/>
-                <a:cs typeface="Arial" pitchFamily="34" charset="-120"/>
-              </a:rPr>
-              <a:t>AWS Lambda</a:t>
-            </a:r>
-            <a:endParaRPr lang="en-US" sz="850" dirty="0"/>
-          </a:p>
-          <a:p>
-            <a:pPr algn="ctr" indent="0" marL="0">
-              <a:buNone/>
-            </a:pPr>
-            <a:r>
-              <a:rPr lang="en-US" sz="850" b="1" dirty="0">
-                <a:solidFill>
-                  <a:srgbClr val="232F3E"/>
-                </a:solidFill>
-                <a:latin typeface="Arial" pitchFamily="34" charset="0"/>
-                <a:ea typeface="Arial" pitchFamily="34" charset="-122"/>
-                <a:cs typeface="Arial" pitchFamily="34" charset="-120"/>
-              </a:rPr>
-              <a:t>Root-cause analysis</a:t>
-            </a:r>
-            <a:endParaRPr lang="en-US" sz="850" dirty="0"/>
-          </a:p>
-        </p:txBody>
-      </p:sp>
-      <p:sp>
-        <p:nvSpPr>
-          <p:cNvPr id="41" name="Text 39"/>
-          <p:cNvSpPr/>
-          <p:nvPr/>
-        </p:nvSpPr>
-        <p:spPr>
-          <a:xfrm>
-            <a:off x="6089904" y="2798064"/>
-            <a:ext cx="219456" cy="219456"/>
-          </a:xfrm>
-          <a:prstGeom prst="ellipse">
-            <a:avLst/>
-          </a:prstGeom>
-          <a:solidFill>
-            <a:srgbClr val="FF9900"/>
-          </a:solidFill>
-          <a:ln/>
-        </p:spPr>
-        <p:txBody>
-          <a:bodyPr wrap="square" rtlCol="0" anchor="ctr"/>
-          <a:lstStyle/>
-          <a:p>
-            <a:pPr algn="ctr" indent="0" marL="0">
-              <a:buNone/>
-            </a:pPr>
-            <a:r>
-              <a:rPr lang="en-US" sz="850" b="1" dirty="0">
-                <a:solidFill>
-                  <a:srgbClr val="FFFFFF"/>
-                </a:solidFill>
-                <a:latin typeface="Arial" pitchFamily="34" charset="0"/>
-                <a:ea typeface="Arial" pitchFamily="34" charset="-122"/>
-                <a:cs typeface="Arial" pitchFamily="34" charset="-120"/>
-              </a:rPr>
-              <a:t>5</a:t>
-            </a:r>
-            <a:endParaRPr lang="en-US" sz="850" dirty="0"/>
-          </a:p>
-        </p:txBody>
-      </p:sp>
-      <p:sp>
-        <p:nvSpPr>
-          <p:cNvPr id="42" name="Text 40"/>
-          <p:cNvSpPr/>
-          <p:nvPr/>
-        </p:nvSpPr>
-        <p:spPr>
-          <a:xfrm>
-            <a:off x="5943600" y="2651760"/>
-            <a:ext cx="219456" cy="219456"/>
-          </a:xfrm>
-          <a:prstGeom prst="ellipse">
-            <a:avLst/>
-          </a:prstGeom>
-          <a:solidFill>
-            <a:srgbClr val="FF9900"/>
-          </a:solidFill>
-          <a:ln/>
-        </p:spPr>
-        <p:txBody>
-          <a:bodyPr wrap="square" rtlCol="0" anchor="ctr"/>
-          <a:lstStyle/>
-          <a:p>
-            <a:pPr algn="ctr" indent="0" marL="0">
-              <a:buNone/>
-            </a:pPr>
-            <a:r>
-              <a:rPr lang="en-US" sz="850" b="1" dirty="0">
-                <a:solidFill>
-                  <a:srgbClr val="FFFFFF"/>
-                </a:solidFill>
-                <a:latin typeface="Arial" pitchFamily="34" charset="0"/>
-                <a:ea typeface="Arial" pitchFamily="34" charset="-122"/>
-                <a:cs typeface="Arial" pitchFamily="34" charset="-120"/>
-              </a:rPr>
-              <a:t>6</a:t>
-            </a:r>
-            <a:endParaRPr lang="en-US" sz="850" dirty="0"/>
-          </a:p>
-        </p:txBody>
-      </p:sp>
-      <p:sp>
-        <p:nvSpPr>
-          <p:cNvPr id="43" name="Text 41"/>
-          <p:cNvSpPr/>
-          <p:nvPr/>
-        </p:nvSpPr>
-        <p:spPr>
-          <a:xfrm>
-            <a:off x="3794760" y="3246120"/>
-            <a:ext cx="1783080" cy="731520"/>
-          </a:xfrm>
-          <a:prstGeom prst="rect">
-            <a:avLst/>
-          </a:prstGeom>
-          <a:solidFill>
-            <a:srgbClr val="FBE2DC"/>
-          </a:solidFill>
-          <a:ln w="12700">
-            <a:solidFill>
-              <a:srgbClr val="D13212"/>
-            </a:solidFill>
-          </a:ln>
-        </p:spPr>
-        <p:txBody>
-          <a:bodyPr wrap="square" rtlCol="0" anchor="ctr"/>
-          <a:lstStyle/>
-          <a:p>
-            <a:pPr algn="ctr" indent="0" marL="0">
-              <a:buNone/>
-            </a:pPr>
-            <a:r>
-              <a:rPr lang="en-US" sz="800" b="1" dirty="0">
-                <a:solidFill>
-                  <a:srgbClr val="232F3E"/>
-                </a:solidFill>
-                <a:latin typeface="Arial" pitchFamily="34" charset="0"/>
-                <a:ea typeface="Arial" pitchFamily="34" charset="-122"/>
-                <a:cs typeface="Arial" pitchFamily="34" charset="-120"/>
-              </a:rPr>
-              <a:t>AWS Secrets Manager</a:t>
-            </a:r>
-            <a:endParaRPr lang="en-US" sz="800" dirty="0"/>
-          </a:p>
-          <a:p>
-            <a:pPr algn="ctr" indent="0" marL="0">
-              <a:buNone/>
-            </a:pPr>
-            <a:r>
-              <a:rPr lang="en-US" sz="800" b="1" dirty="0">
-                <a:solidFill>
-                  <a:srgbClr val="232F3E"/>
-                </a:solidFill>
-                <a:latin typeface="Arial" pitchFamily="34" charset="0"/>
-                <a:ea typeface="Arial" pitchFamily="34" charset="-122"/>
-                <a:cs typeface="Arial" pitchFamily="34" charset="-120"/>
-              </a:rPr>
-              <a:t>agent webhook url + token</a:t>
-            </a:r>
-            <a:endParaRPr lang="en-US" sz="800" dirty="0"/>
-          </a:p>
-        </p:txBody>
-      </p:sp>
-      <p:sp>
-        <p:nvSpPr>
-          <p:cNvPr id="44" name="Text 42"/>
-          <p:cNvSpPr/>
-          <p:nvPr/>
-        </p:nvSpPr>
-        <p:spPr>
-          <a:xfrm>
-            <a:off x="5394960" y="3200400"/>
-            <a:ext cx="219456" cy="219456"/>
-          </a:xfrm>
-          <a:prstGeom prst="ellipse">
-            <a:avLst/>
-          </a:prstGeom>
-          <a:solidFill>
-            <a:srgbClr val="FF9900"/>
-          </a:solidFill>
-          <a:ln/>
-        </p:spPr>
-        <p:txBody>
-          <a:bodyPr wrap="square" rtlCol="0" anchor="ctr"/>
-          <a:lstStyle/>
-          <a:p>
-            <a:pPr algn="ctr" indent="0" marL="0">
-              <a:buNone/>
-            </a:pPr>
-            <a:r>
-              <a:rPr lang="en-US" sz="850" b="1" dirty="0">
-                <a:solidFill>
-                  <a:srgbClr val="FFFFFF"/>
-                </a:solidFill>
-                <a:latin typeface="Arial" pitchFamily="34" charset="0"/>
-                <a:ea typeface="Arial" pitchFamily="34" charset="-122"/>
-                <a:cs typeface="Arial" pitchFamily="34" charset="-120"/>
-              </a:rPr>
-              <a:t>7</a:t>
-            </a:r>
-            <a:endParaRPr lang="en-US" sz="850" dirty="0"/>
-          </a:p>
-        </p:txBody>
-      </p:sp>
-      <p:sp>
-        <p:nvSpPr>
-          <p:cNvPr id="45" name="Text 43"/>
-          <p:cNvSpPr/>
-          <p:nvPr/>
-        </p:nvSpPr>
-        <p:spPr>
-          <a:xfrm>
-            <a:off x="6263640" y="4069080"/>
-            <a:ext cx="1600200" cy="822960"/>
-          </a:xfrm>
-          <a:prstGeom prst="rect">
-            <a:avLst/>
-          </a:prstGeom>
-          <a:solidFill>
-            <a:srgbClr val="ECE3FB"/>
-          </a:solidFill>
-          <a:ln w="12700">
-            <a:solidFill>
-              <a:srgbClr val="7C3AED"/>
-            </a:solidFill>
-          </a:ln>
-        </p:spPr>
-        <p:txBody>
-          <a:bodyPr wrap="square" rtlCol="0" anchor="ctr"/>
-          <a:lstStyle/>
-          <a:p>
-            <a:pPr algn="ctr" indent="0" marL="0">
-              <a:buNone/>
-            </a:pPr>
-            <a:r>
-              <a:rPr lang="en-US" sz="850" b="1" dirty="0">
-                <a:solidFill>
-                  <a:srgbClr val="232F3E"/>
-                </a:solidFill>
-                <a:latin typeface="Arial" pitchFamily="34" charset="0"/>
-                <a:ea typeface="Arial" pitchFamily="34" charset="-122"/>
-                <a:cs typeface="Arial" pitchFamily="34" charset="-120"/>
-              </a:rPr>
-              <a:t>AWS DevOps Agent</a:t>
-            </a:r>
-            <a:endParaRPr lang="en-US" sz="850" dirty="0"/>
-          </a:p>
-          <a:p>
-            <a:pPr algn="ctr" indent="0" marL="0">
-              <a:buNone/>
-            </a:pPr>
-            <a:r>
-              <a:rPr lang="en-US" sz="850" b="1" dirty="0">
-                <a:solidFill>
-                  <a:srgbClr val="232F3E"/>
-                </a:solidFill>
-                <a:latin typeface="Arial" pitchFamily="34" charset="0"/>
-                <a:ea typeface="Arial" pitchFamily="34" charset="-122"/>
-                <a:cs typeface="Arial" pitchFamily="34" charset="-120"/>
-              </a:rPr>
-              <a:t>autonomous investigation</a:t>
-            </a:r>
-            <a:endParaRPr lang="en-US" sz="850" dirty="0"/>
-          </a:p>
-        </p:txBody>
-      </p:sp>
-      <p:sp>
-        <p:nvSpPr>
-          <p:cNvPr id="46" name="Text 44"/>
-          <p:cNvSpPr/>
-          <p:nvPr/>
-        </p:nvSpPr>
-        <p:spPr>
-          <a:xfrm>
-            <a:off x="6089904" y="4123944"/>
-            <a:ext cx="219456" cy="219456"/>
-          </a:xfrm>
-          <a:prstGeom prst="ellipse">
-            <a:avLst/>
-          </a:prstGeom>
-          <a:solidFill>
-            <a:srgbClr val="FF9900"/>
-          </a:solidFill>
-          <a:ln/>
-        </p:spPr>
-        <p:txBody>
-          <a:bodyPr wrap="square" rtlCol="0" anchor="ctr"/>
-          <a:lstStyle/>
-          <a:p>
-            <a:pPr algn="ctr" indent="0" marL="0">
-              <a:buNone/>
-            </a:pPr>
-            <a:r>
-              <a:rPr lang="en-US" sz="850" b="1" dirty="0">
-                <a:solidFill>
-                  <a:srgbClr val="FFFFFF"/>
-                </a:solidFill>
-                <a:latin typeface="Arial" pitchFamily="34" charset="0"/>
-                <a:ea typeface="Arial" pitchFamily="34" charset="-122"/>
-                <a:cs typeface="Arial" pitchFamily="34" charset="-120"/>
-              </a:rPr>
-              <a:t>8</a:t>
-            </a:r>
-            <a:endParaRPr lang="en-US" sz="850" dirty="0"/>
-          </a:p>
-        </p:txBody>
-      </p:sp>
-      <p:sp>
-        <p:nvSpPr>
-          <p:cNvPr id="47" name="Text 45"/>
-          <p:cNvSpPr/>
-          <p:nvPr/>
-        </p:nvSpPr>
-        <p:spPr>
-          <a:xfrm>
-            <a:off x="640080" y="4663440"/>
-            <a:ext cx="2377440" cy="822960"/>
-          </a:xfrm>
-          <a:prstGeom prst="rect">
-            <a:avLst/>
-          </a:prstGeom>
-          <a:solidFill>
-            <a:srgbClr val="DCEBFA"/>
-          </a:solidFill>
-          <a:ln w="12700">
-            <a:solidFill>
-              <a:srgbClr val="0972D3"/>
-            </a:solidFill>
-          </a:ln>
-        </p:spPr>
-        <p:txBody>
-          <a:bodyPr wrap="square" rtlCol="0" anchor="ctr"/>
-          <a:lstStyle/>
-          <a:p>
-            <a:pPr algn="ctr" indent="0" marL="0">
-              <a:buNone/>
-            </a:pPr>
-            <a:r>
-              <a:rPr lang="en-US" sz="850" b="1" dirty="0">
-                <a:solidFill>
-                  <a:srgbClr val="232F3E"/>
-                </a:solidFill>
-                <a:latin typeface="Arial" pitchFamily="34" charset="0"/>
-                <a:ea typeface="Arial" pitchFamily="34" charset="-122"/>
-                <a:cs typeface="Arial" pitchFamily="34" charset="-120"/>
-              </a:rPr>
-              <a:t>Amazon SageMaker</a:t>
-            </a:r>
-            <a:endParaRPr lang="en-US" sz="850" dirty="0"/>
-          </a:p>
-          <a:p>
-            <a:pPr algn="ctr" indent="0" marL="0">
-              <a:buNone/>
-            </a:pPr>
-            <a:r>
-              <a:rPr lang="en-US" sz="850" b="1" dirty="0">
-                <a:solidFill>
-                  <a:srgbClr val="232F3E"/>
-                </a:solidFill>
-                <a:latin typeface="Arial" pitchFamily="34" charset="0"/>
-                <a:ea typeface="Arial" pitchFamily="34" charset="-122"/>
-                <a:cs typeface="Arial" pitchFamily="34" charset="-120"/>
-              </a:rPr>
-              <a:t>Demo notebook</a:t>
-            </a:r>
-            <a:endParaRPr lang="en-US" sz="850" dirty="0"/>
-          </a:p>
-        </p:txBody>
-      </p:sp>
-      <p:sp>
-        <p:nvSpPr>
-          <p:cNvPr id="48" name="Text 46"/>
-          <p:cNvSpPr/>
-          <p:nvPr/>
-        </p:nvSpPr>
-        <p:spPr>
-          <a:xfrm>
-            <a:off x="512064" y="4718304"/>
-            <a:ext cx="219456" cy="219456"/>
-          </a:xfrm>
-          <a:prstGeom prst="ellipse">
-            <a:avLst/>
-          </a:prstGeom>
-          <a:solidFill>
-            <a:srgbClr val="FF9900"/>
-          </a:solidFill>
-          <a:ln/>
-        </p:spPr>
-        <p:txBody>
-          <a:bodyPr wrap="square" rtlCol="0" anchor="ctr"/>
-          <a:lstStyle/>
-          <a:p>
-            <a:pPr algn="ctr" indent="0" marL="0">
-              <a:buNone/>
-            </a:pPr>
-            <a:r>
-              <a:rPr lang="en-US" sz="850" b="1" dirty="0">
-                <a:solidFill>
-                  <a:srgbClr val="FFFFFF"/>
-                </a:solidFill>
-                <a:latin typeface="Arial" pitchFamily="34" charset="0"/>
-                <a:ea typeface="Arial" pitchFamily="34" charset="-122"/>
-                <a:cs typeface="Arial" pitchFamily="34" charset="-120"/>
-              </a:rPr>
-              <a:t>9</a:t>
-            </a:r>
-            <a:endParaRPr lang="en-US" sz="850" dirty="0"/>
-          </a:p>
-        </p:txBody>
-      </p:sp>
-      <p:sp>
-        <p:nvSpPr>
-          <p:cNvPr id="49" name="Shape 47"/>
-          <p:cNvSpPr/>
-          <p:nvPr/>
-        </p:nvSpPr>
-        <p:spPr>
-          <a:xfrm>
-            <a:off x="4937760" y="5074920"/>
-            <a:ext cx="2926080" cy="1188720"/>
-          </a:xfrm>
-          <a:prstGeom prst="rect">
-            <a:avLst/>
-          </a:prstGeom>
-          <a:solidFill>
-            <a:srgbClr val="ECE3FB">
-              <a:alpha val="40000"/>
+          <p:cNvPr id="56" name="Shape 47"/>
+          <p:cNvSpPr/>
+          <p:nvPr/>
+        </p:nvSpPr>
+        <p:spPr>
+          <a:xfrm>
+            <a:off x="4892040" y="5029200"/>
+            <a:ext cx="2971800" cy="1280160"/>
+          </a:xfrm>
+          <a:prstGeom prst="rect">
+            <a:avLst/>
+          </a:prstGeom>
+          <a:solidFill>
+            <a:srgbClr val="F3EEFC">
+              <a:alpha val="65000"/>
             </a:srgbClr>
           </a:solidFill>
           <a:ln w="12700">
@@ -2930,14 +3011,14 @@
       </p:sp>
       <p:sp>
         <p:nvSpPr>
-          <p:cNvPr id="50" name="Text 48"/>
-          <p:cNvSpPr/>
-          <p:nvPr/>
-        </p:nvSpPr>
-        <p:spPr>
-          <a:xfrm>
-            <a:off x="5010912" y="5102352"/>
-            <a:ext cx="2788920" cy="182880"/>
+          <p:cNvPr id="57" name="Text 48"/>
+          <p:cNvSpPr/>
+          <p:nvPr/>
+        </p:nvSpPr>
+        <p:spPr>
+          <a:xfrm>
+            <a:off x="4965192" y="5056632"/>
+            <a:ext cx="2834640" cy="182880"/>
           </a:xfrm>
           <a:prstGeom prst="rect">
             <a:avLst/>
@@ -2967,38 +3048,56 @@
           </a:p>
         </p:txBody>
       </p:sp>
-      <p:sp>
-        <p:nvSpPr>
-          <p:cNvPr id="51" name="Text 49"/>
-          <p:cNvSpPr/>
-          <p:nvPr/>
-        </p:nvSpPr>
-        <p:spPr>
-          <a:xfrm>
-            <a:off x="5029200" y="5349240"/>
-            <a:ext cx="868680" cy="777240"/>
-          </a:xfrm>
-          <a:prstGeom prst="rect">
-            <a:avLst/>
-          </a:prstGeom>
-          <a:solidFill>
-            <a:srgbClr val="ECE3FB"/>
-          </a:solidFill>
-          <a:ln w="12700">
-            <a:solidFill>
-              <a:srgbClr val="7C3AED"/>
-            </a:solidFill>
-          </a:ln>
-        </p:spPr>
-        <p:txBody>
-          <a:bodyPr wrap="square" rtlCol="0" anchor="ctr"/>
+      <p:pic>
+        <p:nvPicPr>
+          <p:cNvPr id="58" name="Image 7" descr="/Users/mdsherif/Library/CloudStorage/WorkDocsDrive-Documents/MyMac/06Tools/24-ai-devops-amp/docs/diagrams/icons/AmazonCognito.png">    </p:cNvPr>
+          <p:cNvPicPr>
+            <a:picLocks noChangeAspect="1"/>
+          </p:cNvPicPr>
+          <p:nvPr/>
+        </p:nvPicPr>
+        <p:blipFill>
+          <a:blip r:embed="rId8"/>
+          <a:stretch>
+            <a:fillRect/>
+          </a:stretch>
+        </p:blipFill>
+        <p:spPr>
+          <a:xfrm>
+            <a:off x="5166360" y="5285232"/>
+            <a:ext cx="457200" cy="457200"/>
+          </a:xfrm>
+          <a:prstGeom prst="rect">
+            <a:avLst/>
+          </a:prstGeom>
+        </p:spPr>
+      </p:pic>
+      <p:sp>
+        <p:nvSpPr>
+          <p:cNvPr id="59" name="Text 49"/>
+          <p:cNvSpPr/>
+          <p:nvPr/>
+        </p:nvSpPr>
+        <p:spPr>
+          <a:xfrm>
+            <a:off x="4937760" y="5751576"/>
+            <a:ext cx="914400" cy="365760"/>
+          </a:xfrm>
+          <a:prstGeom prst="rect">
+            <a:avLst/>
+          </a:prstGeom>
+          <a:noFill/>
+          <a:ln/>
+        </p:spPr>
+        <p:txBody>
+          <a:bodyPr wrap="square" rtlCol="0" anchor="t"/>
           <a:lstStyle/>
           <a:p>
             <a:pPr algn="ctr" indent="0" marL="0">
               <a:buNone/>
             </a:pPr>
             <a:r>
-              <a:rPr lang="en-US" sz="800" b="1" dirty="0">
+              <a:rPr lang="en-US" sz="750" dirty="0">
                 <a:solidFill>
                   <a:srgbClr val="232F3E"/>
                 </a:solidFill>
@@ -3006,16 +3105,62 @@
                 <a:ea typeface="Arial" pitchFamily="34" charset="-122"/>
                 <a:cs typeface="Arial" pitchFamily="34" charset="-120"/>
               </a:rPr>
-              <a:t>Amazon</a:t>
-            </a:r>
-            <a:endParaRPr lang="en-US" sz="800" dirty="0"/>
-          </a:p>
+              <a:t>Amazon Cognito</a:t>
+            </a:r>
+            <a:endParaRPr lang="en-US" sz="750" dirty="0"/>
+          </a:p>
+        </p:txBody>
+      </p:sp>
+      <p:pic>
+        <p:nvPicPr>
+          <p:cNvPr id="60" name="Image 8" descr="/Users/mdsherif/Library/CloudStorage/WorkDocsDrive-Documents/MyMac/06Tools/24-ai-devops-amp/docs/diagrams/icons/AmazonAPIGateway.png">    </p:cNvPr>
+          <p:cNvPicPr>
+            <a:picLocks noChangeAspect="1"/>
+          </p:cNvPicPr>
+          <p:nvPr/>
+        </p:nvPicPr>
+        <p:blipFill>
+          <a:blip r:embed="rId9"/>
+          <a:stretch>
+            <a:fillRect/>
+          </a:stretch>
+        </p:blipFill>
+        <p:spPr>
+          <a:xfrm>
+            <a:off x="6195060" y="5285232"/>
+            <a:ext cx="457200" cy="457200"/>
+          </a:xfrm>
+          <a:prstGeom prst="rect">
+            <a:avLst/>
+          </a:prstGeom>
+        </p:spPr>
+      </p:pic>
+      <p:sp>
+        <p:nvSpPr>
+          <p:cNvPr id="61" name="Text 50"/>
+          <p:cNvSpPr/>
+          <p:nvPr/>
+        </p:nvSpPr>
+        <p:spPr>
+          <a:xfrm>
+            <a:off x="5943600" y="5751576"/>
+            <a:ext cx="960120" cy="365760"/>
+          </a:xfrm>
+          <a:prstGeom prst="rect">
+            <a:avLst/>
+          </a:prstGeom>
+          <a:noFill/>
+          <a:ln/>
+        </p:spPr>
+        <p:txBody>
+          <a:bodyPr wrap="square" rtlCol="0" anchor="t"/>
+          <a:lstStyle/>
           <a:p>
             <a:pPr algn="ctr" indent="0" marL="0">
               <a:buNone/>
             </a:pPr>
             <a:r>
-              <a:rPr lang="en-US" sz="800" b="1" dirty="0">
+              <a:rPr lang="en-US" sz="750" dirty="0">
                 <a:solidFill>
                   <a:srgbClr val="232F3E"/>
                 </a:solidFill>
@@ -3023,44 +3168,62 @@
                 <a:ea typeface="Arial" pitchFamily="34" charset="-122"/>
                 <a:cs typeface="Arial" pitchFamily="34" charset="-120"/>
               </a:rPr>
-              <a:t>Cognito</a:t>
-            </a:r>
-            <a:endParaRPr lang="en-US" sz="800" dirty="0"/>
-          </a:p>
-        </p:txBody>
-      </p:sp>
-      <p:sp>
-        <p:nvSpPr>
-          <p:cNvPr id="52" name="Text 50"/>
-          <p:cNvSpPr/>
-          <p:nvPr/>
-        </p:nvSpPr>
-        <p:spPr>
-          <a:xfrm>
-            <a:off x="5989320" y="5349240"/>
-            <a:ext cx="914400" cy="777240"/>
-          </a:xfrm>
-          <a:prstGeom prst="rect">
-            <a:avLst/>
-          </a:prstGeom>
-          <a:solidFill>
-            <a:srgbClr val="ECE3FB"/>
-          </a:solidFill>
-          <a:ln w="12700">
-            <a:solidFill>
-              <a:srgbClr val="7C3AED"/>
-            </a:solidFill>
-          </a:ln>
-        </p:spPr>
-        <p:txBody>
-          <a:bodyPr wrap="square" rtlCol="0" anchor="ctr"/>
+              <a:t>Amazon API Gateway</a:t>
+            </a:r>
+            <a:endParaRPr lang="en-US" sz="750" dirty="0"/>
+          </a:p>
+        </p:txBody>
+      </p:sp>
+      <p:pic>
+        <p:nvPicPr>
+          <p:cNvPr id="62" name="Image 9" descr="/Users/mdsherif/Library/CloudStorage/WorkDocsDrive-Documents/MyMac/06Tools/24-ai-devops-amp/docs/diagrams/icons/AWSLambda.png">    </p:cNvPr>
+          <p:cNvPicPr>
+            <a:picLocks noChangeAspect="1"/>
+          </p:cNvPicPr>
+          <p:nvPr/>
+        </p:nvPicPr>
+        <p:blipFill>
+          <a:blip r:embed="rId10"/>
+          <a:stretch>
+            <a:fillRect/>
+          </a:stretch>
+        </p:blipFill>
+        <p:spPr>
+          <a:xfrm>
+            <a:off x="7155180" y="5285232"/>
+            <a:ext cx="457200" cy="457200"/>
+          </a:xfrm>
+          <a:prstGeom prst="rect">
+            <a:avLst/>
+          </a:prstGeom>
+        </p:spPr>
+      </p:pic>
+      <p:sp>
+        <p:nvSpPr>
+          <p:cNvPr id="63" name="Text 51"/>
+          <p:cNvSpPr/>
+          <p:nvPr/>
+        </p:nvSpPr>
+        <p:spPr>
+          <a:xfrm>
+            <a:off x="6949440" y="5751576"/>
+            <a:ext cx="868680" cy="365760"/>
+          </a:xfrm>
+          <a:prstGeom prst="rect">
+            <a:avLst/>
+          </a:prstGeom>
+          <a:noFill/>
+          <a:ln/>
+        </p:spPr>
+        <p:txBody>
+          <a:bodyPr wrap="square" rtlCol="0" anchor="t"/>
           <a:lstStyle/>
           <a:p>
             <a:pPr algn="ctr" indent="0" marL="0">
               <a:buNone/>
             </a:pPr>
             <a:r>
-              <a:rPr lang="en-US" sz="800" b="1" dirty="0">
+              <a:rPr lang="en-US" sz="750" dirty="0">
                 <a:solidFill>
                   <a:srgbClr val="232F3E"/>
                 </a:solidFill>
@@ -3068,101 +3231,22 @@
                 <a:ea typeface="Arial" pitchFamily="34" charset="-122"/>
                 <a:cs typeface="Arial" pitchFamily="34" charset="-120"/>
               </a:rPr>
-              <a:t>Amazon API</a:t>
-            </a:r>
-            <a:endParaRPr lang="en-US" sz="800" dirty="0"/>
-          </a:p>
-          <a:p>
-            <a:pPr algn="ctr" indent="0" marL="0">
-              <a:buNone/>
-            </a:pPr>
-            <a:r>
-              <a:rPr lang="en-US" sz="800" b="1" dirty="0">
-                <a:solidFill>
-                  <a:srgbClr val="232F3E"/>
-                </a:solidFill>
-                <a:latin typeface="Arial" pitchFamily="34" charset="0"/>
-                <a:ea typeface="Arial" pitchFamily="34" charset="-122"/>
-                <a:cs typeface="Arial" pitchFamily="34" charset="-120"/>
-              </a:rPr>
-              <a:t>Gateway</a:t>
-            </a:r>
-            <a:endParaRPr lang="en-US" sz="800" dirty="0"/>
-          </a:p>
-        </p:txBody>
-      </p:sp>
-      <p:sp>
-        <p:nvSpPr>
-          <p:cNvPr id="53" name="Text 51"/>
-          <p:cNvSpPr/>
-          <p:nvPr/>
-        </p:nvSpPr>
-        <p:spPr>
-          <a:xfrm>
-            <a:off x="6995160" y="5349240"/>
-            <a:ext cx="777240" cy="777240"/>
-          </a:xfrm>
-          <a:prstGeom prst="rect">
-            <a:avLst/>
-          </a:prstGeom>
-          <a:solidFill>
-            <a:srgbClr val="FFE9CC"/>
-          </a:solidFill>
-          <a:ln w="12700">
-            <a:solidFill>
-              <a:srgbClr val="FF9900"/>
-            </a:solidFill>
-          </a:ln>
-        </p:spPr>
-        <p:txBody>
-          <a:bodyPr wrap="square" rtlCol="0" anchor="ctr"/>
-          <a:lstStyle/>
-          <a:p>
-            <a:pPr algn="ctr" indent="0" marL="0">
-              <a:buNone/>
-            </a:pPr>
-            <a:r>
-              <a:rPr lang="en-US" sz="800" b="1" dirty="0">
-                <a:solidFill>
-                  <a:srgbClr val="232F3E"/>
-                </a:solidFill>
-                <a:latin typeface="Arial" pitchFamily="34" charset="0"/>
-                <a:ea typeface="Arial" pitchFamily="34" charset="-122"/>
-                <a:cs typeface="Arial" pitchFamily="34" charset="-120"/>
-              </a:rPr>
-              <a:t>AWS</a:t>
-            </a:r>
-            <a:endParaRPr lang="en-US" sz="800" dirty="0"/>
-          </a:p>
-          <a:p>
-            <a:pPr algn="ctr" indent="0" marL="0">
-              <a:buNone/>
-            </a:pPr>
-            <a:r>
-              <a:rPr lang="en-US" sz="800" b="1" dirty="0">
-                <a:solidFill>
-                  <a:srgbClr val="232F3E"/>
-                </a:solidFill>
-                <a:latin typeface="Arial" pitchFamily="34" charset="0"/>
-                <a:ea typeface="Arial" pitchFamily="34" charset="-122"/>
-                <a:cs typeface="Arial" pitchFamily="34" charset="-120"/>
-              </a:rPr>
-              <a:t>Lambda</a:t>
-            </a:r>
-            <a:endParaRPr lang="en-US" sz="800" dirty="0"/>
-          </a:p>
-        </p:txBody>
-      </p:sp>
-      <p:sp>
-        <p:nvSpPr>
-          <p:cNvPr id="54" name="Shape 52"/>
-          <p:cNvSpPr/>
-          <p:nvPr/>
-        </p:nvSpPr>
-        <p:spPr>
-          <a:xfrm>
-            <a:off x="3429000" y="1874520"/>
-            <a:ext cx="365760" cy="0"/>
+              <a:t>AWS Lambda</a:t>
+            </a:r>
+            <a:endParaRPr lang="en-US" sz="750" dirty="0"/>
+          </a:p>
+        </p:txBody>
+      </p:sp>
+      <p:sp>
+        <p:nvSpPr>
+          <p:cNvPr id="64" name="Shape 52"/>
+          <p:cNvSpPr/>
+          <p:nvPr/>
+        </p:nvSpPr>
+        <p:spPr>
+          <a:xfrm>
+            <a:off x="3429000" y="1737360"/>
+            <a:ext cx="274320" cy="0"/>
           </a:xfrm>
           <a:prstGeom prst="line">
             <a:avLst/>
@@ -3179,14 +3263,14 @@
       </p:sp>
       <p:sp>
         <p:nvSpPr>
-          <p:cNvPr id="55" name="Shape 53"/>
-          <p:cNvSpPr/>
-          <p:nvPr/>
-        </p:nvSpPr>
-        <p:spPr>
-          <a:xfrm>
-            <a:off x="5943600" y="1874520"/>
-            <a:ext cx="320040" cy="0"/>
+          <p:cNvPr id="65" name="Shape 53"/>
+          <p:cNvSpPr/>
+          <p:nvPr/>
+        </p:nvSpPr>
+        <p:spPr>
+          <a:xfrm>
+            <a:off x="5989320" y="1737360"/>
+            <a:ext cx="182880" cy="0"/>
           </a:xfrm>
           <a:prstGeom prst="line">
             <a:avLst/>
@@ -3203,14 +3287,14 @@
       </p:sp>
       <p:sp>
         <p:nvSpPr>
-          <p:cNvPr id="56" name="Shape 54"/>
-          <p:cNvSpPr/>
-          <p:nvPr/>
-        </p:nvSpPr>
-        <p:spPr>
-          <a:xfrm>
-            <a:off x="7059168" y="2286000"/>
-            <a:ext cx="0" cy="457200"/>
+          <p:cNvPr id="66" name="Shape 54"/>
+          <p:cNvSpPr/>
+          <p:nvPr/>
+        </p:nvSpPr>
+        <p:spPr>
+          <a:xfrm>
+            <a:off x="7040880" y="2148840"/>
+            <a:ext cx="0" cy="594360"/>
           </a:xfrm>
           <a:prstGeom prst="line">
             <a:avLst/>
@@ -3227,13 +3311,13 @@
       </p:sp>
       <p:sp>
         <p:nvSpPr>
-          <p:cNvPr id="57" name="Shape 55"/>
-          <p:cNvSpPr/>
-          <p:nvPr/>
-        </p:nvSpPr>
-        <p:spPr>
-          <a:xfrm>
-            <a:off x="5943600" y="2880360"/>
+          <p:cNvPr id="67" name="Shape 55"/>
+          <p:cNvSpPr/>
+          <p:nvPr/>
+        </p:nvSpPr>
+        <p:spPr>
+          <a:xfrm>
+            <a:off x="5852160" y="2926080"/>
             <a:ext cx="320040" cy="0"/>
           </a:xfrm>
           <a:prstGeom prst="line">
@@ -3251,14 +3335,14 @@
       </p:sp>
       <p:sp>
         <p:nvSpPr>
-          <p:cNvPr id="58" name="Shape 56"/>
-          <p:cNvSpPr/>
-          <p:nvPr/>
-        </p:nvSpPr>
-        <p:spPr>
-          <a:xfrm>
-            <a:off x="5577840" y="3429000"/>
-            <a:ext cx="685800" cy="0"/>
+          <p:cNvPr id="68" name="Shape 56"/>
+          <p:cNvSpPr/>
+          <p:nvPr/>
+        </p:nvSpPr>
+        <p:spPr>
+          <a:xfrm>
+            <a:off x="5532120" y="3429000"/>
+            <a:ext cx="640080" cy="0"/>
           </a:xfrm>
           <a:prstGeom prst="line">
             <a:avLst/>
@@ -3275,13 +3359,13 @@
       </p:sp>
       <p:sp>
         <p:nvSpPr>
-          <p:cNvPr id="59" name="Shape 57"/>
-          <p:cNvSpPr/>
-          <p:nvPr/>
-        </p:nvSpPr>
-        <p:spPr>
-          <a:xfrm>
-            <a:off x="7059168" y="3566160"/>
+          <p:cNvPr id="69" name="Shape 57"/>
+          <p:cNvSpPr/>
+          <p:nvPr/>
+        </p:nvSpPr>
+        <p:spPr>
+          <a:xfrm>
+            <a:off x="7040880" y="3566160"/>
             <a:ext cx="0" cy="502920"/>
           </a:xfrm>
           <a:prstGeom prst="line">
@@ -3299,14 +3383,14 @@
       </p:sp>
       <p:sp>
         <p:nvSpPr>
-          <p:cNvPr id="60" name="Shape 58"/>
-          <p:cNvSpPr/>
-          <p:nvPr/>
-        </p:nvSpPr>
-        <p:spPr>
-          <a:xfrm>
-            <a:off x="7059168" y="4892040"/>
-            <a:ext cx="0" cy="182880"/>
+          <p:cNvPr id="70" name="Shape 58"/>
+          <p:cNvSpPr/>
+          <p:nvPr/>
+        </p:nvSpPr>
+        <p:spPr>
+          <a:xfrm>
+            <a:off x="7040880" y="4892040"/>
+            <a:ext cx="0" cy="137160"/>
           </a:xfrm>
           <a:prstGeom prst="line">
             <a:avLst/>
@@ -3323,14 +3407,14 @@
       </p:sp>
       <p:sp>
         <p:nvSpPr>
-          <p:cNvPr id="61" name="Shape 59"/>
-          <p:cNvSpPr/>
-          <p:nvPr/>
-        </p:nvSpPr>
-        <p:spPr>
-          <a:xfrm>
-            <a:off x="5760720" y="2944368"/>
-            <a:ext cx="0" cy="2130552"/>
+          <p:cNvPr id="71" name="Shape 59"/>
+          <p:cNvSpPr/>
+          <p:nvPr/>
+        </p:nvSpPr>
+        <p:spPr>
+          <a:xfrm>
+            <a:off x="5715000" y="2926080"/>
+            <a:ext cx="0" cy="2103120"/>
           </a:xfrm>
           <a:prstGeom prst="line">
             <a:avLst/>
@@ -3347,14 +3431,14 @@
       </p:sp>
       <p:sp>
         <p:nvSpPr>
-          <p:cNvPr id="62" name="Shape 60"/>
-          <p:cNvSpPr/>
-          <p:nvPr/>
-        </p:nvSpPr>
-        <p:spPr>
-          <a:xfrm>
-            <a:off x="3017520" y="5029200"/>
-            <a:ext cx="548640" cy="0"/>
+          <p:cNvPr id="72" name="Shape 60"/>
+          <p:cNvSpPr/>
+          <p:nvPr/>
+        </p:nvSpPr>
+        <p:spPr>
+          <a:xfrm>
+            <a:off x="3063240" y="5029200"/>
+            <a:ext cx="502920" cy="0"/>
           </a:xfrm>
           <a:prstGeom prst="line">
             <a:avLst/>
@@ -3370,14 +3454,14 @@
       </p:sp>
       <p:sp>
         <p:nvSpPr>
-          <p:cNvPr id="63" name="Shape 61"/>
-          <p:cNvSpPr/>
-          <p:nvPr/>
-        </p:nvSpPr>
-        <p:spPr>
-          <a:xfrm>
-            <a:off x="3566160" y="1874520"/>
-            <a:ext cx="0" cy="3154680"/>
+          <p:cNvPr id="73" name="Shape 61"/>
+          <p:cNvSpPr/>
+          <p:nvPr/>
+        </p:nvSpPr>
+        <p:spPr>
+          <a:xfrm>
+            <a:off x="3566160" y="1783080"/>
+            <a:ext cx="0" cy="3246120"/>
           </a:xfrm>
           <a:prstGeom prst="line">
             <a:avLst/>
@@ -3393,14 +3477,14 @@
       </p:sp>
       <p:sp>
         <p:nvSpPr>
-          <p:cNvPr id="64" name="Shape 62"/>
-          <p:cNvSpPr/>
-          <p:nvPr/>
-        </p:nvSpPr>
-        <p:spPr>
-          <a:xfrm>
-            <a:off x="3566160" y="1874520"/>
-            <a:ext cx="228600" cy="0"/>
+          <p:cNvPr id="74" name="Shape 62"/>
+          <p:cNvSpPr/>
+          <p:nvPr/>
+        </p:nvSpPr>
+        <p:spPr>
+          <a:xfrm>
+            <a:off x="3566160" y="1783080"/>
+            <a:ext cx="137160" cy="0"/>
           </a:xfrm>
           <a:prstGeom prst="line">
             <a:avLst/>
@@ -3417,46 +3501,7 @@
       </p:sp>
       <p:sp>
         <p:nvSpPr>
-          <p:cNvPr id="65" name="Text 63"/>
-          <p:cNvSpPr/>
-          <p:nvPr/>
-        </p:nvSpPr>
-        <p:spPr>
-          <a:xfrm>
-            <a:off x="274320" y="6400800"/>
-            <a:ext cx="7680960" cy="146304"/>
-          </a:xfrm>
-          <a:prstGeom prst="rect">
-            <a:avLst/>
-          </a:prstGeom>
-          <a:noFill/>
-          <a:ln/>
-        </p:spPr>
-        <p:txBody>
-          <a:bodyPr wrap="square" rtlCol="0" anchor="ctr"/>
-          <a:lstStyle/>
-          <a:p>
-            <a:pPr indent="0" marL="0">
-              <a:buNone/>
-            </a:pPr>
-            <a:r>
-              <a:rPr lang="en-US" sz="600" i="1" dirty="0">
-                <a:solidFill>
-                  <a:srgbClr val="AAAAAA"/>
-                </a:solidFill>
-                <a:latin typeface="Arial" pitchFamily="34" charset="0"/>
-                <a:ea typeface="Arial" pitchFamily="34" charset="-122"/>
-                <a:cs typeface="Arial" pitchFamily="34" charset="-120"/>
-              </a:rPr>
-              <a:t>Placeholder boxes represent AWS service icons — replace with official AWS Architecture Icons before publishing.</a:t>
-            </a:r>
-            <a:endParaRPr lang="en-US" sz="600" dirty="0"/>
-          </a:p>
-        </p:txBody>
-      </p:sp>
-      <p:sp>
-        <p:nvSpPr>
-          <p:cNvPr id="66" name="Text 64"/>
+          <p:cNvPr id="75" name="Text 63"/>
           <p:cNvSpPr/>
           <p:nvPr/>
         </p:nvSpPr>

</xml_diff>

<commit_message>
Diagram: rebuild Guidance PPTX to comply with the official AWS template
Rewrote docs/diagrams/generate-guidance-pptx.cjs to match the official
guidance-architecture-diagram-template geometry and conventions:
- grey (#EAEDED) sidebar at x=9.82 w=3.52 full-height with numbered callouts
- 2pt #545B64 separator over the left area only; 20pt title + description
- AWS Cloud (squid-ink solid) > Region (teal #00A4A6 dashed) grouping
- official AWS Architecture Icons with labels; straight/right-angle 1.25pt open arrows
- Arial throughout; footer; acronyms spelled out on first use; bold AWS service names

Also fixed a real bug: the previous generator emitted literal '**' markdown
(pptxgenjs does not parse it) — service names are now proper bold runs.

Validated with python-pptx: single 13.33x7.5 slide; sidebar/separator/title/footer
present; 10 official icons; 7 line shapes (separator 2pt + 6 arrows 1.25pt);
no shapes out of bounds; no leaked '**'.
</commit_message>
<xml_diff>
--- a/docs/diagrams/5g-rcf-architecture-guidance.pptx
+++ b/docs/diagrams/5g-rcf-architecture-guidance.pptx
@@ -876,8 +876,8 @@
         </p:nvSpPr>
         <p:spPr>
           <a:xfrm>
-            <a:off x="274320" y="109728"/>
-            <a:ext cx="7680960" cy="320040"/>
+            <a:off x="109728" y="91440"/>
+            <a:ext cx="8641080" cy="658368"/>
           </a:xfrm>
           <a:prstGeom prst="rect">
             <a:avLst/>
@@ -886,14 +886,14 @@
           <a:ln/>
         </p:spPr>
         <p:txBody>
-          <a:bodyPr wrap="square" rtlCol="0" anchor="ctr"/>
+          <a:bodyPr wrap="square" rtlCol="0" anchor="t"/>
           <a:lstStyle/>
           <a:p>
             <a:pPr indent="0" marL="0">
               <a:buNone/>
             </a:pPr>
             <a:r>
-              <a:rPr lang="en-US" sz="1400" b="1" dirty="0">
+              <a:rPr lang="en-US" sz="2000" b="1" dirty="0">
                 <a:solidFill>
                   <a:srgbClr val="232F3E"/>
                 </a:solidFill>
@@ -903,7 +903,7 @@
               </a:rPr>
               <a:t>Guidance for 5G Network Anomaly Detection and Automated Root Cause Analysis on AWS</a:t>
             </a:r>
-            <a:endParaRPr lang="en-US" sz="1400" dirty="0"/>
+            <a:endParaRPr lang="en-US" sz="2000" dirty="0"/>
           </a:p>
         </p:txBody>
       </p:sp>
@@ -915,8 +915,8 @@
         </p:nvSpPr>
         <p:spPr>
           <a:xfrm>
-            <a:off x="274320" y="429768"/>
-            <a:ext cx="7680960" cy="256032"/>
+            <a:off x="109728" y="768096"/>
+            <a:ext cx="8641080" cy="365760"/>
           </a:xfrm>
           <a:prstGeom prst="rect">
             <a:avLst/>
@@ -925,24 +925,24 @@
           <a:ln/>
         </p:spPr>
         <p:txBody>
-          <a:bodyPr wrap="square" rtlCol="0" anchor="ctr"/>
+          <a:bodyPr wrap="square" rtlCol="0" anchor="t"/>
           <a:lstStyle/>
           <a:p>
             <a:pPr indent="0" marL="0">
               <a:buNone/>
             </a:pPr>
             <a:r>
-              <a:rPr lang="en-US" sz="900" dirty="0">
-                <a:solidFill>
-                  <a:srgbClr val="666666"/>
-                </a:solidFill>
-                <a:latin typeface="Arial" pitchFamily="34" charset="0"/>
-                <a:ea typeface="Arial" pitchFamily="34" charset="-122"/>
-                <a:cs typeface="Arial" pitchFamily="34" charset="-120"/>
-              </a:rPr>
-              <a:t>Amazon Managed Service for Prometheus applies Random Cut Forest anomaly detection to a live 5G core, then runs an automated root-cause-analysis pipeline that identifies the failing network function and hands the incident to the AWS DevOps Agent.</a:t>
-            </a:r>
-            <a:endParaRPr lang="en-US" sz="900" dirty="0"/>
+              <a:rPr lang="en-US" sz="1050" dirty="0">
+                <a:solidFill>
+                  <a:srgbClr val="545B64"/>
+                </a:solidFill>
+                <a:latin typeface="Arial" pitchFamily="34" charset="0"/>
+                <a:ea typeface="Arial" pitchFamily="34" charset="-122"/>
+                <a:cs typeface="Arial" pitchFamily="34" charset="-120"/>
+              </a:rPr>
+              <a:t>Amazon Managed Service for Prometheus applies Random Cut Forest anomaly detection to a live 5G core, then an automated root-cause-analysis pipeline identifies the failing network function and hands the incident to the AWS DevOps Agent for an autonomous investigation.</a:t>
+            </a:r>
+            <a:endParaRPr lang="en-US" sz="1050" dirty="0"/>
           </a:p>
         </p:txBody>
       </p:sp>
@@ -954,16 +954,16 @@
         </p:nvSpPr>
         <p:spPr>
           <a:xfrm>
-            <a:off x="274320" y="713232"/>
-            <a:ext cx="11612880" cy="0"/>
+            <a:off x="109728" y="1188720"/>
+            <a:ext cx="8613648" cy="0"/>
           </a:xfrm>
           <a:prstGeom prst="line">
             <a:avLst/>
           </a:prstGeom>
           <a:noFill/>
-          <a:ln w="12700">
+          <a:ln w="25400">
             <a:solidFill>
-              <a:srgbClr val="CCCCCC"/>
+              <a:srgbClr val="545B64"/>
             </a:solidFill>
             <a:prstDash val="solid"/>
           </a:ln>
@@ -977,18 +977,18 @@
         </p:nvSpPr>
         <p:spPr>
           <a:xfrm>
-            <a:off x="8183880" y="777240"/>
-            <a:ext cx="3977640" cy="5669280"/>
-          </a:xfrm>
-          <a:prstGeom prst="rect">
-            <a:avLst/>
-          </a:prstGeom>
-          <a:solidFill>
-            <a:srgbClr val="F5F5F5"/>
-          </a:solidFill>
-          <a:ln w="6350">
+            <a:off x="8979408" y="0"/>
+            <a:ext cx="3218688" cy="6858000"/>
+          </a:xfrm>
+          <a:prstGeom prst="rect">
+            <a:avLst/>
+          </a:prstGeom>
+          <a:solidFill>
+            <a:srgbClr val="EAEDED"/>
+          </a:solidFill>
+          <a:ln w="12700">
             <a:solidFill>
-              <a:srgbClr val="E0E0E0"/>
+              <a:srgbClr val="EAEDED"/>
             </a:solidFill>
             <a:prstDash val="solid"/>
           </a:ln>
@@ -1002,14 +1002,14 @@
         </p:nvSpPr>
         <p:spPr>
           <a:xfrm>
-            <a:off x="8275320" y="896112"/>
-            <a:ext cx="237744" cy="237744"/>
+            <a:off x="9052560" y="164592"/>
+            <a:ext cx="274320" cy="274320"/>
           </a:xfrm>
           <a:prstGeom prst="ellipse">
             <a:avLst/>
           </a:prstGeom>
           <a:solidFill>
-            <a:srgbClr val="FF9900"/>
+            <a:srgbClr val="232F3E"/>
           </a:solidFill>
           <a:ln/>
         </p:spPr>
@@ -1043,8 +1043,8 @@
         </p:nvSpPr>
         <p:spPr>
           <a:xfrm>
-            <a:off x="8604504" y="868680"/>
-            <a:ext cx="3447288" cy="582168"/>
+            <a:off x="9400032" y="146304"/>
+            <a:ext cx="2706624" cy="699008"/>
           </a:xfrm>
           <a:prstGeom prst="rect">
             <a:avLst/>
@@ -1060,6 +1060,20 @@
               <a:buNone/>
             </a:pPr>
             <a:r>
+              <a:rPr lang="en-US" sz="800" b="1" dirty="0">
+                <a:solidFill>
+                  <a:srgbClr val="232F3E"/>
+                </a:solidFill>
+                <a:latin typeface="Arial" pitchFamily="34" charset="0"/>
+                <a:ea typeface="Arial" pitchFamily="34" charset="-122"/>
+                <a:cs typeface="Arial" pitchFamily="34" charset="-120"/>
+              </a:rPr>
+              <a:t>Amazon Elastic Kubernetes Service (Amazon EKS)</a:t>
+            </a:r>
+            <a:pPr indent="0" marL="0">
+              <a:buNone/>
+            </a:pPr>
+            <a:r>
               <a:rPr lang="en-US" sz="800" dirty="0">
                 <a:solidFill>
                   <a:srgbClr val="232F3E"/>
@@ -1068,7 +1082,7 @@
                 <a:ea typeface="Arial" pitchFamily="34" charset="-122"/>
                 <a:cs typeface="Arial" pitchFamily="34" charset="-120"/>
               </a:rPr>
-              <a:t>**Amazon Elastic Kubernetes Service (Amazon EKS)** hosts the open5gs 5G core (AMF, SMF, UPF) and the UERANSIM radio access network (100 gNodeBs, 1,000 UEs), which emit registration and session metrics.</a:t>
+              <a:t> hosts the open5gs 5G core and the UERANSIM radio access network (100 gNodeBs, 1,000 UEs), which emit registration and session metrics.</a:t>
             </a:r>
             <a:endParaRPr lang="en-US" sz="800" dirty="0"/>
           </a:p>
@@ -1082,14 +1096,14 @@
         </p:nvSpPr>
         <p:spPr>
           <a:xfrm>
-            <a:off x="8275320" y="1505712"/>
-            <a:ext cx="237744" cy="237744"/>
+            <a:off x="9052560" y="900176"/>
+            <a:ext cx="274320" cy="274320"/>
           </a:xfrm>
           <a:prstGeom prst="ellipse">
             <a:avLst/>
           </a:prstGeom>
           <a:solidFill>
-            <a:srgbClr val="FF9900"/>
+            <a:srgbClr val="232F3E"/>
           </a:solidFill>
           <a:ln/>
         </p:spPr>
@@ -1123,8 +1137,8 @@
         </p:nvSpPr>
         <p:spPr>
           <a:xfrm>
-            <a:off x="8604504" y="1478280"/>
-            <a:ext cx="3447288" cy="582168"/>
+            <a:off x="9400032" y="881888"/>
+            <a:ext cx="2706624" cy="699008"/>
           </a:xfrm>
           <a:prstGeom prst="rect">
             <a:avLst/>
@@ -1148,7 +1162,35 @@
                 <a:ea typeface="Arial" pitchFamily="34" charset="-122"/>
                 <a:cs typeface="Arial" pitchFamily="34" charset="-120"/>
               </a:rPr>
-              <a:t>A Prometheus agent scrapes the metrics and remote-writes them to **Amazon Managed Service for Prometheus** using SigV4 signing and IAM Roles for Service Accounts.</a:t>
+              <a:t>A Prometheus agent scrapes the metrics and remote-writes them to </a:t>
+            </a:r>
+            <a:pPr indent="0" marL="0">
+              <a:buNone/>
+            </a:pPr>
+            <a:r>
+              <a:rPr lang="en-US" sz="800" b="1" dirty="0">
+                <a:solidFill>
+                  <a:srgbClr val="232F3E"/>
+                </a:solidFill>
+                <a:latin typeface="Arial" pitchFamily="34" charset="0"/>
+                <a:ea typeface="Arial" pitchFamily="34" charset="-122"/>
+                <a:cs typeface="Arial" pitchFamily="34" charset="-120"/>
+              </a:rPr>
+              <a:t>Amazon Managed Service for Prometheus</a:t>
+            </a:r>
+            <a:pPr indent="0" marL="0">
+              <a:buNone/>
+            </a:pPr>
+            <a:r>
+              <a:rPr lang="en-US" sz="800" dirty="0">
+                <a:solidFill>
+                  <a:srgbClr val="232F3E"/>
+                </a:solidFill>
+                <a:latin typeface="Arial" pitchFamily="34" charset="0"/>
+                <a:ea typeface="Arial" pitchFamily="34" charset="-122"/>
+                <a:cs typeface="Arial" pitchFamily="34" charset="-120"/>
+              </a:rPr>
+              <a:t> using SigV4 signing and IAM Roles for Service Accounts.</a:t>
             </a:r>
             <a:endParaRPr lang="en-US" sz="800" dirty="0"/>
           </a:p>
@@ -1162,14 +1204,14 @@
         </p:nvSpPr>
         <p:spPr>
           <a:xfrm>
-            <a:off x="8275320" y="2115312"/>
-            <a:ext cx="237744" cy="237744"/>
+            <a:off x="9052560" y="1635760"/>
+            <a:ext cx="274320" cy="274320"/>
           </a:xfrm>
           <a:prstGeom prst="ellipse">
             <a:avLst/>
           </a:prstGeom>
           <a:solidFill>
-            <a:srgbClr val="FF9900"/>
+            <a:srgbClr val="232F3E"/>
           </a:solidFill>
           <a:ln/>
         </p:spPr>
@@ -1203,8 +1245,8 @@
         </p:nvSpPr>
         <p:spPr>
           <a:xfrm>
-            <a:off x="8604504" y="2087880"/>
-            <a:ext cx="3447288" cy="582168"/>
+            <a:off x="9400032" y="1617472"/>
+            <a:ext cx="2706624" cy="699008"/>
           </a:xfrm>
           <a:prstGeom prst="rect">
             <a:avLst/>
@@ -1220,6 +1262,20 @@
               <a:buNone/>
             </a:pPr>
             <a:r>
+              <a:rPr lang="en-US" sz="800" b="1" dirty="0">
+                <a:solidFill>
+                  <a:srgbClr val="232F3E"/>
+                </a:solidFill>
+                <a:latin typeface="Arial" pitchFamily="34" charset="0"/>
+                <a:ea typeface="Arial" pitchFamily="34" charset="-122"/>
+                <a:cs typeface="Arial" pitchFamily="34" charset="-120"/>
+              </a:rPr>
+              <a:t>Amazon Managed Service for Prometheus</a:t>
+            </a:r>
+            <a:pPr indent="0" marL="0">
+              <a:buNone/>
+            </a:pPr>
+            <a:r>
               <a:rPr lang="en-US" sz="800" dirty="0">
                 <a:solidFill>
                   <a:srgbClr val="232F3E"/>
@@ -1228,7 +1284,7 @@
                 <a:ea typeface="Arial" pitchFamily="34" charset="-122"/>
                 <a:cs typeface="Arial" pitchFamily="34" charset="-120"/>
               </a:rPr>
-              <a:t>**Amazon Managed Service for Prometheus** runs a Random Cut Forest (RCF) anomaly detector on the aggregate registered-subscriber count, emitting an anomaly score every 30 seconds.</a:t>
+              <a:t> runs a Random Cut Forest (RCF) anomaly detector on the registered-subscriber count, emitting an anomaly score every 30 seconds.</a:t>
             </a:r>
             <a:endParaRPr lang="en-US" sz="800" dirty="0"/>
           </a:p>
@@ -1242,14 +1298,14 @@
         </p:nvSpPr>
         <p:spPr>
           <a:xfrm>
-            <a:off x="8275320" y="2724912"/>
-            <a:ext cx="237744" cy="237744"/>
+            <a:off x="9052560" y="2371344"/>
+            <a:ext cx="274320" cy="274320"/>
           </a:xfrm>
           <a:prstGeom prst="ellipse">
             <a:avLst/>
           </a:prstGeom>
           <a:solidFill>
-            <a:srgbClr val="FF9900"/>
+            <a:srgbClr val="232F3E"/>
           </a:solidFill>
           <a:ln/>
         </p:spPr>
@@ -1283,8 +1339,8 @@
         </p:nvSpPr>
         <p:spPr>
           <a:xfrm>
-            <a:off x="8604504" y="2697480"/>
-            <a:ext cx="3447288" cy="582168"/>
+            <a:off x="9400032" y="2353056"/>
+            <a:ext cx="2706624" cy="699008"/>
           </a:xfrm>
           <a:prstGeom prst="rect">
             <a:avLst/>
@@ -1308,7 +1364,35 @@
                 <a:ea typeface="Arial" pitchFamily="34" charset="-122"/>
                 <a:cs typeface="Arial" pitchFamily="34" charset="-120"/>
               </a:rPr>
-              <a:t>When the score crosses the threshold, the alerting rule fires and Alertmanager publishes to an **Amazon Simple Notification Service (Amazon SNS)** topic.</a:t>
+              <a:t>When the score crosses the threshold, Alertmanager publishes to an </a:t>
+            </a:r>
+            <a:pPr indent="0" marL="0">
+              <a:buNone/>
+            </a:pPr>
+            <a:r>
+              <a:rPr lang="en-US" sz="800" b="1" dirty="0">
+                <a:solidFill>
+                  <a:srgbClr val="232F3E"/>
+                </a:solidFill>
+                <a:latin typeface="Arial" pitchFamily="34" charset="0"/>
+                <a:ea typeface="Arial" pitchFamily="34" charset="-122"/>
+                <a:cs typeface="Arial" pitchFamily="34" charset="-120"/>
+              </a:rPr>
+              <a:t>Amazon Simple Notification Service (Amazon SNS)</a:t>
+            </a:r>
+            <a:pPr indent="0" marL="0">
+              <a:buNone/>
+            </a:pPr>
+            <a:r>
+              <a:rPr lang="en-US" sz="800" dirty="0">
+                <a:solidFill>
+                  <a:srgbClr val="232F3E"/>
+                </a:solidFill>
+                <a:latin typeface="Arial" pitchFamily="34" charset="0"/>
+                <a:ea typeface="Arial" pitchFamily="34" charset="-122"/>
+                <a:cs typeface="Arial" pitchFamily="34" charset="-120"/>
+              </a:rPr>
+              <a:t> topic.</a:t>
             </a:r>
             <a:endParaRPr lang="en-US" sz="800" dirty="0"/>
           </a:p>
@@ -1322,14 +1406,14 @@
         </p:nvSpPr>
         <p:spPr>
           <a:xfrm>
-            <a:off x="8275320" y="3334512"/>
-            <a:ext cx="237744" cy="237744"/>
+            <a:off x="9052560" y="3106928"/>
+            <a:ext cx="274320" cy="274320"/>
           </a:xfrm>
           <a:prstGeom prst="ellipse">
             <a:avLst/>
           </a:prstGeom>
           <a:solidFill>
-            <a:srgbClr val="FF9900"/>
+            <a:srgbClr val="232F3E"/>
           </a:solidFill>
           <a:ln/>
         </p:spPr>
@@ -1363,8 +1447,8 @@
         </p:nvSpPr>
         <p:spPr>
           <a:xfrm>
-            <a:off x="8604504" y="3307080"/>
-            <a:ext cx="3447288" cy="582168"/>
+            <a:off x="9400032" y="3088640"/>
+            <a:ext cx="2706624" cy="699008"/>
           </a:xfrm>
           <a:prstGeom prst="rect">
             <a:avLst/>
@@ -1380,6 +1464,20 @@
               <a:buNone/>
             </a:pPr>
             <a:r>
+              <a:rPr lang="en-US" sz="800" b="1" dirty="0">
+                <a:solidFill>
+                  <a:srgbClr val="232F3E"/>
+                </a:solidFill>
+                <a:latin typeface="Arial" pitchFamily="34" charset="0"/>
+                <a:ea typeface="Arial" pitchFamily="34" charset="-122"/>
+                <a:cs typeface="Arial" pitchFamily="34" charset="-120"/>
+              </a:rPr>
+              <a:t>Amazon SNS</a:t>
+            </a:r>
+            <a:pPr indent="0" marL="0">
+              <a:buNone/>
+            </a:pPr>
+            <a:r>
               <a:rPr lang="en-US" sz="800" dirty="0">
                 <a:solidFill>
                   <a:srgbClr val="232F3E"/>
@@ -1388,7 +1486,35 @@
                 <a:ea typeface="Arial" pitchFamily="34" charset="-122"/>
                 <a:cs typeface="Arial" pitchFamily="34" charset="-120"/>
               </a:rPr>
-              <a:t>**Amazon SNS** invokes the root-cause-analysis **AWS Lambda** function.</a:t>
+              <a:t> invokes the root-cause-analysis </a:t>
+            </a:r>
+            <a:pPr indent="0" marL="0">
+              <a:buNone/>
+            </a:pPr>
+            <a:r>
+              <a:rPr lang="en-US" sz="800" b="1" dirty="0">
+                <a:solidFill>
+                  <a:srgbClr val="232F3E"/>
+                </a:solidFill>
+                <a:latin typeface="Arial" pitchFamily="34" charset="0"/>
+                <a:ea typeface="Arial" pitchFamily="34" charset="-122"/>
+                <a:cs typeface="Arial" pitchFamily="34" charset="-120"/>
+              </a:rPr>
+              <a:t>AWS Lambda</a:t>
+            </a:r>
+            <a:pPr indent="0" marL="0">
+              <a:buNone/>
+            </a:pPr>
+            <a:r>
+              <a:rPr lang="en-US" sz="800" dirty="0">
+                <a:solidFill>
+                  <a:srgbClr val="232F3E"/>
+                </a:solidFill>
+                <a:latin typeface="Arial" pitchFamily="34" charset="0"/>
+                <a:ea typeface="Arial" pitchFamily="34" charset="-122"/>
+                <a:cs typeface="Arial" pitchFamily="34" charset="-120"/>
+              </a:rPr>
+              <a:t> function.</a:t>
             </a:r>
             <a:endParaRPr lang="en-US" sz="800" dirty="0"/>
           </a:p>
@@ -1402,14 +1528,14 @@
         </p:nvSpPr>
         <p:spPr>
           <a:xfrm>
-            <a:off x="8275320" y="3944112"/>
-            <a:ext cx="237744" cy="237744"/>
+            <a:off x="9052560" y="3842512"/>
+            <a:ext cx="274320" cy="274320"/>
           </a:xfrm>
           <a:prstGeom prst="ellipse">
             <a:avLst/>
           </a:prstGeom>
           <a:solidFill>
-            <a:srgbClr val="FF9900"/>
+            <a:srgbClr val="232F3E"/>
           </a:solidFill>
           <a:ln/>
         </p:spPr>
@@ -1443,8 +1569,8 @@
         </p:nvSpPr>
         <p:spPr>
           <a:xfrm>
-            <a:off x="8604504" y="3916680"/>
-            <a:ext cx="3447288" cy="582168"/>
+            <a:off x="9400032" y="3824224"/>
+            <a:ext cx="2706624" cy="699008"/>
           </a:xfrm>
           <a:prstGeom prst="rect">
             <a:avLst/>
@@ -1460,6 +1586,20 @@
               <a:buNone/>
             </a:pPr>
             <a:r>
+              <a:rPr lang="en-US" sz="800" b="1" dirty="0">
+                <a:solidFill>
+                  <a:srgbClr val="232F3E"/>
+                </a:solidFill>
+                <a:latin typeface="Arial" pitchFamily="34" charset="0"/>
+                <a:ea typeface="Arial" pitchFamily="34" charset="-122"/>
+                <a:cs typeface="Arial" pitchFamily="34" charset="-120"/>
+              </a:rPr>
+              <a:t>AWS Lambda</a:t>
+            </a:r>
+            <a:pPr indent="0" marL="0">
+              <a:buNone/>
+            </a:pPr>
+            <a:r>
               <a:rPr lang="en-US" sz="800" dirty="0">
                 <a:solidFill>
                   <a:srgbClr val="232F3E"/>
@@ -1468,7 +1608,35 @@
                 <a:ea typeface="Arial" pitchFamily="34" charset="-122"/>
                 <a:cs typeface="Arial" pitchFamily="34" charset="-120"/>
               </a:rPr>
-              <a:t>The **AWS Lambda** function queries **Amazon Managed Service for Prometheus** for per-network-function registration and pod restarts to pinpoint the failed function.</a:t>
+              <a:t> queries </a:t>
+            </a:r>
+            <a:pPr indent="0" marL="0">
+              <a:buNone/>
+            </a:pPr>
+            <a:r>
+              <a:rPr lang="en-US" sz="800" b="1" dirty="0">
+                <a:solidFill>
+                  <a:srgbClr val="232F3E"/>
+                </a:solidFill>
+                <a:latin typeface="Arial" pitchFamily="34" charset="0"/>
+                <a:ea typeface="Arial" pitchFamily="34" charset="-122"/>
+                <a:cs typeface="Arial" pitchFamily="34" charset="-120"/>
+              </a:rPr>
+              <a:t>Amazon Managed Service for Prometheus</a:t>
+            </a:r>
+            <a:pPr indent="0" marL="0">
+              <a:buNone/>
+            </a:pPr>
+            <a:r>
+              <a:rPr lang="en-US" sz="800" dirty="0">
+                <a:solidFill>
+                  <a:srgbClr val="232F3E"/>
+                </a:solidFill>
+                <a:latin typeface="Arial" pitchFamily="34" charset="0"/>
+                <a:ea typeface="Arial" pitchFamily="34" charset="-122"/>
+                <a:cs typeface="Arial" pitchFamily="34" charset="-120"/>
+              </a:rPr>
+              <a:t> for per-network-function registration and pod restarts to pinpoint the failed function.</a:t>
             </a:r>
             <a:endParaRPr lang="en-US" sz="800" dirty="0"/>
           </a:p>
@@ -1482,14 +1650,14 @@
         </p:nvSpPr>
         <p:spPr>
           <a:xfrm>
-            <a:off x="8275320" y="4553712"/>
-            <a:ext cx="237744" cy="237744"/>
+            <a:off x="9052560" y="4578096"/>
+            <a:ext cx="274320" cy="274320"/>
           </a:xfrm>
           <a:prstGeom prst="ellipse">
             <a:avLst/>
           </a:prstGeom>
           <a:solidFill>
-            <a:srgbClr val="FF9900"/>
+            <a:srgbClr val="232F3E"/>
           </a:solidFill>
           <a:ln/>
         </p:spPr>
@@ -1523,8 +1691,8 @@
         </p:nvSpPr>
         <p:spPr>
           <a:xfrm>
-            <a:off x="8604504" y="4526280"/>
-            <a:ext cx="3447288" cy="582168"/>
+            <a:off x="9400032" y="4559808"/>
+            <a:ext cx="2706624" cy="699008"/>
           </a:xfrm>
           <a:prstGeom prst="rect">
             <a:avLst/>
@@ -1540,6 +1708,20 @@
               <a:buNone/>
             </a:pPr>
             <a:r>
+              <a:rPr lang="en-US" sz="800" b="1" dirty="0">
+                <a:solidFill>
+                  <a:srgbClr val="232F3E"/>
+                </a:solidFill>
+                <a:latin typeface="Arial" pitchFamily="34" charset="0"/>
+                <a:ea typeface="Arial" pitchFamily="34" charset="-122"/>
+                <a:cs typeface="Arial" pitchFamily="34" charset="-120"/>
+              </a:rPr>
+              <a:t>AWS Lambda</a:t>
+            </a:r>
+            <a:pPr indent="0" marL="0">
+              <a:buNone/>
+            </a:pPr>
+            <a:r>
               <a:rPr lang="en-US" sz="800" dirty="0">
                 <a:solidFill>
                   <a:srgbClr val="232F3E"/>
@@ -1548,7 +1730,35 @@
                 <a:ea typeface="Arial" pitchFamily="34" charset="-122"/>
                 <a:cs typeface="Arial" pitchFamily="34" charset="-120"/>
               </a:rPr>
-              <a:t>The function retrieves the DevOps Agent webhook URL and token from **AWS Secrets Manager**.</a:t>
+              <a:t> reads the DevOps Agent webhook URL and token from </a:t>
+            </a:r>
+            <a:pPr indent="0" marL="0">
+              <a:buNone/>
+            </a:pPr>
+            <a:r>
+              <a:rPr lang="en-US" sz="800" b="1" dirty="0">
+                <a:solidFill>
+                  <a:srgbClr val="232F3E"/>
+                </a:solidFill>
+                <a:latin typeface="Arial" pitchFamily="34" charset="0"/>
+                <a:ea typeface="Arial" pitchFamily="34" charset="-122"/>
+                <a:cs typeface="Arial" pitchFamily="34" charset="-120"/>
+              </a:rPr>
+              <a:t>AWS Secrets Manager</a:t>
+            </a:r>
+            <a:pPr indent="0" marL="0">
+              <a:buNone/>
+            </a:pPr>
+            <a:r>
+              <a:rPr lang="en-US" sz="800" dirty="0">
+                <a:solidFill>
+                  <a:srgbClr val="232F3E"/>
+                </a:solidFill>
+                <a:latin typeface="Arial" pitchFamily="34" charset="0"/>
+                <a:ea typeface="Arial" pitchFamily="34" charset="-122"/>
+                <a:cs typeface="Arial" pitchFamily="34" charset="-120"/>
+              </a:rPr>
+              <a:t>.</a:t>
             </a:r>
             <a:endParaRPr lang="en-US" sz="800" dirty="0"/>
           </a:p>
@@ -1562,14 +1772,14 @@
         </p:nvSpPr>
         <p:spPr>
           <a:xfrm>
-            <a:off x="8275320" y="5163312"/>
-            <a:ext cx="237744" cy="237744"/>
+            <a:off x="9052560" y="5313680"/>
+            <a:ext cx="274320" cy="274320"/>
           </a:xfrm>
           <a:prstGeom prst="ellipse">
             <a:avLst/>
           </a:prstGeom>
           <a:solidFill>
-            <a:srgbClr val="FF9900"/>
+            <a:srgbClr val="232F3E"/>
           </a:solidFill>
           <a:ln/>
         </p:spPr>
@@ -1603,8 +1813,8 @@
         </p:nvSpPr>
         <p:spPr>
           <a:xfrm>
-            <a:off x="8604504" y="5135880"/>
-            <a:ext cx="3447288" cy="582168"/>
+            <a:off x="9400032" y="5295392"/>
+            <a:ext cx="2706624" cy="699008"/>
           </a:xfrm>
           <a:prstGeom prst="rect">
             <a:avLst/>
@@ -1620,6 +1830,20 @@
               <a:buNone/>
             </a:pPr>
             <a:r>
+              <a:rPr lang="en-US" sz="800" b="1" dirty="0">
+                <a:solidFill>
+                  <a:srgbClr val="232F3E"/>
+                </a:solidFill>
+                <a:latin typeface="Arial" pitchFamily="34" charset="0"/>
+                <a:ea typeface="Arial" pitchFamily="34" charset="-122"/>
+                <a:cs typeface="Arial" pitchFamily="34" charset="-120"/>
+              </a:rPr>
+              <a:t>AWS Lambda</a:t>
+            </a:r>
+            <a:pPr indent="0" marL="0">
+              <a:buNone/>
+            </a:pPr>
+            <a:r>
               <a:rPr lang="en-US" sz="800" dirty="0">
                 <a:solidFill>
                   <a:srgbClr val="232F3E"/>
@@ -1628,7 +1852,91 @@
                 <a:ea typeface="Arial" pitchFamily="34" charset="-122"/>
                 <a:cs typeface="Arial" pitchFamily="34" charset="-120"/>
               </a:rPr>
-              <a:t>The function posts an incident to the **AWS DevOps Agent** for autonomous investigation; the agent can also query metrics on demand through a Model Context Protocol server on **Amazon API Gateway**, secured by **Amazon Cognito**.</a:t>
+              <a:t> posts an incident to the </a:t>
+            </a:r>
+            <a:pPr indent="0" marL="0">
+              <a:buNone/>
+            </a:pPr>
+            <a:r>
+              <a:rPr lang="en-US" sz="800" b="1" dirty="0">
+                <a:solidFill>
+                  <a:srgbClr val="232F3E"/>
+                </a:solidFill>
+                <a:latin typeface="Arial" pitchFamily="34" charset="0"/>
+                <a:ea typeface="Arial" pitchFamily="34" charset="-122"/>
+                <a:cs typeface="Arial" pitchFamily="34" charset="-120"/>
+              </a:rPr>
+              <a:t>AWS DevOps Agent</a:t>
+            </a:r>
+            <a:pPr indent="0" marL="0">
+              <a:buNone/>
+            </a:pPr>
+            <a:r>
+              <a:rPr lang="en-US" sz="800" dirty="0">
+                <a:solidFill>
+                  <a:srgbClr val="232F3E"/>
+                </a:solidFill>
+                <a:latin typeface="Arial" pitchFamily="34" charset="0"/>
+                <a:ea typeface="Arial" pitchFamily="34" charset="-122"/>
+                <a:cs typeface="Arial" pitchFamily="34" charset="-120"/>
+              </a:rPr>
+              <a:t>, which investigates autonomously and can query metrics through a Model Context Protocol server on </a:t>
+            </a:r>
+            <a:pPr indent="0" marL="0">
+              <a:buNone/>
+            </a:pPr>
+            <a:r>
+              <a:rPr lang="en-US" sz="800" b="1" dirty="0">
+                <a:solidFill>
+                  <a:srgbClr val="232F3E"/>
+                </a:solidFill>
+                <a:latin typeface="Arial" pitchFamily="34" charset="0"/>
+                <a:ea typeface="Arial" pitchFamily="34" charset="-122"/>
+                <a:cs typeface="Arial" pitchFamily="34" charset="-120"/>
+              </a:rPr>
+              <a:t>Amazon API Gateway</a:t>
+            </a:r>
+            <a:pPr indent="0" marL="0">
+              <a:buNone/>
+            </a:pPr>
+            <a:r>
+              <a:rPr lang="en-US" sz="800" dirty="0">
+                <a:solidFill>
+                  <a:srgbClr val="232F3E"/>
+                </a:solidFill>
+                <a:latin typeface="Arial" pitchFamily="34" charset="0"/>
+                <a:ea typeface="Arial" pitchFamily="34" charset="-122"/>
+                <a:cs typeface="Arial" pitchFamily="34" charset="-120"/>
+              </a:rPr>
+              <a:t>, secured by </a:t>
+            </a:r>
+            <a:pPr indent="0" marL="0">
+              <a:buNone/>
+            </a:pPr>
+            <a:r>
+              <a:rPr lang="en-US" sz="800" b="1" dirty="0">
+                <a:solidFill>
+                  <a:srgbClr val="232F3E"/>
+                </a:solidFill>
+                <a:latin typeface="Arial" pitchFamily="34" charset="0"/>
+                <a:ea typeface="Arial" pitchFamily="34" charset="-122"/>
+                <a:cs typeface="Arial" pitchFamily="34" charset="-120"/>
+              </a:rPr>
+              <a:t>Amazon Cognito</a:t>
+            </a:r>
+            <a:pPr indent="0" marL="0">
+              <a:buNone/>
+            </a:pPr>
+            <a:r>
+              <a:rPr lang="en-US" sz="800" dirty="0">
+                <a:solidFill>
+                  <a:srgbClr val="232F3E"/>
+                </a:solidFill>
+                <a:latin typeface="Arial" pitchFamily="34" charset="0"/>
+                <a:ea typeface="Arial" pitchFamily="34" charset="-122"/>
+                <a:cs typeface="Arial" pitchFamily="34" charset="-120"/>
+              </a:rPr>
+              <a:t>.</a:t>
             </a:r>
             <a:endParaRPr lang="en-US" sz="800" dirty="0"/>
           </a:p>
@@ -1642,14 +1950,14 @@
         </p:nvSpPr>
         <p:spPr>
           <a:xfrm>
-            <a:off x="8275320" y="5772912"/>
-            <a:ext cx="237744" cy="237744"/>
+            <a:off x="9052560" y="6049264"/>
+            <a:ext cx="274320" cy="274320"/>
           </a:xfrm>
           <a:prstGeom prst="ellipse">
             <a:avLst/>
           </a:prstGeom>
           <a:solidFill>
-            <a:srgbClr val="FF9900"/>
+            <a:srgbClr val="232F3E"/>
           </a:solidFill>
           <a:ln/>
         </p:spPr>
@@ -1683,8 +1991,8 @@
         </p:nvSpPr>
         <p:spPr>
           <a:xfrm>
-            <a:off x="8604504" y="5745480"/>
-            <a:ext cx="3447288" cy="582168"/>
+            <a:off x="9400032" y="6030976"/>
+            <a:ext cx="2706624" cy="699008"/>
           </a:xfrm>
           <a:prstGeom prst="rect">
             <a:avLst/>
@@ -1708,7 +2016,35 @@
                 <a:ea typeface="Arial" pitchFamily="34" charset="-122"/>
                 <a:cs typeface="Arial" pitchFamily="34" charset="-120"/>
               </a:rPr>
-              <a:t>Engineers run the guided demo and interactive analysis from an **Amazon SageMaker** notebook.</a:t>
+              <a:t>Engineers run the guided demo and interactive analysis from an </a:t>
+            </a:r>
+            <a:pPr indent="0" marL="0">
+              <a:buNone/>
+            </a:pPr>
+            <a:r>
+              <a:rPr lang="en-US" sz="800" b="1" dirty="0">
+                <a:solidFill>
+                  <a:srgbClr val="232F3E"/>
+                </a:solidFill>
+                <a:latin typeface="Arial" pitchFamily="34" charset="0"/>
+                <a:ea typeface="Arial" pitchFamily="34" charset="-122"/>
+                <a:cs typeface="Arial" pitchFamily="34" charset="-120"/>
+              </a:rPr>
+              <a:t>Amazon SageMaker</a:t>
+            </a:r>
+            <a:pPr indent="0" marL="0">
+              <a:buNone/>
+            </a:pPr>
+            <a:r>
+              <a:rPr lang="en-US" sz="800" dirty="0">
+                <a:solidFill>
+                  <a:srgbClr val="232F3E"/>
+                </a:solidFill>
+                <a:latin typeface="Arial" pitchFamily="34" charset="0"/>
+                <a:ea typeface="Arial" pitchFamily="34" charset="-122"/>
+                <a:cs typeface="Arial" pitchFamily="34" charset="-120"/>
+              </a:rPr>
+              <a:t> notebook.</a:t>
             </a:r>
             <a:endParaRPr lang="en-US" sz="800" dirty="0"/>
           </a:p>
@@ -1722,8 +2058,8 @@
         </p:nvSpPr>
         <p:spPr>
           <a:xfrm>
-            <a:off x="274320" y="777240"/>
-            <a:ext cx="7726680" cy="5669280"/>
+            <a:off x="182880" y="1298448"/>
+            <a:ext cx="8540496" cy="5074920"/>
           </a:xfrm>
           <a:prstGeom prst="rect">
             <a:avLst/>
@@ -1737,7 +2073,7 @@
             <a:solidFill>
               <a:srgbClr val="232F3E"/>
             </a:solidFill>
-            <a:prstDash val="dash"/>
+            <a:prstDash val="solid"/>
           </a:ln>
         </p:spPr>
       </p:sp>
@@ -1749,8 +2085,8 @@
         </p:nvSpPr>
         <p:spPr>
           <a:xfrm>
-            <a:off x="365760" y="795528"/>
-            <a:ext cx="1097280" cy="182880"/>
+            <a:off x="493776" y="1325880"/>
+            <a:ext cx="8174736" cy="201168"/>
           </a:xfrm>
           <a:prstGeom prst="rect">
             <a:avLst/>
@@ -1766,7 +2102,7 @@
               <a:buNone/>
             </a:pPr>
             <a:r>
-              <a:rPr lang="en-US" sz="800" b="1" dirty="0">
+              <a:rPr lang="en-US" sz="900" b="1" dirty="0">
                 <a:solidFill>
                   <a:srgbClr val="232F3E"/>
                 </a:solidFill>
@@ -1776,7 +2112,7 @@
               </a:rPr>
               <a:t>AWS Cloud</a:t>
             </a:r>
-            <a:endParaRPr lang="en-US" sz="800" dirty="0"/>
+            <a:endParaRPr lang="en-US" sz="900" dirty="0"/>
           </a:p>
         </p:txBody>
       </p:sp>
@@ -1788,8 +2124,8 @@
         </p:nvSpPr>
         <p:spPr>
           <a:xfrm>
-            <a:off x="457200" y="1051560"/>
-            <a:ext cx="7406640" cy="5303520"/>
+            <a:off x="329184" y="1645920"/>
+            <a:ext cx="8247888" cy="4590288"/>
           </a:xfrm>
           <a:prstGeom prst="rect">
             <a:avLst/>
@@ -1799,9 +2135,9 @@
               <a:alpha val="0"/>
             </a:srgbClr>
           </a:solidFill>
-          <a:ln w="12700">
+          <a:ln w="15875">
             <a:solidFill>
-              <a:srgbClr val="0972D3"/>
+              <a:srgbClr val="00A4A6"/>
             </a:solidFill>
             <a:prstDash val="dash"/>
           </a:ln>
@@ -1815,8 +2151,8 @@
         </p:nvSpPr>
         <p:spPr>
           <a:xfrm>
-            <a:off x="548640" y="1069848"/>
-            <a:ext cx="1645920" cy="182880"/>
+            <a:off x="640080" y="1673352"/>
+            <a:ext cx="7882128" cy="201168"/>
           </a:xfrm>
           <a:prstGeom prst="rect">
             <a:avLst/>
@@ -1832,9 +2168,9 @@
               <a:buNone/>
             </a:pPr>
             <a:r>
-              <a:rPr lang="en-US" sz="800" b="1" dirty="0">
-                <a:solidFill>
-                  <a:srgbClr val="0972D3"/>
+              <a:rPr lang="en-US" sz="900" b="1" dirty="0">
+                <a:solidFill>
+                  <a:srgbClr val="00A4A6"/>
                 </a:solidFill>
                 <a:latin typeface="Arial" pitchFamily="34" charset="0"/>
                 <a:ea typeface="Arial" pitchFamily="34" charset="-122"/>
@@ -1842,7 +2178,7 @@
               </a:rPr>
               <a:t>Region (us-east-1)</a:t>
             </a:r>
-            <a:endParaRPr lang="en-US" sz="800" dirty="0"/>
+            <a:endParaRPr lang="en-US" sz="900" dirty="0"/>
           </a:p>
         </p:txBody>
       </p:sp>
@@ -1854,18 +2190,18 @@
         </p:nvSpPr>
         <p:spPr>
           <a:xfrm>
-            <a:off x="640080" y="1371600"/>
-            <a:ext cx="2788920" cy="2697480"/>
-          </a:xfrm>
-          <a:prstGeom prst="rect">
-            <a:avLst/>
-          </a:prstGeom>
-          <a:solidFill>
-            <a:srgbClr val="EAF3FB">
-              <a:alpha val="65000"/>
+            <a:off x="475488" y="1993392"/>
+            <a:ext cx="2761488" cy="2788920"/>
+          </a:xfrm>
+          <a:prstGeom prst="rect">
+            <a:avLst/>
+          </a:prstGeom>
+          <a:solidFill>
+            <a:srgbClr val="FFFFFF">
+              <a:alpha val="0"/>
             </a:srgbClr>
           </a:solidFill>
-          <a:ln w="12700">
+          <a:ln w="15875">
             <a:solidFill>
               <a:srgbClr val="FF9900"/>
             </a:solidFill>
@@ -1873,9 +2209,48 @@
           </a:ln>
         </p:spPr>
       </p:sp>
+      <p:sp>
+        <p:nvSpPr>
+          <p:cNvPr id="29" name="Text 27"/>
+          <p:cNvSpPr/>
+          <p:nvPr/>
+        </p:nvSpPr>
+        <p:spPr>
+          <a:xfrm>
+            <a:off x="786384" y="2020824"/>
+            <a:ext cx="2395728" cy="201168"/>
+          </a:xfrm>
+          <a:prstGeom prst="rect">
+            <a:avLst/>
+          </a:prstGeom>
+          <a:noFill/>
+          <a:ln/>
+        </p:spPr>
+        <p:txBody>
+          <a:bodyPr wrap="square" rtlCol="0" anchor="ctr"/>
+          <a:lstStyle/>
+          <a:p>
+            <a:pPr indent="0" marL="0">
+              <a:buNone/>
+            </a:pPr>
+            <a:r>
+              <a:rPr lang="en-US" sz="900" b="1" dirty="0">
+                <a:solidFill>
+                  <a:srgbClr val="FF9900"/>
+                </a:solidFill>
+                <a:latin typeface="Arial" pitchFamily="34" charset="0"/>
+                <a:ea typeface="Arial" pitchFamily="34" charset="-122"/>
+                <a:cs typeface="Arial" pitchFamily="34" charset="-120"/>
+              </a:rPr>
+              <a:t>Amazon EKS · open5gs-amp-cluster</a:t>
+            </a:r>
+            <a:endParaRPr lang="en-US" sz="900" dirty="0"/>
+          </a:p>
+        </p:txBody>
+      </p:sp>
       <p:pic>
         <p:nvPicPr>
-          <p:cNvPr id="29" name="Image 0" descr="/Users/mdsherif/Library/CloudStorage/WorkDocsDrive-Documents/MyMac/06Tools/24-ai-devops-amp/docs/diagrams/icons/AmazonElasticKubernetesService.png">    </p:cNvPr>
+          <p:cNvPr id="30" name="Image 0" descr="/Users/mdsherif/Library/CloudStorage/WorkDocsDrive-Documents/MyMac/06Tools/24-ai-devops-amp/docs/diagrams/icons/AmazonElasticKubernetesService.png">    </p:cNvPr>
           <p:cNvPicPr>
             <a:picLocks noChangeAspect="1"/>
           </p:cNvPicPr>
@@ -1889,8 +2264,8 @@
         </p:blipFill>
         <p:spPr>
           <a:xfrm>
-            <a:off x="713232" y="1417320"/>
-            <a:ext cx="292608" cy="292608"/>
+            <a:off x="530352" y="2020824"/>
+            <a:ext cx="256032" cy="256032"/>
           </a:xfrm>
           <a:prstGeom prst="rect">
             <a:avLst/>
@@ -1899,53 +2274,14 @@
       </p:pic>
       <p:sp>
         <p:nvSpPr>
-          <p:cNvPr id="30" name="Text 27"/>
-          <p:cNvSpPr/>
-          <p:nvPr/>
-        </p:nvSpPr>
-        <p:spPr>
-          <a:xfrm>
-            <a:off x="1042416" y="1435608"/>
-            <a:ext cx="2286000" cy="274320"/>
-          </a:xfrm>
-          <a:prstGeom prst="rect">
-            <a:avLst/>
-          </a:prstGeom>
-          <a:noFill/>
-          <a:ln/>
-        </p:spPr>
-        <p:txBody>
-          <a:bodyPr wrap="square" rtlCol="0" anchor="ctr"/>
-          <a:lstStyle/>
-          <a:p>
-            <a:pPr indent="0" marL="0">
-              <a:buNone/>
-            </a:pPr>
-            <a:r>
-              <a:rPr lang="en-US" sz="800" b="1" dirty="0">
-                <a:solidFill>
-                  <a:srgbClr val="232F3E"/>
-                </a:solidFill>
-                <a:latin typeface="Arial" pitchFamily="34" charset="0"/>
-                <a:ea typeface="Arial" pitchFamily="34" charset="-122"/>
-                <a:cs typeface="Arial" pitchFamily="34" charset="-120"/>
-              </a:rPr>
-              <a:t>Amazon EKS · open5gs-amp-cluster</a:t>
-            </a:r>
-            <a:endParaRPr lang="en-US" sz="800" dirty="0"/>
-          </a:p>
-        </p:txBody>
-      </p:sp>
-      <p:sp>
-        <p:nvSpPr>
           <p:cNvPr id="31" name="Text 28"/>
           <p:cNvSpPr/>
           <p:nvPr/>
         </p:nvSpPr>
         <p:spPr>
           <a:xfrm>
-            <a:off x="777240" y="1828800"/>
-            <a:ext cx="2514600" cy="457200"/>
+            <a:off x="585216" y="2359152"/>
+            <a:ext cx="2542032" cy="457200"/>
           </a:xfrm>
           <a:prstGeom prst="rect">
             <a:avLst/>
@@ -1955,7 +2291,7 @@
           </a:solidFill>
           <a:ln w="12700">
             <a:solidFill>
-              <a:srgbClr val="666666"/>
+              <a:srgbClr val="545B64"/>
             </a:solidFill>
           </a:ln>
         </p:spPr>
@@ -1975,10 +2311,27 @@
                 <a:ea typeface="Arial" pitchFamily="34" charset="-122"/>
                 <a:cs typeface="Arial" pitchFamily="34" charset="-120"/>
               </a:rPr>
-              <a:t>UERANSIM RAN — 100 gNodeBs · 1,000 UEs</a:t>
+              <a:t>UERANSIM RAN</a:t>
             </a:r>
             <a:endParaRPr lang="en-US" sz="800" dirty="0"/>
           </a:p>
+          <a:p>
+            <a:pPr algn="ctr" indent="0" marL="0">
+              <a:buNone/>
+            </a:pPr>
+            <a:r>
+              <a:rPr lang="en-US" sz="800" b="1" dirty="0">
+                <a:solidFill>
+                  <a:srgbClr val="232F3E"/>
+                </a:solidFill>
+                <a:latin typeface="Arial" pitchFamily="34" charset="0"/>
+                <a:ea typeface="Arial" pitchFamily="34" charset="-122"/>
+                <a:cs typeface="Arial" pitchFamily="34" charset="-120"/>
+              </a:rPr>
+              <a:t>100 gNodeBs · 1,000 UEs</a:t>
+            </a:r>
+            <a:endParaRPr lang="en-US" sz="800" dirty="0"/>
+          </a:p>
         </p:txBody>
       </p:sp>
       <p:sp>
@@ -1989,8 +2342,8 @@
         </p:nvSpPr>
         <p:spPr>
           <a:xfrm>
-            <a:off x="777240" y="2377440"/>
-            <a:ext cx="2514600" cy="685800"/>
+            <a:off x="585216" y="2889504"/>
+            <a:ext cx="2542032" cy="658368"/>
           </a:xfrm>
           <a:prstGeom prst="rect">
             <a:avLst/>
@@ -2000,7 +2353,7 @@
           </a:solidFill>
           <a:ln w="12700">
             <a:solidFill>
-              <a:srgbClr val="666666"/>
+              <a:srgbClr val="545B64"/>
             </a:solidFill>
           </a:ln>
         </p:spPr>
@@ -2051,8 +2404,8 @@
         </p:nvSpPr>
         <p:spPr>
           <a:xfrm>
-            <a:off x="777240" y="3200400"/>
-            <a:ext cx="2514600" cy="640080"/>
+            <a:off x="585216" y="3621024"/>
+            <a:ext cx="2542032" cy="566928"/>
           </a:xfrm>
           <a:prstGeom prst="rect">
             <a:avLst/>
@@ -2113,14 +2466,14 @@
         </p:nvSpPr>
         <p:spPr>
           <a:xfrm>
-            <a:off x="512064" y="1554480"/>
-            <a:ext cx="219456" cy="219456"/>
+            <a:off x="365760" y="2103120"/>
+            <a:ext cx="237744" cy="237744"/>
           </a:xfrm>
           <a:prstGeom prst="ellipse">
             <a:avLst/>
           </a:prstGeom>
           <a:solidFill>
-            <a:srgbClr val="FF9900"/>
+            <a:srgbClr val="232F3E"/>
           </a:solidFill>
           <a:ln/>
         </p:spPr>
@@ -2148,7 +2501,7 @@
       </p:sp>
       <p:pic>
         <p:nvPicPr>
-          <p:cNvPr id="35" name="Image 1" descr="/Users/mdsherif/Library/CloudStorage/WorkDocsDrive-Documents/MyMac/06Tools/24-ai-devops-amp/docs/diagrams/icons/AmazonManagedServiceforPrometheus.png">    </p:cNvPr>
+          <p:cNvPr id="35" name="Image 1" descr="/Users/mdsherif/Library/CloudStorage/WorkDocsDrive-Documents/MyMac/06Tools/24-ai-devops-amp/docs/diagrams/icons/AmazonSageMaker.png">    </p:cNvPr>
           <p:cNvPicPr>
             <a:picLocks noChangeAspect="1"/>
           </p:cNvPicPr>
@@ -2162,8 +2515,8 @@
         </p:blipFill>
         <p:spPr>
           <a:xfrm>
-            <a:off x="4617720" y="1371600"/>
-            <a:ext cx="457200" cy="457200"/>
+            <a:off x="1143000" y="5074920"/>
+            <a:ext cx="548640" cy="548640"/>
           </a:xfrm>
           <a:prstGeom prst="rect">
             <a:avLst/>
@@ -2178,8 +2531,8 @@
         </p:nvSpPr>
         <p:spPr>
           <a:xfrm>
-            <a:off x="3703320" y="1837944"/>
-            <a:ext cx="2286000" cy="365760"/>
+            <a:off x="502920" y="5632704"/>
+            <a:ext cx="1828800" cy="329184"/>
           </a:xfrm>
           <a:prstGeom prst="rect">
             <a:avLst/>
@@ -2203,7 +2556,7 @@
                 <a:ea typeface="Arial" pitchFamily="34" charset="-122"/>
                 <a:cs typeface="Arial" pitchFamily="34" charset="-120"/>
               </a:rPr>
-              <a:t>Amazon Managed Service</a:t>
+              <a:t>Amazon SageMaker</a:t>
             </a:r>
             <a:endParaRPr lang="en-US" sz="800" dirty="0"/>
           </a:p>
@@ -2220,7 +2573,7 @@
                 <a:ea typeface="Arial" pitchFamily="34" charset="-122"/>
                 <a:cs typeface="Arial" pitchFamily="34" charset="-120"/>
               </a:rPr>
-              <a:t>for Prometheus</a:t>
+              <a:t>Demo notebook</a:t>
             </a:r>
             <a:endParaRPr lang="en-US" sz="800" dirty="0"/>
           </a:p>
@@ -2234,20 +2587,16 @@
         </p:nvSpPr>
         <p:spPr>
           <a:xfrm>
-            <a:off x="3977640" y="2331720"/>
-            <a:ext cx="1737360" cy="457200"/>
-          </a:xfrm>
-          <a:prstGeom prst="rect">
-            <a:avLst/>
-          </a:prstGeom>
-          <a:solidFill>
-            <a:srgbClr val="DCEEDC"/>
-          </a:solidFill>
-          <a:ln w="12700">
-            <a:solidFill>
-              <a:srgbClr val="1B8B1B"/>
-            </a:solidFill>
-          </a:ln>
+            <a:off x="786384" y="5102352"/>
+            <a:ext cx="237744" cy="237744"/>
+          </a:xfrm>
+          <a:prstGeom prst="ellipse">
+            <a:avLst/>
+          </a:prstGeom>
+          <a:solidFill>
+            <a:srgbClr val="232F3E"/>
+          </a:solidFill>
+          <a:ln/>
         </p:spPr>
         <p:txBody>
           <a:bodyPr wrap="square" rtlCol="0" anchor="ctr"/>
@@ -2257,47 +2606,6 @@
               <a:buNone/>
             </a:pPr>
             <a:r>
-              <a:rPr lang="en-US" sz="750" b="1" dirty="0">
-                <a:solidFill>
-                  <a:srgbClr val="232F3E"/>
-                </a:solidFill>
-                <a:latin typeface="Arial" pitchFamily="34" charset="0"/>
-                <a:ea typeface="Arial" pitchFamily="34" charset="-122"/>
-                <a:cs typeface="Arial" pitchFamily="34" charset="-120"/>
-              </a:rPr>
-              <a:t>RCF anomaly detector — score &gt; 0.1 · 30s</a:t>
-            </a:r>
-            <a:endParaRPr lang="en-US" sz="750" dirty="0"/>
-          </a:p>
-        </p:txBody>
-      </p:sp>
-      <p:sp>
-        <p:nvSpPr>
-          <p:cNvPr id="38" name="Text 34"/>
-          <p:cNvSpPr/>
-          <p:nvPr/>
-        </p:nvSpPr>
-        <p:spPr>
-          <a:xfrm>
-            <a:off x="3703320" y="1426464"/>
-            <a:ext cx="219456" cy="219456"/>
-          </a:xfrm>
-          <a:prstGeom prst="ellipse">
-            <a:avLst/>
-          </a:prstGeom>
-          <a:solidFill>
-            <a:srgbClr val="FF9900"/>
-          </a:solidFill>
-          <a:ln/>
-        </p:spPr>
-        <p:txBody>
-          <a:bodyPr wrap="square" rtlCol="0" anchor="ctr"/>
-          <a:lstStyle/>
-          <a:p>
-            <a:pPr algn="ctr" indent="0" marL="0">
-              <a:buNone/>
-            </a:pPr>
-            <a:r>
               <a:rPr lang="en-US" sz="850" b="1" dirty="0">
                 <a:solidFill>
                   <a:srgbClr val="FFFFFF"/>
@@ -2306,48 +2614,7 @@
                 <a:ea typeface="Arial" pitchFamily="34" charset="-122"/>
                 <a:cs typeface="Arial" pitchFamily="34" charset="-120"/>
               </a:rPr>
-              <a:t>2</a:t>
-            </a:r>
-            <a:endParaRPr lang="en-US" sz="850" dirty="0"/>
-          </a:p>
-        </p:txBody>
-      </p:sp>
-      <p:sp>
-        <p:nvSpPr>
-          <p:cNvPr id="39" name="Text 35"/>
-          <p:cNvSpPr/>
-          <p:nvPr/>
-        </p:nvSpPr>
-        <p:spPr>
-          <a:xfrm>
-            <a:off x="5486400" y="1426464"/>
-            <a:ext cx="219456" cy="219456"/>
-          </a:xfrm>
-          <a:prstGeom prst="ellipse">
-            <a:avLst/>
-          </a:prstGeom>
-          <a:solidFill>
-            <a:srgbClr val="FF9900"/>
-          </a:solidFill>
-          <a:ln/>
-        </p:spPr>
-        <p:txBody>
-          <a:bodyPr wrap="square" rtlCol="0" anchor="ctr"/>
-          <a:lstStyle/>
-          <a:p>
-            <a:pPr algn="ctr" indent="0" marL="0">
-              <a:buNone/>
-            </a:pPr>
-            <a:r>
-              <a:rPr lang="en-US" sz="850" b="1" dirty="0">
-                <a:solidFill>
-                  <a:srgbClr val="FFFFFF"/>
-                </a:solidFill>
-                <a:latin typeface="Arial" pitchFamily="34" charset="0"/>
-                <a:ea typeface="Arial" pitchFamily="34" charset="-122"/>
-                <a:cs typeface="Arial" pitchFamily="34" charset="-120"/>
-              </a:rPr>
-              <a:t>3</a:t>
+              <a:t>9</a:t>
             </a:r>
             <a:endParaRPr lang="en-US" sz="850" dirty="0"/>
           </a:p>
@@ -2355,7 +2622,7 @@
       </p:sp>
       <p:pic>
         <p:nvPicPr>
-          <p:cNvPr id="40" name="Image 2" descr="/Users/mdsherif/Library/CloudStorage/WorkDocsDrive-Documents/MyMac/06Tools/24-ai-devops-amp/docs/diagrams/icons/AmazonSimpleNotificationService.png">    </p:cNvPr>
+          <p:cNvPr id="38" name="Image 2" descr="/Users/mdsherif/Library/CloudStorage/WorkDocsDrive-Documents/MyMac/06Tools/24-ai-devops-amp/docs/diagrams/icons/AmazonManagedServiceforPrometheus.png">    </p:cNvPr>
           <p:cNvPicPr>
             <a:picLocks noChangeAspect="1"/>
           </p:cNvPicPr>
@@ -2369,8 +2636,8 @@
         </p:blipFill>
         <p:spPr>
           <a:xfrm>
-            <a:off x="6812280" y="1371600"/>
-            <a:ext cx="457200" cy="457200"/>
+            <a:off x="4023360" y="2103120"/>
+            <a:ext cx="548640" cy="548640"/>
           </a:xfrm>
           <a:prstGeom prst="rect">
             <a:avLst/>
@@ -2379,57 +2646,160 @@
       </p:pic>
       <p:sp>
         <p:nvSpPr>
+          <p:cNvPr id="39" name="Text 34"/>
+          <p:cNvSpPr/>
+          <p:nvPr/>
+        </p:nvSpPr>
+        <p:spPr>
+          <a:xfrm>
+            <a:off x="3383280" y="2660904"/>
+            <a:ext cx="1828800" cy="329184"/>
+          </a:xfrm>
+          <a:prstGeom prst="rect">
+            <a:avLst/>
+          </a:prstGeom>
+          <a:noFill/>
+          <a:ln/>
+        </p:spPr>
+        <p:txBody>
+          <a:bodyPr wrap="square" rtlCol="0" anchor="t"/>
+          <a:lstStyle/>
+          <a:p>
+            <a:pPr algn="ctr" indent="0" marL="0">
+              <a:buNone/>
+            </a:pPr>
+            <a:r>
+              <a:rPr lang="en-US" sz="800" dirty="0">
+                <a:solidFill>
+                  <a:srgbClr val="232F3E"/>
+                </a:solidFill>
+                <a:latin typeface="Arial" pitchFamily="34" charset="0"/>
+                <a:ea typeface="Arial" pitchFamily="34" charset="-122"/>
+                <a:cs typeface="Arial" pitchFamily="34" charset="-120"/>
+              </a:rPr>
+              <a:t>Amazon Managed Service</a:t>
+            </a:r>
+            <a:endParaRPr lang="en-US" sz="800" dirty="0"/>
+          </a:p>
+          <a:p>
+            <a:pPr algn="ctr" indent="0" marL="0">
+              <a:buNone/>
+            </a:pPr>
+            <a:r>
+              <a:rPr lang="en-US" sz="800" dirty="0">
+                <a:solidFill>
+                  <a:srgbClr val="232F3E"/>
+                </a:solidFill>
+                <a:latin typeface="Arial" pitchFamily="34" charset="0"/>
+                <a:ea typeface="Arial" pitchFamily="34" charset="-122"/>
+                <a:cs typeface="Arial" pitchFamily="34" charset="-120"/>
+              </a:rPr>
+              <a:t>for Prometheus</a:t>
+            </a:r>
+            <a:endParaRPr lang="en-US" sz="800" dirty="0"/>
+          </a:p>
+        </p:txBody>
+      </p:sp>
+      <p:sp>
+        <p:nvSpPr>
+          <p:cNvPr id="40" name="Text 35"/>
+          <p:cNvSpPr/>
+          <p:nvPr/>
+        </p:nvSpPr>
+        <p:spPr>
+          <a:xfrm>
+            <a:off x="3611880" y="3218688"/>
+            <a:ext cx="1783080" cy="457200"/>
+          </a:xfrm>
+          <a:prstGeom prst="rect">
+            <a:avLst/>
+          </a:prstGeom>
+          <a:solidFill>
+            <a:srgbClr val="DCEEDC"/>
+          </a:solidFill>
+          <a:ln w="12700">
+            <a:solidFill>
+              <a:srgbClr val="1B8B1B"/>
+            </a:solidFill>
+          </a:ln>
+        </p:spPr>
+        <p:txBody>
+          <a:bodyPr wrap="square" rtlCol="0" anchor="ctr"/>
+          <a:lstStyle/>
+          <a:p>
+            <a:pPr algn="ctr" indent="0" marL="0">
+              <a:buNone/>
+            </a:pPr>
+            <a:r>
+              <a:rPr lang="en-US" sz="750" b="1" dirty="0">
+                <a:solidFill>
+                  <a:srgbClr val="232F3E"/>
+                </a:solidFill>
+                <a:latin typeface="Arial" pitchFamily="34" charset="0"/>
+                <a:ea typeface="Arial" pitchFamily="34" charset="-122"/>
+                <a:cs typeface="Arial" pitchFamily="34" charset="-120"/>
+              </a:rPr>
+              <a:t>RCF anomaly detector</a:t>
+            </a:r>
+            <a:endParaRPr lang="en-US" sz="750" dirty="0"/>
+          </a:p>
+          <a:p>
+            <a:pPr algn="ctr" indent="0" marL="0">
+              <a:buNone/>
+            </a:pPr>
+            <a:r>
+              <a:rPr lang="en-US" sz="750" b="1" dirty="0">
+                <a:solidFill>
+                  <a:srgbClr val="232F3E"/>
+                </a:solidFill>
+                <a:latin typeface="Arial" pitchFamily="34" charset="0"/>
+                <a:ea typeface="Arial" pitchFamily="34" charset="-122"/>
+                <a:cs typeface="Arial" pitchFamily="34" charset="-120"/>
+              </a:rPr>
+              <a:t>score &gt; 0.1 · 30s</a:t>
+            </a:r>
+            <a:endParaRPr lang="en-US" sz="750" dirty="0"/>
+          </a:p>
+        </p:txBody>
+      </p:sp>
+      <p:sp>
+        <p:nvSpPr>
           <p:cNvPr id="41" name="Text 36"/>
           <p:cNvSpPr/>
           <p:nvPr/>
         </p:nvSpPr>
         <p:spPr>
           <a:xfrm>
-            <a:off x="6172200" y="1837944"/>
-            <a:ext cx="1737360" cy="365760"/>
-          </a:xfrm>
-          <a:prstGeom prst="rect">
-            <a:avLst/>
-          </a:prstGeom>
-          <a:noFill/>
-          <a:ln/>
-        </p:spPr>
-        <p:txBody>
-          <a:bodyPr wrap="square" rtlCol="0" anchor="t"/>
-          <a:lstStyle/>
-          <a:p>
-            <a:pPr algn="ctr" indent="0" marL="0">
-              <a:buNone/>
-            </a:pPr>
-            <a:r>
-              <a:rPr lang="en-US" sz="800" dirty="0">
-                <a:solidFill>
-                  <a:srgbClr val="232F3E"/>
-                </a:solidFill>
-                <a:latin typeface="Arial" pitchFamily="34" charset="0"/>
-                <a:ea typeface="Arial" pitchFamily="34" charset="-122"/>
-                <a:cs typeface="Arial" pitchFamily="34" charset="-120"/>
-              </a:rPr>
-              <a:t>Amazon SNS</a:t>
-            </a:r>
-            <a:endParaRPr lang="en-US" sz="800" dirty="0"/>
-          </a:p>
-          <a:p>
-            <a:pPr algn="ctr" indent="0" marL="0">
-              <a:buNone/>
-            </a:pPr>
-            <a:r>
-              <a:rPr lang="en-US" sz="800" dirty="0">
-                <a:solidFill>
-                  <a:srgbClr val="232F3E"/>
-                </a:solidFill>
-                <a:latin typeface="Arial" pitchFamily="34" charset="0"/>
-                <a:ea typeface="Arial" pitchFamily="34" charset="-122"/>
-                <a:cs typeface="Arial" pitchFamily="34" charset="-120"/>
-              </a:rPr>
-              <a:t>RCA trigger topic</a:t>
-            </a:r>
-            <a:endParaRPr lang="en-US" sz="800" dirty="0"/>
+            <a:off x="3675888" y="2048256"/>
+            <a:ext cx="237744" cy="237744"/>
+          </a:xfrm>
+          <a:prstGeom prst="ellipse">
+            <a:avLst/>
+          </a:prstGeom>
+          <a:solidFill>
+            <a:srgbClr val="232F3E"/>
+          </a:solidFill>
+          <a:ln/>
+        </p:spPr>
+        <p:txBody>
+          <a:bodyPr wrap="square" rtlCol="0" anchor="ctr"/>
+          <a:lstStyle/>
+          <a:p>
+            <a:pPr algn="ctr" indent="0" marL="0">
+              <a:buNone/>
+            </a:pPr>
+            <a:r>
+              <a:rPr lang="en-US" sz="850" b="1" dirty="0">
+                <a:solidFill>
+                  <a:srgbClr val="FFFFFF"/>
+                </a:solidFill>
+                <a:latin typeface="Arial" pitchFamily="34" charset="0"/>
+                <a:ea typeface="Arial" pitchFamily="34" charset="-122"/>
+                <a:cs typeface="Arial" pitchFamily="34" charset="-120"/>
+              </a:rPr>
+              <a:t>2</a:t>
+            </a:r>
+            <a:endParaRPr lang="en-US" sz="850" dirty="0"/>
           </a:p>
         </p:txBody>
       </p:sp>
@@ -2441,14 +2811,14 @@
         </p:nvSpPr>
         <p:spPr>
           <a:xfrm>
-            <a:off x="6035040" y="1426464"/>
-            <a:ext cx="219456" cy="219456"/>
+            <a:off x="4791456" y="2048256"/>
+            <a:ext cx="237744" cy="237744"/>
           </a:xfrm>
           <a:prstGeom prst="ellipse">
             <a:avLst/>
           </a:prstGeom>
           <a:solidFill>
-            <a:srgbClr val="FF9900"/>
+            <a:srgbClr val="232F3E"/>
           </a:solidFill>
           <a:ln/>
         </p:spPr>
@@ -2468,7 +2838,7 @@
                 <a:ea typeface="Arial" pitchFamily="34" charset="-122"/>
                 <a:cs typeface="Arial" pitchFamily="34" charset="-120"/>
               </a:rPr>
-              <a:t>4</a:t>
+              <a:t>3</a:t>
             </a:r>
             <a:endParaRPr lang="en-US" sz="850" dirty="0"/>
           </a:p>
@@ -2476,7 +2846,7 @@
       </p:sp>
       <p:pic>
         <p:nvPicPr>
-          <p:cNvPr id="43" name="Image 3" descr="/Users/mdsherif/Library/CloudStorage/WorkDocsDrive-Documents/MyMac/06Tools/24-ai-devops-amp/docs/diagrams/icons/AWSLambda.png">    </p:cNvPr>
+          <p:cNvPr id="43" name="Image 3" descr="/Users/mdsherif/Library/CloudStorage/WorkDocsDrive-Documents/MyMac/06Tools/24-ai-devops-amp/docs/diagrams/icons/AWSSecretsManager.png">    </p:cNvPr>
           <p:cNvPicPr>
             <a:picLocks noChangeAspect="1"/>
           </p:cNvPicPr>
@@ -2490,8 +2860,8 @@
         </p:blipFill>
         <p:spPr>
           <a:xfrm>
-            <a:off x="6812280" y="2743200"/>
-            <a:ext cx="457200" cy="457200"/>
+            <a:off x="4023360" y="3931920"/>
+            <a:ext cx="548640" cy="548640"/>
           </a:xfrm>
           <a:prstGeom prst="rect">
             <a:avLst/>
@@ -2506,8 +2876,8 @@
         </p:nvSpPr>
         <p:spPr>
           <a:xfrm>
-            <a:off x="6172200" y="3209544"/>
-            <a:ext cx="1737360" cy="365760"/>
+            <a:off x="3383280" y="4489704"/>
+            <a:ext cx="1828800" cy="329184"/>
           </a:xfrm>
           <a:prstGeom prst="rect">
             <a:avLst/>
@@ -2531,7 +2901,7 @@
                 <a:ea typeface="Arial" pitchFamily="34" charset="-122"/>
                 <a:cs typeface="Arial" pitchFamily="34" charset="-120"/>
               </a:rPr>
-              <a:t>AWS Lambda</a:t>
+              <a:t>AWS Secrets Manager</a:t>
             </a:r>
             <a:endParaRPr lang="en-US" sz="800" dirty="0"/>
           </a:p>
@@ -2548,7 +2918,7 @@
                 <a:ea typeface="Arial" pitchFamily="34" charset="-122"/>
                 <a:cs typeface="Arial" pitchFamily="34" charset="-120"/>
               </a:rPr>
-              <a:t>Root-cause analysis</a:t>
+              <a:t>webhook url + token</a:t>
             </a:r>
             <a:endParaRPr lang="en-US" sz="800" dirty="0"/>
           </a:p>
@@ -2562,14 +2932,14 @@
         </p:nvSpPr>
         <p:spPr>
           <a:xfrm>
-            <a:off x="6035040" y="2798064"/>
-            <a:ext cx="219456" cy="219456"/>
+            <a:off x="3675888" y="3877056"/>
+            <a:ext cx="237744" cy="237744"/>
           </a:xfrm>
           <a:prstGeom prst="ellipse">
             <a:avLst/>
           </a:prstGeom>
           <a:solidFill>
-            <a:srgbClr val="FF9900"/>
+            <a:srgbClr val="232F3E"/>
           </a:solidFill>
           <a:ln/>
         </p:spPr>
@@ -2589,7 +2959,7 @@
                 <a:ea typeface="Arial" pitchFamily="34" charset="-122"/>
                 <a:cs typeface="Arial" pitchFamily="34" charset="-120"/>
               </a:rPr>
-              <a:t>5</a:t>
+              <a:t>7</a:t>
             </a:r>
             <a:endParaRPr lang="en-US" sz="850" dirty="0"/>
           </a:p>
@@ -2597,48 +2967,73 @@
       </p:sp>
       <p:sp>
         <p:nvSpPr>
-          <p:cNvPr id="46" name="Text 40"/>
-          <p:cNvSpPr/>
-          <p:nvPr/>
-        </p:nvSpPr>
-        <p:spPr>
-          <a:xfrm>
-            <a:off x="5760720" y="2697480"/>
-            <a:ext cx="219456" cy="219456"/>
-          </a:xfrm>
-          <a:prstGeom prst="ellipse">
-            <a:avLst/>
-          </a:prstGeom>
-          <a:solidFill>
-            <a:srgbClr val="FF9900"/>
-          </a:solidFill>
+          <p:cNvPr id="46" name="Shape 40"/>
+          <p:cNvSpPr/>
+          <p:nvPr/>
+        </p:nvSpPr>
+        <p:spPr>
+          <a:xfrm>
+            <a:off x="3547872" y="5010912"/>
+            <a:ext cx="2331720" cy="960120"/>
+          </a:xfrm>
+          <a:prstGeom prst="rect">
+            <a:avLst/>
+          </a:prstGeom>
+          <a:solidFill>
+            <a:srgbClr val="FFFFFF">
+              <a:alpha val="0"/>
+            </a:srgbClr>
+          </a:solidFill>
+          <a:ln w="15875">
+            <a:solidFill>
+              <a:srgbClr val="7C3AED"/>
+            </a:solidFill>
+            <a:prstDash val="solid"/>
+          </a:ln>
+        </p:spPr>
+      </p:sp>
+      <p:sp>
+        <p:nvSpPr>
+          <p:cNvPr id="47" name="Text 41"/>
+          <p:cNvSpPr/>
+          <p:nvPr/>
+        </p:nvSpPr>
+        <p:spPr>
+          <a:xfrm>
+            <a:off x="3858768" y="5038344"/>
+            <a:ext cx="1965960" cy="201168"/>
+          </a:xfrm>
+          <a:prstGeom prst="rect">
+            <a:avLst/>
+          </a:prstGeom>
+          <a:noFill/>
           <a:ln/>
         </p:spPr>
         <p:txBody>
           <a:bodyPr wrap="square" rtlCol="0" anchor="ctr"/>
           <a:lstStyle/>
           <a:p>
-            <a:pPr algn="ctr" indent="0" marL="0">
-              <a:buNone/>
-            </a:pPr>
-            <a:r>
-              <a:rPr lang="en-US" sz="850" b="1" dirty="0">
-                <a:solidFill>
-                  <a:srgbClr val="FFFFFF"/>
-                </a:solidFill>
-                <a:latin typeface="Arial" pitchFamily="34" charset="0"/>
-                <a:ea typeface="Arial" pitchFamily="34" charset="-122"/>
-                <a:cs typeface="Arial" pitchFamily="34" charset="-120"/>
-              </a:rPr>
-              <a:t>6</a:t>
-            </a:r>
-            <a:endParaRPr lang="en-US" sz="850" dirty="0"/>
+            <a:pPr indent="0" marL="0">
+              <a:buNone/>
+            </a:pPr>
+            <a:r>
+              <a:rPr lang="en-US" sz="900" b="1" dirty="0">
+                <a:solidFill>
+                  <a:srgbClr val="7C3AED"/>
+                </a:solidFill>
+                <a:latin typeface="Arial" pitchFamily="34" charset="0"/>
+                <a:ea typeface="Arial" pitchFamily="34" charset="-122"/>
+                <a:cs typeface="Arial" pitchFamily="34" charset="-120"/>
+              </a:rPr>
+              <a:t>Prometheus MCP (on-demand query)</a:t>
+            </a:r>
+            <a:endParaRPr lang="en-US" sz="900" dirty="0"/>
           </a:p>
         </p:txBody>
       </p:sp>
       <p:pic>
         <p:nvPicPr>
-          <p:cNvPr id="47" name="Image 4" descr="/Users/mdsherif/Library/CloudStorage/WorkDocsDrive-Documents/MyMac/06Tools/24-ai-devops-amp/docs/diagrams/icons/AWSSecretsManager.png">    </p:cNvPr>
+          <p:cNvPr id="48" name="Image 4" descr="/Users/mdsherif/Library/CloudStorage/WorkDocsDrive-Documents/MyMac/06Tools/24-ai-devops-amp/docs/diagrams/icons/AmazonCognito.png">    </p:cNvPr>
           <p:cNvPicPr>
             <a:picLocks noChangeAspect="1"/>
           </p:cNvPicPr>
@@ -2652,8 +3047,8 @@
         </p:blipFill>
         <p:spPr>
           <a:xfrm>
-            <a:off x="4434840" y="3246120"/>
-            <a:ext cx="457200" cy="457200"/>
+            <a:off x="3767328" y="5285232"/>
+            <a:ext cx="548640" cy="548640"/>
           </a:xfrm>
           <a:prstGeom prst="rect">
             <a:avLst/>
@@ -2662,14 +3057,14 @@
       </p:pic>
       <p:sp>
         <p:nvSpPr>
-          <p:cNvPr id="48" name="Text 41"/>
-          <p:cNvSpPr/>
-          <p:nvPr/>
-        </p:nvSpPr>
-        <p:spPr>
-          <a:xfrm>
-            <a:off x="3794760" y="3712464"/>
-            <a:ext cx="1737360" cy="365760"/>
+          <p:cNvPr id="49" name="Text 42"/>
+          <p:cNvSpPr/>
+          <p:nvPr/>
+        </p:nvSpPr>
+        <p:spPr>
+          <a:xfrm>
+            <a:off x="3127248" y="5843016"/>
+            <a:ext cx="1828800" cy="329184"/>
           </a:xfrm>
           <a:prstGeom prst="rect">
             <a:avLst/>
@@ -2685,81 +3080,40 @@
               <a:buNone/>
             </a:pPr>
             <a:r>
-              <a:rPr lang="en-US" sz="800" dirty="0">
-                <a:solidFill>
-                  <a:srgbClr val="232F3E"/>
-                </a:solidFill>
-                <a:latin typeface="Arial" pitchFamily="34" charset="0"/>
-                <a:ea typeface="Arial" pitchFamily="34" charset="-122"/>
-                <a:cs typeface="Arial" pitchFamily="34" charset="-120"/>
-              </a:rPr>
-              <a:t>AWS Secrets Manager</a:t>
-            </a:r>
-            <a:endParaRPr lang="en-US" sz="800" dirty="0"/>
-          </a:p>
-          <a:p>
-            <a:pPr algn="ctr" indent="0" marL="0">
-              <a:buNone/>
-            </a:pPr>
-            <a:r>
-              <a:rPr lang="en-US" sz="800" dirty="0">
-                <a:solidFill>
-                  <a:srgbClr val="232F3E"/>
-                </a:solidFill>
-                <a:latin typeface="Arial" pitchFamily="34" charset="0"/>
-                <a:ea typeface="Arial" pitchFamily="34" charset="-122"/>
-                <a:cs typeface="Arial" pitchFamily="34" charset="-120"/>
-              </a:rPr>
-              <a:t>agent webhook url+token</a:t>
-            </a:r>
-            <a:endParaRPr lang="en-US" sz="800" dirty="0"/>
-          </a:p>
-        </p:txBody>
-      </p:sp>
-      <p:sp>
-        <p:nvSpPr>
-          <p:cNvPr id="49" name="Text 42"/>
-          <p:cNvSpPr/>
-          <p:nvPr/>
-        </p:nvSpPr>
-        <p:spPr>
-          <a:xfrm>
-            <a:off x="5257800" y="3200400"/>
-            <a:ext cx="219456" cy="219456"/>
-          </a:xfrm>
-          <a:prstGeom prst="ellipse">
-            <a:avLst/>
-          </a:prstGeom>
-          <a:solidFill>
-            <a:srgbClr val="FF9900"/>
-          </a:solidFill>
-          <a:ln/>
-        </p:spPr>
-        <p:txBody>
-          <a:bodyPr wrap="square" rtlCol="0" anchor="ctr"/>
-          <a:lstStyle/>
-          <a:p>
-            <a:pPr algn="ctr" indent="0" marL="0">
-              <a:buNone/>
-            </a:pPr>
-            <a:r>
-              <a:rPr lang="en-US" sz="850" b="1" dirty="0">
-                <a:solidFill>
-                  <a:srgbClr val="FFFFFF"/>
-                </a:solidFill>
-                <a:latin typeface="Arial" pitchFamily="34" charset="0"/>
-                <a:ea typeface="Arial" pitchFamily="34" charset="-122"/>
-                <a:cs typeface="Arial" pitchFamily="34" charset="-120"/>
-              </a:rPr>
-              <a:t>7</a:t>
-            </a:r>
-            <a:endParaRPr lang="en-US" sz="850" dirty="0"/>
+              <a:rPr lang="en-US" sz="700" dirty="0">
+                <a:solidFill>
+                  <a:srgbClr val="232F3E"/>
+                </a:solidFill>
+                <a:latin typeface="Arial" pitchFamily="34" charset="0"/>
+                <a:ea typeface="Arial" pitchFamily="34" charset="-122"/>
+                <a:cs typeface="Arial" pitchFamily="34" charset="-120"/>
+              </a:rPr>
+              <a:t>Amazon</a:t>
+            </a:r>
+            <a:endParaRPr lang="en-US" sz="700" dirty="0"/>
+          </a:p>
+          <a:p>
+            <a:pPr algn="ctr" indent="0" marL="0">
+              <a:buNone/>
+            </a:pPr>
+            <a:r>
+              <a:rPr lang="en-US" sz="700" dirty="0">
+                <a:solidFill>
+                  <a:srgbClr val="232F3E"/>
+                </a:solidFill>
+                <a:latin typeface="Arial" pitchFamily="34" charset="0"/>
+                <a:ea typeface="Arial" pitchFamily="34" charset="-122"/>
+                <a:cs typeface="Arial" pitchFamily="34" charset="-120"/>
+              </a:rPr>
+              <a:t>Cognito</a:t>
+            </a:r>
+            <a:endParaRPr lang="en-US" sz="700" dirty="0"/>
           </a:p>
         </p:txBody>
       </p:sp>
       <p:pic>
         <p:nvPicPr>
-          <p:cNvPr id="50" name="Image 5" descr="/Users/mdsherif/Library/CloudStorage/WorkDocsDrive-Documents/MyMac/06Tools/24-ai-devops-amp/docs/diagrams/icons/AWSDevOpsAgent.png">    </p:cNvPr>
+          <p:cNvPr id="50" name="Image 5" descr="/Users/mdsherif/Library/CloudStorage/WorkDocsDrive-Documents/MyMac/06Tools/24-ai-devops-amp/docs/diagrams/icons/AmazonAPIGateway.png">    </p:cNvPr>
           <p:cNvPicPr>
             <a:picLocks noChangeAspect="1"/>
           </p:cNvPicPr>
@@ -2773,8 +3127,8 @@
         </p:blipFill>
         <p:spPr>
           <a:xfrm>
-            <a:off x="6812280" y="4069080"/>
-            <a:ext cx="457200" cy="457200"/>
+            <a:off x="4480560" y="5285232"/>
+            <a:ext cx="548640" cy="548640"/>
           </a:xfrm>
           <a:prstGeom prst="rect">
             <a:avLst/>
@@ -2789,8 +3143,8 @@
         </p:nvSpPr>
         <p:spPr>
           <a:xfrm>
-            <a:off x="6172200" y="4535424"/>
-            <a:ext cx="1737360" cy="365760"/>
+            <a:off x="3840480" y="5843016"/>
+            <a:ext cx="1828800" cy="329184"/>
           </a:xfrm>
           <a:prstGeom prst="rect">
             <a:avLst/>
@@ -2806,81 +3160,40 @@
               <a:buNone/>
             </a:pPr>
             <a:r>
-              <a:rPr lang="en-US" sz="800" dirty="0">
-                <a:solidFill>
-                  <a:srgbClr val="232F3E"/>
-                </a:solidFill>
-                <a:latin typeface="Arial" pitchFamily="34" charset="0"/>
-                <a:ea typeface="Arial" pitchFamily="34" charset="-122"/>
-                <a:cs typeface="Arial" pitchFamily="34" charset="-120"/>
-              </a:rPr>
-              <a:t>AWS DevOps Agent</a:t>
-            </a:r>
-            <a:endParaRPr lang="en-US" sz="800" dirty="0"/>
-          </a:p>
-          <a:p>
-            <a:pPr algn="ctr" indent="0" marL="0">
-              <a:buNone/>
-            </a:pPr>
-            <a:r>
-              <a:rPr lang="en-US" sz="800" dirty="0">
-                <a:solidFill>
-                  <a:srgbClr val="232F3E"/>
-                </a:solidFill>
-                <a:latin typeface="Arial" pitchFamily="34" charset="0"/>
-                <a:ea typeface="Arial" pitchFamily="34" charset="-122"/>
-                <a:cs typeface="Arial" pitchFamily="34" charset="-120"/>
-              </a:rPr>
-              <a:t>autonomous investigation</a:t>
-            </a:r>
-            <a:endParaRPr lang="en-US" sz="800" dirty="0"/>
-          </a:p>
-        </p:txBody>
-      </p:sp>
-      <p:sp>
-        <p:nvSpPr>
-          <p:cNvPr id="52" name="Text 44"/>
-          <p:cNvSpPr/>
-          <p:nvPr/>
-        </p:nvSpPr>
-        <p:spPr>
-          <a:xfrm>
-            <a:off x="6035040" y="4123944"/>
-            <a:ext cx="219456" cy="219456"/>
-          </a:xfrm>
-          <a:prstGeom prst="ellipse">
-            <a:avLst/>
-          </a:prstGeom>
-          <a:solidFill>
-            <a:srgbClr val="FF9900"/>
-          </a:solidFill>
-          <a:ln/>
-        </p:spPr>
-        <p:txBody>
-          <a:bodyPr wrap="square" rtlCol="0" anchor="ctr"/>
-          <a:lstStyle/>
-          <a:p>
-            <a:pPr algn="ctr" indent="0" marL="0">
-              <a:buNone/>
-            </a:pPr>
-            <a:r>
-              <a:rPr lang="en-US" sz="850" b="1" dirty="0">
-                <a:solidFill>
-                  <a:srgbClr val="FFFFFF"/>
-                </a:solidFill>
-                <a:latin typeface="Arial" pitchFamily="34" charset="0"/>
-                <a:ea typeface="Arial" pitchFamily="34" charset="-122"/>
-                <a:cs typeface="Arial" pitchFamily="34" charset="-120"/>
-              </a:rPr>
-              <a:t>8</a:t>
-            </a:r>
-            <a:endParaRPr lang="en-US" sz="850" dirty="0"/>
+              <a:rPr lang="en-US" sz="700" dirty="0">
+                <a:solidFill>
+                  <a:srgbClr val="232F3E"/>
+                </a:solidFill>
+                <a:latin typeface="Arial" pitchFamily="34" charset="0"/>
+                <a:ea typeface="Arial" pitchFamily="34" charset="-122"/>
+                <a:cs typeface="Arial" pitchFamily="34" charset="-120"/>
+              </a:rPr>
+              <a:t>Amazon API</a:t>
+            </a:r>
+            <a:endParaRPr lang="en-US" sz="700" dirty="0"/>
+          </a:p>
+          <a:p>
+            <a:pPr algn="ctr" indent="0" marL="0">
+              <a:buNone/>
+            </a:pPr>
+            <a:r>
+              <a:rPr lang="en-US" sz="700" dirty="0">
+                <a:solidFill>
+                  <a:srgbClr val="232F3E"/>
+                </a:solidFill>
+                <a:latin typeface="Arial" pitchFamily="34" charset="0"/>
+                <a:ea typeface="Arial" pitchFamily="34" charset="-122"/>
+                <a:cs typeface="Arial" pitchFamily="34" charset="-120"/>
+              </a:rPr>
+              <a:t>Gateway</a:t>
+            </a:r>
+            <a:endParaRPr lang="en-US" sz="700" dirty="0"/>
           </a:p>
         </p:txBody>
       </p:sp>
       <p:pic>
         <p:nvPicPr>
-          <p:cNvPr id="53" name="Image 6" descr="/Users/mdsherif/Library/CloudStorage/WorkDocsDrive-Documents/MyMac/06Tools/24-ai-devops-amp/docs/diagrams/icons/AmazonSageMaker.png">    </p:cNvPr>
+          <p:cNvPr id="52" name="Image 6" descr="/Users/mdsherif/Library/CloudStorage/WorkDocsDrive-Documents/MyMac/06Tools/24-ai-devops-amp/docs/diagrams/icons/AWSLambda.png">    </p:cNvPr>
           <p:cNvPicPr>
             <a:picLocks noChangeAspect="1"/>
           </p:cNvPicPr>
@@ -2894,8 +3207,8 @@
         </p:blipFill>
         <p:spPr>
           <a:xfrm>
-            <a:off x="1600200" y="4709160"/>
-            <a:ext cx="457200" cy="457200"/>
+            <a:off x="5193792" y="5285232"/>
+            <a:ext cx="548640" cy="548640"/>
           </a:xfrm>
           <a:prstGeom prst="rect">
             <a:avLst/>
@@ -2904,14 +3217,14 @@
       </p:pic>
       <p:sp>
         <p:nvSpPr>
-          <p:cNvPr id="54" name="Text 45"/>
-          <p:cNvSpPr/>
-          <p:nvPr/>
-        </p:nvSpPr>
-        <p:spPr>
-          <a:xfrm>
-            <a:off x="777240" y="5175504"/>
-            <a:ext cx="2103120" cy="365760"/>
+          <p:cNvPr id="53" name="Text 44"/>
+          <p:cNvSpPr/>
+          <p:nvPr/>
+        </p:nvSpPr>
+        <p:spPr>
+          <a:xfrm>
+            <a:off x="4553712" y="5843016"/>
+            <a:ext cx="1828800" cy="329184"/>
           </a:xfrm>
           <a:prstGeom prst="rect">
             <a:avLst/>
@@ -2927,130 +3240,40 @@
               <a:buNone/>
             </a:pPr>
             <a:r>
-              <a:rPr lang="en-US" sz="800" dirty="0">
-                <a:solidFill>
-                  <a:srgbClr val="232F3E"/>
-                </a:solidFill>
-                <a:latin typeface="Arial" pitchFamily="34" charset="0"/>
-                <a:ea typeface="Arial" pitchFamily="34" charset="-122"/>
-                <a:cs typeface="Arial" pitchFamily="34" charset="-120"/>
-              </a:rPr>
-              <a:t>Amazon SageMaker — Demo notebook</a:t>
-            </a:r>
-            <a:endParaRPr lang="en-US" sz="800" dirty="0"/>
-          </a:p>
-        </p:txBody>
-      </p:sp>
-      <p:sp>
-        <p:nvSpPr>
-          <p:cNvPr id="55" name="Text 46"/>
-          <p:cNvSpPr/>
-          <p:nvPr/>
-        </p:nvSpPr>
-        <p:spPr>
-          <a:xfrm>
-            <a:off x="603504" y="4736592"/>
-            <a:ext cx="219456" cy="219456"/>
-          </a:xfrm>
-          <a:prstGeom prst="ellipse">
-            <a:avLst/>
-          </a:prstGeom>
-          <a:solidFill>
-            <a:srgbClr val="FF9900"/>
-          </a:solidFill>
-          <a:ln/>
-        </p:spPr>
-        <p:txBody>
-          <a:bodyPr wrap="square" rtlCol="0" anchor="ctr"/>
-          <a:lstStyle/>
-          <a:p>
-            <a:pPr algn="ctr" indent="0" marL="0">
-              <a:buNone/>
-            </a:pPr>
-            <a:r>
-              <a:rPr lang="en-US" sz="850" b="1" dirty="0">
-                <a:solidFill>
-                  <a:srgbClr val="FFFFFF"/>
-                </a:solidFill>
-                <a:latin typeface="Arial" pitchFamily="34" charset="0"/>
-                <a:ea typeface="Arial" pitchFamily="34" charset="-122"/>
-                <a:cs typeface="Arial" pitchFamily="34" charset="-120"/>
-              </a:rPr>
-              <a:t>9</a:t>
-            </a:r>
-            <a:endParaRPr lang="en-US" sz="850" dirty="0"/>
-          </a:p>
-        </p:txBody>
-      </p:sp>
-      <p:sp>
-        <p:nvSpPr>
-          <p:cNvPr id="56" name="Shape 47"/>
-          <p:cNvSpPr/>
-          <p:nvPr/>
-        </p:nvSpPr>
-        <p:spPr>
-          <a:xfrm>
-            <a:off x="4892040" y="5029200"/>
-            <a:ext cx="2971800" cy="1280160"/>
-          </a:xfrm>
-          <a:prstGeom prst="rect">
-            <a:avLst/>
-          </a:prstGeom>
-          <a:solidFill>
-            <a:srgbClr val="F3EEFC">
-              <a:alpha val="65000"/>
-            </a:srgbClr>
-          </a:solidFill>
-          <a:ln w="12700">
-            <a:solidFill>
-              <a:srgbClr val="7C3AED"/>
-            </a:solidFill>
-            <a:prstDash val="solid"/>
-          </a:ln>
-        </p:spPr>
-      </p:sp>
-      <p:sp>
-        <p:nvSpPr>
-          <p:cNvPr id="57" name="Text 48"/>
-          <p:cNvSpPr/>
-          <p:nvPr/>
-        </p:nvSpPr>
-        <p:spPr>
-          <a:xfrm>
-            <a:off x="4965192" y="5056632"/>
-            <a:ext cx="2834640" cy="182880"/>
-          </a:xfrm>
-          <a:prstGeom prst="rect">
-            <a:avLst/>
-          </a:prstGeom>
-          <a:noFill/>
-          <a:ln/>
-        </p:spPr>
-        <p:txBody>
-          <a:bodyPr wrap="square" rtlCol="0" anchor="ctr"/>
-          <a:lstStyle/>
-          <a:p>
-            <a:pPr indent="0" marL="0">
-              <a:buNone/>
-            </a:pPr>
-            <a:r>
-              <a:rPr lang="en-US" sz="800" b="1" dirty="0">
-                <a:solidFill>
-                  <a:srgbClr val="232F3E"/>
-                </a:solidFill>
-                <a:latin typeface="Arial" pitchFamily="34" charset="0"/>
-                <a:ea typeface="Arial" pitchFamily="34" charset="-122"/>
-                <a:cs typeface="Arial" pitchFamily="34" charset="-120"/>
-              </a:rPr>
-              <a:t>Prometheus MCP server (on-demand query)</a:t>
-            </a:r>
-            <a:endParaRPr lang="en-US" sz="800" dirty="0"/>
+              <a:rPr lang="en-US" sz="700" dirty="0">
+                <a:solidFill>
+                  <a:srgbClr val="232F3E"/>
+                </a:solidFill>
+                <a:latin typeface="Arial" pitchFamily="34" charset="0"/>
+                <a:ea typeface="Arial" pitchFamily="34" charset="-122"/>
+                <a:cs typeface="Arial" pitchFamily="34" charset="-120"/>
+              </a:rPr>
+              <a:t>AWS</a:t>
+            </a:r>
+            <a:endParaRPr lang="en-US" sz="700" dirty="0"/>
+          </a:p>
+          <a:p>
+            <a:pPr algn="ctr" indent="0" marL="0">
+              <a:buNone/>
+            </a:pPr>
+            <a:r>
+              <a:rPr lang="en-US" sz="700" dirty="0">
+                <a:solidFill>
+                  <a:srgbClr val="232F3E"/>
+                </a:solidFill>
+                <a:latin typeface="Arial" pitchFamily="34" charset="0"/>
+                <a:ea typeface="Arial" pitchFamily="34" charset="-122"/>
+                <a:cs typeface="Arial" pitchFamily="34" charset="-120"/>
+              </a:rPr>
+              <a:t>Lambda</a:t>
+            </a:r>
+            <a:endParaRPr lang="en-US" sz="700" dirty="0"/>
           </a:p>
         </p:txBody>
       </p:sp>
       <p:pic>
         <p:nvPicPr>
-          <p:cNvPr id="58" name="Image 7" descr="/Users/mdsherif/Library/CloudStorage/WorkDocsDrive-Documents/MyMac/06Tools/24-ai-devops-amp/docs/diagrams/icons/AmazonCognito.png">    </p:cNvPr>
+          <p:cNvPr id="54" name="Image 7" descr="/Users/mdsherif/Library/CloudStorage/WorkDocsDrive-Documents/MyMac/06Tools/24-ai-devops-amp/docs/diagrams/icons/AmazonSimpleNotificationService.png">    </p:cNvPr>
           <p:cNvPicPr>
             <a:picLocks noChangeAspect="1"/>
           </p:cNvPicPr>
@@ -3064,8 +3287,8 @@
         </p:blipFill>
         <p:spPr>
           <a:xfrm>
-            <a:off x="5166360" y="5285232"/>
-            <a:ext cx="457200" cy="457200"/>
+            <a:off x="6903720" y="2103120"/>
+            <a:ext cx="548640" cy="548640"/>
           </a:xfrm>
           <a:prstGeom prst="rect">
             <a:avLst/>
@@ -3074,14 +3297,14 @@
       </p:pic>
       <p:sp>
         <p:nvSpPr>
-          <p:cNvPr id="59" name="Text 49"/>
-          <p:cNvSpPr/>
-          <p:nvPr/>
-        </p:nvSpPr>
-        <p:spPr>
-          <a:xfrm>
-            <a:off x="4937760" y="5751576"/>
-            <a:ext cx="914400" cy="365760"/>
+          <p:cNvPr id="55" name="Text 45"/>
+          <p:cNvSpPr/>
+          <p:nvPr/>
+        </p:nvSpPr>
+        <p:spPr>
+          <a:xfrm>
+            <a:off x="6263640" y="2660904"/>
+            <a:ext cx="1828800" cy="329184"/>
           </a:xfrm>
           <a:prstGeom prst="rect">
             <a:avLst/>
@@ -3097,23 +3320,81 @@
               <a:buNone/>
             </a:pPr>
             <a:r>
-              <a:rPr lang="en-US" sz="750" dirty="0">
-                <a:solidFill>
-                  <a:srgbClr val="232F3E"/>
-                </a:solidFill>
-                <a:latin typeface="Arial" pitchFamily="34" charset="0"/>
-                <a:ea typeface="Arial" pitchFamily="34" charset="-122"/>
-                <a:cs typeface="Arial" pitchFamily="34" charset="-120"/>
-              </a:rPr>
-              <a:t>Amazon Cognito</a:t>
-            </a:r>
-            <a:endParaRPr lang="en-US" sz="750" dirty="0"/>
+              <a:rPr lang="en-US" sz="800" dirty="0">
+                <a:solidFill>
+                  <a:srgbClr val="232F3E"/>
+                </a:solidFill>
+                <a:latin typeface="Arial" pitchFamily="34" charset="0"/>
+                <a:ea typeface="Arial" pitchFamily="34" charset="-122"/>
+                <a:cs typeface="Arial" pitchFamily="34" charset="-120"/>
+              </a:rPr>
+              <a:t>Amazon SNS</a:t>
+            </a:r>
+            <a:endParaRPr lang="en-US" sz="800" dirty="0"/>
+          </a:p>
+          <a:p>
+            <a:pPr algn="ctr" indent="0" marL="0">
+              <a:buNone/>
+            </a:pPr>
+            <a:r>
+              <a:rPr lang="en-US" sz="800" dirty="0">
+                <a:solidFill>
+                  <a:srgbClr val="232F3E"/>
+                </a:solidFill>
+                <a:latin typeface="Arial" pitchFamily="34" charset="0"/>
+                <a:ea typeface="Arial" pitchFamily="34" charset="-122"/>
+                <a:cs typeface="Arial" pitchFamily="34" charset="-120"/>
+              </a:rPr>
+              <a:t>RCA trigger topic</a:t>
+            </a:r>
+            <a:endParaRPr lang="en-US" sz="800" dirty="0"/>
+          </a:p>
+        </p:txBody>
+      </p:sp>
+      <p:sp>
+        <p:nvSpPr>
+          <p:cNvPr id="56" name="Text 46"/>
+          <p:cNvSpPr/>
+          <p:nvPr/>
+        </p:nvSpPr>
+        <p:spPr>
+          <a:xfrm>
+            <a:off x="6556248" y="2048256"/>
+            <a:ext cx="237744" cy="237744"/>
+          </a:xfrm>
+          <a:prstGeom prst="ellipse">
+            <a:avLst/>
+          </a:prstGeom>
+          <a:solidFill>
+            <a:srgbClr val="232F3E"/>
+          </a:solidFill>
+          <a:ln/>
+        </p:spPr>
+        <p:txBody>
+          <a:bodyPr wrap="square" rtlCol="0" anchor="ctr"/>
+          <a:lstStyle/>
+          <a:p>
+            <a:pPr algn="ctr" indent="0" marL="0">
+              <a:buNone/>
+            </a:pPr>
+            <a:r>
+              <a:rPr lang="en-US" sz="850" b="1" dirty="0">
+                <a:solidFill>
+                  <a:srgbClr val="FFFFFF"/>
+                </a:solidFill>
+                <a:latin typeface="Arial" pitchFamily="34" charset="0"/>
+                <a:ea typeface="Arial" pitchFamily="34" charset="-122"/>
+                <a:cs typeface="Arial" pitchFamily="34" charset="-120"/>
+              </a:rPr>
+              <a:t>4</a:t>
+            </a:r>
+            <a:endParaRPr lang="en-US" sz="850" dirty="0"/>
           </a:p>
         </p:txBody>
       </p:sp>
       <p:pic>
         <p:nvPicPr>
-          <p:cNvPr id="60" name="Image 8" descr="/Users/mdsherif/Library/CloudStorage/WorkDocsDrive-Documents/MyMac/06Tools/24-ai-devops-amp/docs/diagrams/icons/AmazonAPIGateway.png">    </p:cNvPr>
+          <p:cNvPr id="57" name="Image 8" descr="/Users/mdsherif/Library/CloudStorage/WorkDocsDrive-Documents/MyMac/06Tools/24-ai-devops-amp/docs/diagrams/icons/AWSLambda.png">    </p:cNvPr>
           <p:cNvPicPr>
             <a:picLocks noChangeAspect="1"/>
           </p:cNvPicPr>
@@ -3127,8 +3408,8 @@
         </p:blipFill>
         <p:spPr>
           <a:xfrm>
-            <a:off x="6195060" y="5285232"/>
-            <a:ext cx="457200" cy="457200"/>
+            <a:off x="6903720" y="3657600"/>
+            <a:ext cx="548640" cy="548640"/>
           </a:xfrm>
           <a:prstGeom prst="rect">
             <a:avLst/>
@@ -3137,14 +3418,14 @@
       </p:pic>
       <p:sp>
         <p:nvSpPr>
-          <p:cNvPr id="61" name="Text 50"/>
-          <p:cNvSpPr/>
-          <p:nvPr/>
-        </p:nvSpPr>
-        <p:spPr>
-          <a:xfrm>
-            <a:off x="5943600" y="5751576"/>
-            <a:ext cx="960120" cy="365760"/>
+          <p:cNvPr id="58" name="Text 47"/>
+          <p:cNvSpPr/>
+          <p:nvPr/>
+        </p:nvSpPr>
+        <p:spPr>
+          <a:xfrm>
+            <a:off x="6263640" y="4215384"/>
+            <a:ext cx="1828800" cy="329184"/>
           </a:xfrm>
           <a:prstGeom prst="rect">
             <a:avLst/>
@@ -3160,23 +3441,122 @@
               <a:buNone/>
             </a:pPr>
             <a:r>
-              <a:rPr lang="en-US" sz="750" dirty="0">
-                <a:solidFill>
-                  <a:srgbClr val="232F3E"/>
-                </a:solidFill>
-                <a:latin typeface="Arial" pitchFamily="34" charset="0"/>
-                <a:ea typeface="Arial" pitchFamily="34" charset="-122"/>
-                <a:cs typeface="Arial" pitchFamily="34" charset="-120"/>
-              </a:rPr>
-              <a:t>Amazon API Gateway</a:t>
-            </a:r>
-            <a:endParaRPr lang="en-US" sz="750" dirty="0"/>
+              <a:rPr lang="en-US" sz="800" dirty="0">
+                <a:solidFill>
+                  <a:srgbClr val="232F3E"/>
+                </a:solidFill>
+                <a:latin typeface="Arial" pitchFamily="34" charset="0"/>
+                <a:ea typeface="Arial" pitchFamily="34" charset="-122"/>
+                <a:cs typeface="Arial" pitchFamily="34" charset="-120"/>
+              </a:rPr>
+              <a:t>AWS Lambda</a:t>
+            </a:r>
+            <a:endParaRPr lang="en-US" sz="800" dirty="0"/>
+          </a:p>
+          <a:p>
+            <a:pPr algn="ctr" indent="0" marL="0">
+              <a:buNone/>
+            </a:pPr>
+            <a:r>
+              <a:rPr lang="en-US" sz="800" dirty="0">
+                <a:solidFill>
+                  <a:srgbClr val="232F3E"/>
+                </a:solidFill>
+                <a:latin typeface="Arial" pitchFamily="34" charset="0"/>
+                <a:ea typeface="Arial" pitchFamily="34" charset="-122"/>
+                <a:cs typeface="Arial" pitchFamily="34" charset="-120"/>
+              </a:rPr>
+              <a:t>Root-cause analysis</a:t>
+            </a:r>
+            <a:endParaRPr lang="en-US" sz="800" dirty="0"/>
+          </a:p>
+        </p:txBody>
+      </p:sp>
+      <p:sp>
+        <p:nvSpPr>
+          <p:cNvPr id="59" name="Text 48"/>
+          <p:cNvSpPr/>
+          <p:nvPr/>
+        </p:nvSpPr>
+        <p:spPr>
+          <a:xfrm>
+            <a:off x="6556248" y="3602736"/>
+            <a:ext cx="237744" cy="237744"/>
+          </a:xfrm>
+          <a:prstGeom prst="ellipse">
+            <a:avLst/>
+          </a:prstGeom>
+          <a:solidFill>
+            <a:srgbClr val="232F3E"/>
+          </a:solidFill>
+          <a:ln/>
+        </p:spPr>
+        <p:txBody>
+          <a:bodyPr wrap="square" rtlCol="0" anchor="ctr"/>
+          <a:lstStyle/>
+          <a:p>
+            <a:pPr algn="ctr" indent="0" marL="0">
+              <a:buNone/>
+            </a:pPr>
+            <a:r>
+              <a:rPr lang="en-US" sz="850" b="1" dirty="0">
+                <a:solidFill>
+                  <a:srgbClr val="FFFFFF"/>
+                </a:solidFill>
+                <a:latin typeface="Arial" pitchFamily="34" charset="0"/>
+                <a:ea typeface="Arial" pitchFamily="34" charset="-122"/>
+                <a:cs typeface="Arial" pitchFamily="34" charset="-120"/>
+              </a:rPr>
+              <a:t>5</a:t>
+            </a:r>
+            <a:endParaRPr lang="en-US" sz="850" dirty="0"/>
+          </a:p>
+        </p:txBody>
+      </p:sp>
+      <p:sp>
+        <p:nvSpPr>
+          <p:cNvPr id="60" name="Text 49"/>
+          <p:cNvSpPr/>
+          <p:nvPr/>
+        </p:nvSpPr>
+        <p:spPr>
+          <a:xfrm>
+            <a:off x="7799832" y="3602736"/>
+            <a:ext cx="237744" cy="237744"/>
+          </a:xfrm>
+          <a:prstGeom prst="ellipse">
+            <a:avLst/>
+          </a:prstGeom>
+          <a:solidFill>
+            <a:srgbClr val="232F3E"/>
+          </a:solidFill>
+          <a:ln/>
+        </p:spPr>
+        <p:txBody>
+          <a:bodyPr wrap="square" rtlCol="0" anchor="ctr"/>
+          <a:lstStyle/>
+          <a:p>
+            <a:pPr algn="ctr" indent="0" marL="0">
+              <a:buNone/>
+            </a:pPr>
+            <a:r>
+              <a:rPr lang="en-US" sz="850" b="1" dirty="0">
+                <a:solidFill>
+                  <a:srgbClr val="FFFFFF"/>
+                </a:solidFill>
+                <a:latin typeface="Arial" pitchFamily="34" charset="0"/>
+                <a:ea typeface="Arial" pitchFamily="34" charset="-122"/>
+                <a:cs typeface="Arial" pitchFamily="34" charset="-120"/>
+              </a:rPr>
+              <a:t>6</a:t>
+            </a:r>
+            <a:endParaRPr lang="en-US" sz="850" dirty="0"/>
           </a:p>
         </p:txBody>
       </p:sp>
       <p:pic>
         <p:nvPicPr>
-          <p:cNvPr id="62" name="Image 9" descr="/Users/mdsherif/Library/CloudStorage/WorkDocsDrive-Documents/MyMac/06Tools/24-ai-devops-amp/docs/diagrams/icons/AWSLambda.png">    </p:cNvPr>
+          <p:cNvPr id="61" name="Image 9" descr="/Users/mdsherif/Library/CloudStorage/WorkDocsDrive-Documents/MyMac/06Tools/24-ai-devops-amp/docs/diagrams/icons/AWSDevOpsAgent.png">    </p:cNvPr>
           <p:cNvPicPr>
             <a:picLocks noChangeAspect="1"/>
           </p:cNvPicPr>
@@ -3190,8 +3570,8 @@
         </p:blipFill>
         <p:spPr>
           <a:xfrm>
-            <a:off x="7155180" y="5285232"/>
-            <a:ext cx="457200" cy="457200"/>
+            <a:off x="6903720" y="5074920"/>
+            <a:ext cx="548640" cy="548640"/>
           </a:xfrm>
           <a:prstGeom prst="rect">
             <a:avLst/>
@@ -3200,40 +3580,98 @@
       </p:pic>
       <p:sp>
         <p:nvSpPr>
+          <p:cNvPr id="62" name="Text 50"/>
+          <p:cNvSpPr/>
+          <p:nvPr/>
+        </p:nvSpPr>
+        <p:spPr>
+          <a:xfrm>
+            <a:off x="6263640" y="5632704"/>
+            <a:ext cx="1828800" cy="329184"/>
+          </a:xfrm>
+          <a:prstGeom prst="rect">
+            <a:avLst/>
+          </a:prstGeom>
+          <a:noFill/>
+          <a:ln/>
+        </p:spPr>
+        <p:txBody>
+          <a:bodyPr wrap="square" rtlCol="0" anchor="t"/>
+          <a:lstStyle/>
+          <a:p>
+            <a:pPr algn="ctr" indent="0" marL="0">
+              <a:buNone/>
+            </a:pPr>
+            <a:r>
+              <a:rPr lang="en-US" sz="800" dirty="0">
+                <a:solidFill>
+                  <a:srgbClr val="232F3E"/>
+                </a:solidFill>
+                <a:latin typeface="Arial" pitchFamily="34" charset="0"/>
+                <a:ea typeface="Arial" pitchFamily="34" charset="-122"/>
+                <a:cs typeface="Arial" pitchFamily="34" charset="-120"/>
+              </a:rPr>
+              <a:t>AWS DevOps Agent</a:t>
+            </a:r>
+            <a:endParaRPr lang="en-US" sz="800" dirty="0"/>
+          </a:p>
+          <a:p>
+            <a:pPr algn="ctr" indent="0" marL="0">
+              <a:buNone/>
+            </a:pPr>
+            <a:r>
+              <a:rPr lang="en-US" sz="800" dirty="0">
+                <a:solidFill>
+                  <a:srgbClr val="232F3E"/>
+                </a:solidFill>
+                <a:latin typeface="Arial" pitchFamily="34" charset="0"/>
+                <a:ea typeface="Arial" pitchFamily="34" charset="-122"/>
+                <a:cs typeface="Arial" pitchFamily="34" charset="-120"/>
+              </a:rPr>
+              <a:t>autonomous investigation</a:t>
+            </a:r>
+            <a:endParaRPr lang="en-US" sz="800" dirty="0"/>
+          </a:p>
+        </p:txBody>
+      </p:sp>
+      <p:sp>
+        <p:nvSpPr>
           <p:cNvPr id="63" name="Text 51"/>
           <p:cNvSpPr/>
           <p:nvPr/>
         </p:nvSpPr>
         <p:spPr>
           <a:xfrm>
-            <a:off x="6949440" y="5751576"/>
-            <a:ext cx="868680" cy="365760"/>
-          </a:xfrm>
-          <a:prstGeom prst="rect">
-            <a:avLst/>
-          </a:prstGeom>
-          <a:noFill/>
-          <a:ln/>
-        </p:spPr>
-        <p:txBody>
-          <a:bodyPr wrap="square" rtlCol="0" anchor="t"/>
-          <a:lstStyle/>
-          <a:p>
-            <a:pPr algn="ctr" indent="0" marL="0">
-              <a:buNone/>
-            </a:pPr>
-            <a:r>
-              <a:rPr lang="en-US" sz="750" dirty="0">
-                <a:solidFill>
-                  <a:srgbClr val="232F3E"/>
-                </a:solidFill>
-                <a:latin typeface="Arial" pitchFamily="34" charset="0"/>
-                <a:ea typeface="Arial" pitchFamily="34" charset="-122"/>
-                <a:cs typeface="Arial" pitchFamily="34" charset="-120"/>
-              </a:rPr>
-              <a:t>AWS Lambda</a:t>
-            </a:r>
-            <a:endParaRPr lang="en-US" sz="750" dirty="0"/>
+            <a:off x="6556248" y="5020056"/>
+            <a:ext cx="237744" cy="237744"/>
+          </a:xfrm>
+          <a:prstGeom prst="ellipse">
+            <a:avLst/>
+          </a:prstGeom>
+          <a:solidFill>
+            <a:srgbClr val="232F3E"/>
+          </a:solidFill>
+          <a:ln/>
+        </p:spPr>
+        <p:txBody>
+          <a:bodyPr wrap="square" rtlCol="0" anchor="ctr"/>
+          <a:lstStyle/>
+          <a:p>
+            <a:pPr algn="ctr" indent="0" marL="0">
+              <a:buNone/>
+            </a:pPr>
+            <a:r>
+              <a:rPr lang="en-US" sz="850" b="1" dirty="0">
+                <a:solidFill>
+                  <a:srgbClr val="FFFFFF"/>
+                </a:solidFill>
+                <a:latin typeface="Arial" pitchFamily="34" charset="0"/>
+                <a:ea typeface="Arial" pitchFamily="34" charset="-122"/>
+                <a:cs typeface="Arial" pitchFamily="34" charset="-120"/>
+              </a:rPr>
+              <a:t>8</a:t>
+            </a:r>
+            <a:endParaRPr lang="en-US" sz="850" dirty="0"/>
           </a:p>
         </p:txBody>
       </p:sp>
@@ -3245,8 +3683,8 @@
         </p:nvSpPr>
         <p:spPr>
           <a:xfrm>
-            <a:off x="3429000" y="1737360"/>
-            <a:ext cx="274320" cy="0"/>
+            <a:off x="3236976" y="2377440"/>
+            <a:ext cx="1060704" cy="0"/>
           </a:xfrm>
           <a:prstGeom prst="line">
             <a:avLst/>
@@ -3257,7 +3695,7 @@
               <a:srgbClr val="1B8B1B"/>
             </a:solidFill>
             <a:prstDash val="solid"/>
-            <a:tailEnd type="triangle"/>
+            <a:tailEnd type="arrow"/>
           </a:ln>
         </p:spPr>
       </p:sp>
@@ -3269,8 +3707,8 @@
         </p:nvSpPr>
         <p:spPr>
           <a:xfrm>
-            <a:off x="5989320" y="1737360"/>
-            <a:ext cx="182880" cy="0"/>
+            <a:off x="5120640" y="2377440"/>
+            <a:ext cx="1508760" cy="0"/>
           </a:xfrm>
           <a:prstGeom prst="line">
             <a:avLst/>
@@ -3278,10 +3716,10 @@
           <a:noFill/>
           <a:ln w="15875">
             <a:solidFill>
-              <a:srgbClr val="1B8B1B"/>
+              <a:srgbClr val="545B64"/>
             </a:solidFill>
             <a:prstDash val="solid"/>
-            <a:tailEnd type="triangle"/>
+            <a:tailEnd type="arrow"/>
           </a:ln>
         </p:spPr>
       </p:sp>
@@ -3293,8 +3731,8 @@
         </p:nvSpPr>
         <p:spPr>
           <a:xfrm>
-            <a:off x="7040880" y="2148840"/>
-            <a:ext cx="0" cy="594360"/>
+            <a:off x="7178040" y="2697480"/>
+            <a:ext cx="0" cy="960120"/>
           </a:xfrm>
           <a:prstGeom prst="line">
             <a:avLst/>
@@ -3305,7 +3743,7 @@
               <a:srgbClr val="7C3AED"/>
             </a:solidFill>
             <a:prstDash val="solid"/>
-            <a:tailEnd type="triangle"/>
+            <a:tailEnd type="arrow"/>
           </a:ln>
         </p:spPr>
       </p:sp>
@@ -3317,32 +3755,8 @@
         </p:nvSpPr>
         <p:spPr>
           <a:xfrm>
-            <a:off x="5852160" y="2926080"/>
-            <a:ext cx="320040" cy="0"/>
-          </a:xfrm>
-          <a:prstGeom prst="line">
-            <a:avLst/>
-          </a:prstGeom>
-          <a:noFill/>
-          <a:ln w="15875">
-            <a:solidFill>
-              <a:srgbClr val="0972D3"/>
-            </a:solidFill>
-            <a:prstDash val="solid"/>
-            <a:headEnd type="triangle"/>
-          </a:ln>
-        </p:spPr>
-      </p:sp>
-      <p:sp>
-        <p:nvSpPr>
-          <p:cNvPr id="68" name="Shape 56"/>
-          <p:cNvSpPr/>
-          <p:nvPr/>
-        </p:nvSpPr>
-        <p:spPr>
-          <a:xfrm>
-            <a:off x="5532120" y="3429000"/>
-            <a:ext cx="640080" cy="0"/>
+            <a:off x="4846320" y="4206240"/>
+            <a:ext cx="1783080" cy="0"/>
           </a:xfrm>
           <a:prstGeom prst="line">
             <a:avLst/>
@@ -3353,20 +3767,20 @@
               <a:srgbClr val="D13212"/>
             </a:solidFill>
             <a:prstDash val="solid"/>
-            <a:tailEnd type="triangle"/>
+            <a:tailEnd type="arrow"/>
           </a:ln>
         </p:spPr>
       </p:sp>
       <p:sp>
         <p:nvSpPr>
-          <p:cNvPr id="69" name="Shape 57"/>
-          <p:cNvSpPr/>
-          <p:nvPr/>
-        </p:nvSpPr>
-        <p:spPr>
-          <a:xfrm>
-            <a:off x="7040880" y="3566160"/>
-            <a:ext cx="0" cy="502920"/>
+          <p:cNvPr id="68" name="Shape 56"/>
+          <p:cNvSpPr/>
+          <p:nvPr/>
+        </p:nvSpPr>
+        <p:spPr>
+          <a:xfrm>
+            <a:off x="7178040" y="4261104"/>
+            <a:ext cx="0" cy="813816"/>
           </a:xfrm>
           <a:prstGeom prst="line">
             <a:avLst/>
@@ -3377,20 +3791,20 @@
               <a:srgbClr val="7C3AED"/>
             </a:solidFill>
             <a:prstDash val="solid"/>
-            <a:tailEnd type="triangle"/>
+            <a:tailEnd type="arrow"/>
           </a:ln>
         </p:spPr>
       </p:sp>
       <p:sp>
         <p:nvSpPr>
-          <p:cNvPr id="70" name="Shape 58"/>
-          <p:cNvSpPr/>
-          <p:nvPr/>
-        </p:nvSpPr>
-        <p:spPr>
-          <a:xfrm>
-            <a:off x="7040880" y="4892040"/>
-            <a:ext cx="0" cy="137160"/>
+          <p:cNvPr id="69" name="Shape 57"/>
+          <p:cNvSpPr/>
+          <p:nvPr/>
+        </p:nvSpPr>
+        <p:spPr>
+          <a:xfrm>
+            <a:off x="5879592" y="5440680"/>
+            <a:ext cx="1298448" cy="0"/>
           </a:xfrm>
           <a:prstGeom prst="line">
             <a:avLst/>
@@ -3401,119 +3815,25 @@
               <a:srgbClr val="7C3AED"/>
             </a:solidFill>
             <a:prstDash val="solid"/>
-            <a:tailEnd type="triangle"/>
+            <a:headEnd type="arrow"/>
           </a:ln>
         </p:spPr>
       </p:sp>
       <p:sp>
         <p:nvSpPr>
-          <p:cNvPr id="71" name="Shape 59"/>
-          <p:cNvSpPr/>
-          <p:nvPr/>
-        </p:nvSpPr>
-        <p:spPr>
-          <a:xfrm>
-            <a:off x="5715000" y="2926080"/>
-            <a:ext cx="0" cy="2103120"/>
-          </a:xfrm>
-          <a:prstGeom prst="line">
+          <p:cNvPr id="70" name="Text 58"/>
+          <p:cNvSpPr/>
+          <p:nvPr/>
+        </p:nvSpPr>
+        <p:spPr>
+          <a:xfrm>
+            <a:off x="109728" y="6620256"/>
+            <a:ext cx="8595360" cy="182880"/>
+          </a:xfrm>
+          <a:prstGeom prst="rect">
             <a:avLst/>
           </a:prstGeom>
           <a:noFill/>
-          <a:ln w="15875">
-            <a:solidFill>
-              <a:srgbClr val="0972D3"/>
-            </a:solidFill>
-            <a:prstDash val="solid"/>
-            <a:headEnd type="triangle"/>
-          </a:ln>
-        </p:spPr>
-      </p:sp>
-      <p:sp>
-        <p:nvSpPr>
-          <p:cNvPr id="72" name="Shape 60"/>
-          <p:cNvSpPr/>
-          <p:nvPr/>
-        </p:nvSpPr>
-        <p:spPr>
-          <a:xfrm>
-            <a:off x="3063240" y="5029200"/>
-            <a:ext cx="502920" cy="0"/>
-          </a:xfrm>
-          <a:prstGeom prst="line">
-            <a:avLst/>
-          </a:prstGeom>
-          <a:noFill/>
-          <a:ln w="15875">
-            <a:solidFill>
-              <a:srgbClr val="0972D3"/>
-            </a:solidFill>
-            <a:prstDash val="solid"/>
-          </a:ln>
-        </p:spPr>
-      </p:sp>
-      <p:sp>
-        <p:nvSpPr>
-          <p:cNvPr id="73" name="Shape 61"/>
-          <p:cNvSpPr/>
-          <p:nvPr/>
-        </p:nvSpPr>
-        <p:spPr>
-          <a:xfrm>
-            <a:off x="3566160" y="1783080"/>
-            <a:ext cx="0" cy="3246120"/>
-          </a:xfrm>
-          <a:prstGeom prst="line">
-            <a:avLst/>
-          </a:prstGeom>
-          <a:noFill/>
-          <a:ln w="15875">
-            <a:solidFill>
-              <a:srgbClr val="0972D3"/>
-            </a:solidFill>
-            <a:prstDash val="solid"/>
-          </a:ln>
-        </p:spPr>
-      </p:sp>
-      <p:sp>
-        <p:nvSpPr>
-          <p:cNvPr id="74" name="Shape 62"/>
-          <p:cNvSpPr/>
-          <p:nvPr/>
-        </p:nvSpPr>
-        <p:spPr>
-          <a:xfrm>
-            <a:off x="3566160" y="1783080"/>
-            <a:ext cx="137160" cy="0"/>
-          </a:xfrm>
-          <a:prstGeom prst="line">
-            <a:avLst/>
-          </a:prstGeom>
-          <a:noFill/>
-          <a:ln w="15875">
-            <a:solidFill>
-              <a:srgbClr val="0972D3"/>
-            </a:solidFill>
-            <a:prstDash val="solid"/>
-            <a:tailEnd type="triangle"/>
-          </a:ln>
-        </p:spPr>
-      </p:sp>
-      <p:sp>
-        <p:nvSpPr>
-          <p:cNvPr id="75" name="Text 63"/>
-          <p:cNvSpPr/>
-          <p:nvPr/>
-        </p:nvSpPr>
-        <p:spPr>
-          <a:xfrm>
-            <a:off x="274320" y="6583680"/>
-            <a:ext cx="7680960" cy="182880"/>
-          </a:xfrm>
-          <a:prstGeom prst="rect">
-            <a:avLst/>
-          </a:prstGeom>
-          <a:noFill/>
           <a:ln/>
         </p:spPr>
         <p:txBody>
@@ -3524,9 +3844,9 @@
               <a:buNone/>
             </a:pPr>
             <a:r>
-              <a:rPr lang="en-US" sz="650" dirty="0">
-                <a:solidFill>
-                  <a:srgbClr val="666666"/>
+              <a:rPr lang="en-US" sz="700" dirty="0">
+                <a:solidFill>
+                  <a:srgbClr val="545B64"/>
                 </a:solidFill>
                 <a:latin typeface="Arial" pitchFamily="34" charset="0"/>
                 <a:ea typeface="Arial" pitchFamily="34" charset="-122"/>
@@ -3534,7 +3854,7 @@
               </a:rPr>
               <a:t>© 2026, Amazon Web Services, Inc. or its affiliates. All rights reserved.</a:t>
             </a:r>
-            <a:endParaRPr lang="en-US" sz="650" dirty="0"/>
+            <a:endParaRPr lang="en-US" sz="700" dirty="0"/>
           </a:p>
         </p:txBody>
       </p:sp>

</xml_diff>

<commit_message>
Update architecture diagram icons to latest AWS Icon pack (July 2026)
</commit_message>
<xml_diff>
--- a/docs/diagrams/5g-rcf-architecture-guidance.pptx
+++ b/docs/diagrams/5g-rcf-architecture-guidance.pptx
@@ -2092,30 +2092,6 @@
           </a:ln>
         </p:spPr>
       </p:sp>
-      <p:pic>
-        <p:nvPicPr>
-          <p:cNvPr id="27" name="Image 0" descr="/Users/mdsherif/Library/CloudStorage/WorkDocsDrive-Documents/MyMac/06Tools/24-ai-devops-amp/docs/diagrams/icons/AmazonElasticKubernetesService.png">    </p:cNvPr>
-          <p:cNvPicPr>
-            <a:picLocks noChangeAspect="1"/>
-          </p:cNvPicPr>
-          <p:nvPr/>
-        </p:nvPicPr>
-        <p:blipFill>
-          <a:blip r:embed="rId1"/>
-          <a:stretch>
-            <a:fillRect/>
-          </a:stretch>
-        </p:blipFill>
-        <p:spPr>
-          <a:xfrm>
-            <a:off x="521208" y="2029968"/>
-            <a:ext cx="292608" cy="292608"/>
-          </a:xfrm>
-          <a:prstGeom prst="rect">
-            <a:avLst/>
-          </a:prstGeom>
-        </p:spPr>
-      </p:pic>
       <p:sp>
         <p:nvSpPr>
           <p:cNvPr id="28" name="Text 25"/>
@@ -2365,30 +2341,6 @@
           </a:p>
         </p:txBody>
       </p:sp>
-      <p:pic>
-        <p:nvPicPr>
-          <p:cNvPr id="33" name="Image 1" descr="/Users/mdsherif/Library/CloudStorage/WorkDocsDrive-Documents/MyMac/06Tools/24-ai-devops-amp/docs/diagrams/icons/AmazonManagedServiceforPrometheus.png">    </p:cNvPr>
-          <p:cNvPicPr>
-            <a:picLocks noChangeAspect="1"/>
-          </p:cNvPicPr>
-          <p:nvPr/>
-        </p:nvPicPr>
-        <p:blipFill>
-          <a:blip r:embed="rId2"/>
-          <a:stretch>
-            <a:fillRect/>
-          </a:stretch>
-        </p:blipFill>
-        <p:spPr>
-          <a:xfrm>
-            <a:off x="4023360" y="2103120"/>
-            <a:ext cx="548640" cy="548640"/>
-          </a:xfrm>
-          <a:prstGeom prst="rect">
-            <a:avLst/>
-          </a:prstGeom>
-        </p:spPr>
-      </p:pic>
       <p:sp>
         <p:nvSpPr>
           <p:cNvPr id="34" name="Text 30"/>
@@ -2592,30 +2544,6 @@
           </a:p>
         </p:txBody>
       </p:sp>
-      <p:pic>
-        <p:nvPicPr>
-          <p:cNvPr id="38" name="Image 2" descr="/Users/mdsherif/Library/CloudStorage/WorkDocsDrive-Documents/MyMac/06Tools/24-ai-devops-amp/docs/diagrams/icons/AmazonSimpleNotificationService.png">    </p:cNvPr>
-          <p:cNvPicPr>
-            <a:picLocks noChangeAspect="1"/>
-          </p:cNvPicPr>
-          <p:nvPr/>
-        </p:nvPicPr>
-        <p:blipFill>
-          <a:blip r:embed="rId3"/>
-          <a:stretch>
-            <a:fillRect/>
-          </a:stretch>
-        </p:blipFill>
-        <p:spPr>
-          <a:xfrm>
-            <a:off x="6903720" y="2103120"/>
-            <a:ext cx="548640" cy="548640"/>
-          </a:xfrm>
-          <a:prstGeom prst="rect">
-            <a:avLst/>
-          </a:prstGeom>
-        </p:spPr>
-      </p:pic>
       <p:sp>
         <p:nvSpPr>
           <p:cNvPr id="39" name="Text 34"/>
@@ -2716,30 +2644,6 @@
           </a:p>
         </p:txBody>
       </p:sp>
-      <p:pic>
-        <p:nvPicPr>
-          <p:cNvPr id="41" name="Image 3" descr="/Users/mdsherif/Library/CloudStorage/WorkDocsDrive-Documents/MyMac/06Tools/24-ai-devops-amp/docs/diagrams/icons/AWSLambda.png">    </p:cNvPr>
-          <p:cNvPicPr>
-            <a:picLocks noChangeAspect="1"/>
-          </p:cNvPicPr>
-          <p:nvPr/>
-        </p:nvPicPr>
-        <p:blipFill>
-          <a:blip r:embed="rId4"/>
-          <a:stretch>
-            <a:fillRect/>
-          </a:stretch>
-        </p:blipFill>
-        <p:spPr>
-          <a:xfrm>
-            <a:off x="6903720" y="3657600"/>
-            <a:ext cx="548640" cy="548640"/>
-          </a:xfrm>
-          <a:prstGeom prst="rect">
-            <a:avLst/>
-          </a:prstGeom>
-        </p:spPr>
-      </p:pic>
       <p:sp>
         <p:nvSpPr>
           <p:cNvPr id="42" name="Text 36"/>
@@ -2840,30 +2744,6 @@
           </a:p>
         </p:txBody>
       </p:sp>
-      <p:pic>
-        <p:nvPicPr>
-          <p:cNvPr id="44" name="Image 4" descr="/Users/mdsherif/Library/CloudStorage/WorkDocsDrive-Documents/MyMac/06Tools/24-ai-devops-amp/docs/diagrams/icons/AWSSecretsManager.png">    </p:cNvPr>
-          <p:cNvPicPr>
-            <a:picLocks noChangeAspect="1"/>
-          </p:cNvPicPr>
-          <p:nvPr/>
-        </p:nvPicPr>
-        <p:blipFill>
-          <a:blip r:embed="rId5"/>
-          <a:stretch>
-            <a:fillRect/>
-          </a:stretch>
-        </p:blipFill>
-        <p:spPr>
-          <a:xfrm>
-            <a:off x="5486400" y="3931920"/>
-            <a:ext cx="548640" cy="548640"/>
-          </a:xfrm>
-          <a:prstGeom prst="rect">
-            <a:avLst/>
-          </a:prstGeom>
-        </p:spPr>
-      </p:pic>
       <p:sp>
         <p:nvSpPr>
           <p:cNvPr id="45" name="Text 38"/>
@@ -2964,30 +2844,6 @@
           </a:p>
         </p:txBody>
       </p:sp>
-      <p:pic>
-        <p:nvPicPr>
-          <p:cNvPr id="47" name="Image 5" descr="/Users/mdsherif/Library/CloudStorage/WorkDocsDrive-Documents/MyMac/06Tools/24-ai-devops-amp/docs/diagrams/icons/AWSDevOpsAgent.png">    </p:cNvPr>
-          <p:cNvPicPr>
-            <a:picLocks noChangeAspect="1"/>
-          </p:cNvPicPr>
-          <p:nvPr/>
-        </p:nvPicPr>
-        <p:blipFill>
-          <a:blip r:embed="rId6"/>
-          <a:stretch>
-            <a:fillRect/>
-          </a:stretch>
-        </p:blipFill>
-        <p:spPr>
-          <a:xfrm>
-            <a:off x="6903720" y="5074920"/>
-            <a:ext cx="548640" cy="548640"/>
-          </a:xfrm>
-          <a:prstGeom prst="rect">
-            <a:avLst/>
-          </a:prstGeom>
-        </p:spPr>
-      </p:pic>
       <p:sp>
         <p:nvSpPr>
           <p:cNvPr id="48" name="Text 40"/>
@@ -3088,30 +2944,6 @@
           </a:p>
         </p:txBody>
       </p:sp>
-      <p:pic>
-        <p:nvPicPr>
-          <p:cNvPr id="50" name="Image 6" descr="/Users/mdsherif/Library/CloudStorage/WorkDocsDrive-Documents/MyMac/06Tools/24-ai-devops-amp/docs/diagrams/icons/AmazonSageMaker.png">    </p:cNvPr>
-          <p:cNvPicPr>
-            <a:picLocks noChangeAspect="1"/>
-          </p:cNvPicPr>
-          <p:nvPr/>
-        </p:nvPicPr>
-        <p:blipFill>
-          <a:blip r:embed="rId7"/>
-          <a:stretch>
-            <a:fillRect/>
-          </a:stretch>
-        </p:blipFill>
-        <p:spPr>
-          <a:xfrm>
-            <a:off x="1143000" y="5074920"/>
-            <a:ext cx="548640" cy="548640"/>
-          </a:xfrm>
-          <a:prstGeom prst="rect">
-            <a:avLst/>
-          </a:prstGeom>
-        </p:spPr>
-      </p:pic>
       <p:sp>
         <p:nvSpPr>
           <p:cNvPr id="51" name="Text 42"/>
@@ -3278,30 +3110,6 @@
           </a:p>
         </p:txBody>
       </p:sp>
-      <p:pic>
-        <p:nvPicPr>
-          <p:cNvPr id="55" name="Image 7" descr="/Users/mdsherif/Library/CloudStorage/WorkDocsDrive-Documents/MyMac/06Tools/24-ai-devops-amp/docs/diagrams/icons/AmazonCognito.png">    </p:cNvPr>
-          <p:cNvPicPr>
-            <a:picLocks noChangeAspect="1"/>
-          </p:cNvPicPr>
-          <p:nvPr/>
-        </p:nvPicPr>
-        <p:blipFill>
-          <a:blip r:embed="rId8"/>
-          <a:stretch>
-            <a:fillRect/>
-          </a:stretch>
-        </p:blipFill>
-        <p:spPr>
-          <a:xfrm>
-            <a:off x="3611880" y="5138928"/>
-            <a:ext cx="548640" cy="548640"/>
-          </a:xfrm>
-          <a:prstGeom prst="rect">
-            <a:avLst/>
-          </a:prstGeom>
-        </p:spPr>
-      </p:pic>
       <p:sp>
         <p:nvSpPr>
           <p:cNvPr id="56" name="Text 46"/>
@@ -3361,30 +3169,6 @@
           </a:p>
         </p:txBody>
       </p:sp>
-      <p:pic>
-        <p:nvPicPr>
-          <p:cNvPr id="57" name="Image 8" descr="/Users/mdsherif/Library/CloudStorage/WorkDocsDrive-Documents/MyMac/06Tools/24-ai-devops-amp/docs/diagrams/icons/AmazonAPIGateway.png">    </p:cNvPr>
-          <p:cNvPicPr>
-            <a:picLocks noChangeAspect="1"/>
-          </p:cNvPicPr>
-          <p:nvPr/>
-        </p:nvPicPr>
-        <p:blipFill>
-          <a:blip r:embed="rId9"/>
-          <a:stretch>
-            <a:fillRect/>
-          </a:stretch>
-        </p:blipFill>
-        <p:spPr>
-          <a:xfrm>
-            <a:off x="4617720" y="5138928"/>
-            <a:ext cx="548640" cy="548640"/>
-          </a:xfrm>
-          <a:prstGeom prst="rect">
-            <a:avLst/>
-          </a:prstGeom>
-        </p:spPr>
-      </p:pic>
       <p:sp>
         <p:nvSpPr>
           <p:cNvPr id="58" name="Text 47"/>
@@ -3444,30 +3228,6 @@
           </a:p>
         </p:txBody>
       </p:sp>
-      <p:pic>
-        <p:nvPicPr>
-          <p:cNvPr id="59" name="Image 9" descr="/Users/mdsherif/Library/CloudStorage/WorkDocsDrive-Documents/MyMac/06Tools/24-ai-devops-amp/docs/diagrams/icons/AWSLambda.png">    </p:cNvPr>
-          <p:cNvPicPr>
-            <a:picLocks noChangeAspect="1"/>
-          </p:cNvPicPr>
-          <p:nvPr/>
-        </p:nvPicPr>
-        <p:blipFill>
-          <a:blip r:embed="rId10"/>
-          <a:stretch>
-            <a:fillRect/>
-          </a:stretch>
-        </p:blipFill>
-        <p:spPr>
-          <a:xfrm>
-            <a:off x="5669280" y="5138928"/>
-            <a:ext cx="548640" cy="548640"/>
-          </a:xfrm>
-          <a:prstGeom prst="rect">
-            <a:avLst/>
-          </a:prstGeom>
-        </p:spPr>
-      </p:pic>
       <p:sp>
         <p:nvSpPr>
           <p:cNvPr id="60" name="Text 48"/>
@@ -3745,6 +3505,246 @@
           </a:fontRef>
         </p:style>
       </p:cxnSp>
+      <p:pic>
+        <p:nvPicPr>
+          <p:cNvPr id="69" name="Picture 68" descr="Arch_Amazon-Elastic-Kubernetes-Service_48.png"/>
+          <p:cNvPicPr>
+            <a:picLocks noChangeAspect="1"/>
+          </p:cNvPicPr>
+          <p:nvPr/>
+        </p:nvPicPr>
+        <p:blipFill>
+          <a:blip r:embed="rId13"/>
+          <a:stretch>
+            <a:fillRect/>
+          </a:stretch>
+        </p:blipFill>
+        <p:spPr>
+          <a:xfrm>
+            <a:off x="521208" y="2029968"/>
+            <a:ext cx="292608" cy="292608"/>
+          </a:xfrm>
+          <a:prstGeom prst="rect">
+            <a:avLst/>
+          </a:prstGeom>
+        </p:spPr>
+      </p:pic>
+      <p:pic>
+        <p:nvPicPr>
+          <p:cNvPr id="70" name="Picture 69" descr="Arch_Amazon-Managed-Service-for-Prometheus_48.png"/>
+          <p:cNvPicPr>
+            <a:picLocks noChangeAspect="1"/>
+          </p:cNvPicPr>
+          <p:nvPr/>
+        </p:nvPicPr>
+        <p:blipFill>
+          <a:blip r:embed="rId14"/>
+          <a:stretch>
+            <a:fillRect/>
+          </a:stretch>
+        </p:blipFill>
+        <p:spPr>
+          <a:xfrm>
+            <a:off x="4023360" y="2103120"/>
+            <a:ext cx="548640" cy="548640"/>
+          </a:xfrm>
+          <a:prstGeom prst="rect">
+            <a:avLst/>
+          </a:prstGeom>
+        </p:spPr>
+      </p:pic>
+      <p:pic>
+        <p:nvPicPr>
+          <p:cNvPr id="71" name="Picture 70" descr="Arch_Amazon-Simple-Notification-Service_48.png"/>
+          <p:cNvPicPr>
+            <a:picLocks noChangeAspect="1"/>
+          </p:cNvPicPr>
+          <p:nvPr/>
+        </p:nvPicPr>
+        <p:blipFill>
+          <a:blip r:embed="rId15"/>
+          <a:stretch>
+            <a:fillRect/>
+          </a:stretch>
+        </p:blipFill>
+        <p:spPr>
+          <a:xfrm>
+            <a:off x="6903720" y="2103120"/>
+            <a:ext cx="548640" cy="548640"/>
+          </a:xfrm>
+          <a:prstGeom prst="rect">
+            <a:avLst/>
+          </a:prstGeom>
+        </p:spPr>
+      </p:pic>
+      <p:pic>
+        <p:nvPicPr>
+          <p:cNvPr id="72" name="Picture 71" descr="Arch_AWS-Lambda_48.png"/>
+          <p:cNvPicPr>
+            <a:picLocks noChangeAspect="1"/>
+          </p:cNvPicPr>
+          <p:nvPr/>
+        </p:nvPicPr>
+        <p:blipFill>
+          <a:blip r:embed="rId16"/>
+          <a:stretch>
+            <a:fillRect/>
+          </a:stretch>
+        </p:blipFill>
+        <p:spPr>
+          <a:xfrm>
+            <a:off x="6903720" y="3657600"/>
+            <a:ext cx="548640" cy="548640"/>
+          </a:xfrm>
+          <a:prstGeom prst="rect">
+            <a:avLst/>
+          </a:prstGeom>
+        </p:spPr>
+      </p:pic>
+      <p:pic>
+        <p:nvPicPr>
+          <p:cNvPr id="73" name="Picture 72" descr="Arch_AWS-Secrets-Manager_48.png"/>
+          <p:cNvPicPr>
+            <a:picLocks noChangeAspect="1"/>
+          </p:cNvPicPr>
+          <p:nvPr/>
+        </p:nvPicPr>
+        <p:blipFill>
+          <a:blip r:embed="rId17"/>
+          <a:stretch>
+            <a:fillRect/>
+          </a:stretch>
+        </p:blipFill>
+        <p:spPr>
+          <a:xfrm>
+            <a:off x="5486400" y="3931920"/>
+            <a:ext cx="548640" cy="548640"/>
+          </a:xfrm>
+          <a:prstGeom prst="rect">
+            <a:avLst/>
+          </a:prstGeom>
+        </p:spPr>
+      </p:pic>
+      <p:pic>
+        <p:nvPicPr>
+          <p:cNvPr id="74" name="Picture 73" descr="Arch_AWS-DevOps-Agent_48.png"/>
+          <p:cNvPicPr>
+            <a:picLocks noChangeAspect="1"/>
+          </p:cNvPicPr>
+          <p:nvPr/>
+        </p:nvPicPr>
+        <p:blipFill>
+          <a:blip r:embed="rId18"/>
+          <a:stretch>
+            <a:fillRect/>
+          </a:stretch>
+        </p:blipFill>
+        <p:spPr>
+          <a:xfrm>
+            <a:off x="6903720" y="5074920"/>
+            <a:ext cx="548640" cy="548640"/>
+          </a:xfrm>
+          <a:prstGeom prst="rect">
+            <a:avLst/>
+          </a:prstGeom>
+        </p:spPr>
+      </p:pic>
+      <p:pic>
+        <p:nvPicPr>
+          <p:cNvPr id="75" name="Picture 74" descr="Arch_Amazon-SageMaker-AI_48.png"/>
+          <p:cNvPicPr>
+            <a:picLocks noChangeAspect="1"/>
+          </p:cNvPicPr>
+          <p:nvPr/>
+        </p:nvPicPr>
+        <p:blipFill>
+          <a:blip r:embed="rId19"/>
+          <a:stretch>
+            <a:fillRect/>
+          </a:stretch>
+        </p:blipFill>
+        <p:spPr>
+          <a:xfrm>
+            <a:off x="1143000" y="5074920"/>
+            <a:ext cx="548640" cy="548640"/>
+          </a:xfrm>
+          <a:prstGeom prst="rect">
+            <a:avLst/>
+          </a:prstGeom>
+        </p:spPr>
+      </p:pic>
+      <p:pic>
+        <p:nvPicPr>
+          <p:cNvPr id="76" name="Picture 75" descr="Arch_Amazon-Cognito_48.png"/>
+          <p:cNvPicPr>
+            <a:picLocks noChangeAspect="1"/>
+          </p:cNvPicPr>
+          <p:nvPr/>
+        </p:nvPicPr>
+        <p:blipFill>
+          <a:blip r:embed="rId20"/>
+          <a:stretch>
+            <a:fillRect/>
+          </a:stretch>
+        </p:blipFill>
+        <p:spPr>
+          <a:xfrm>
+            <a:off x="3611880" y="5138928"/>
+            <a:ext cx="548640" cy="548640"/>
+          </a:xfrm>
+          <a:prstGeom prst="rect">
+            <a:avLst/>
+          </a:prstGeom>
+        </p:spPr>
+      </p:pic>
+      <p:pic>
+        <p:nvPicPr>
+          <p:cNvPr id="77" name="Picture 76" descr="Arch_Amazon-API-Gateway_48.png"/>
+          <p:cNvPicPr>
+            <a:picLocks noChangeAspect="1"/>
+          </p:cNvPicPr>
+          <p:nvPr/>
+        </p:nvPicPr>
+        <p:blipFill>
+          <a:blip r:embed="rId21"/>
+          <a:stretch>
+            <a:fillRect/>
+          </a:stretch>
+        </p:blipFill>
+        <p:spPr>
+          <a:xfrm>
+            <a:off x="4617720" y="5138928"/>
+            <a:ext cx="548640" cy="548640"/>
+          </a:xfrm>
+          <a:prstGeom prst="rect">
+            <a:avLst/>
+          </a:prstGeom>
+        </p:spPr>
+      </p:pic>
+      <p:pic>
+        <p:nvPicPr>
+          <p:cNvPr id="78" name="Picture 77" descr="Arch_AWS-Lambda_48.png"/>
+          <p:cNvPicPr>
+            <a:picLocks noChangeAspect="1"/>
+          </p:cNvPicPr>
+          <p:nvPr/>
+        </p:nvPicPr>
+        <p:blipFill>
+          <a:blip r:embed="rId16"/>
+          <a:stretch>
+            <a:fillRect/>
+          </a:stretch>
+        </p:blipFill>
+        <p:spPr>
+          <a:xfrm>
+            <a:off x="5669280" y="5138928"/>
+            <a:ext cx="548640" cy="548640"/>
+          </a:xfrm>
+          <a:prstGeom prst="rect">
+            <a:avLst/>
+          </a:prstGeom>
+        </p:spPr>
+      </p:pic>
     </p:spTree>
   </p:cSld>
   <p:clrMapOvr>

</xml_diff>